<commit_message>
Switch Q2 revenue analysis from day-ahead to real-time prices
Recomputes standalone solar, standalone storage, and combined
solar+storage revenue using NYISO NYC real-time prices instead of
day-ahead, and propagates the resulting numbers through Q3 payback
and the recommendation slides for consistency.

Co-Authored-By: Claude Sonnet 5 <noreply@anthropic.com>
Claude-Session: https://claude.ai/code/session_01Wd98BoYaSaTQ6bNKBze8DQ
</commit_message>
<xml_diff>
--- a/GCV_Solar_Storage_Valuation.pptx
+++ b/GCV_Solar_Storage_Valuation.pptx
@@ -5,18 +5,18 @@
     <p:sldMasterId id="2147483648" r:id="rId1"/>
   </p:sldMasterIdLst>
   <p:sldIdLst>
-    <p:sldId id="256" r:id="rId2"/>
-    <p:sldId id="257" r:id="rId3"/>
-    <p:sldId id="258" r:id="rId4"/>
-    <p:sldId id="259" r:id="rId5"/>
-    <p:sldId id="260" r:id="rId6"/>
-    <p:sldId id="261" r:id="rId7"/>
-    <p:sldId id="262" r:id="rId8"/>
-    <p:sldId id="263" r:id="rId9"/>
-    <p:sldId id="264" r:id="rId10"/>
-    <p:sldId id="265" r:id="rId11"/>
+    <p:sldId id="256" r:id="rId7"/>
+    <p:sldId id="257" r:id="rId8"/>
+    <p:sldId id="258" r:id="rId9"/>
+    <p:sldId id="259" r:id="rId10"/>
+    <p:sldId id="260" r:id="rId11"/>
+    <p:sldId id="261" r:id="rId12"/>
+    <p:sldId id="262" r:id="rId13"/>
+    <p:sldId id="263" r:id="rId14"/>
+    <p:sldId id="264" r:id="rId15"/>
+    <p:sldId id="265" r:id="rId16"/>
   </p:sldIdLst>
-  <p:sldSz cx="12192000" cy="6858000"/>
+  <p:sldSz cx="12191695" cy="6858000" type="screen4x3"/>
   <p:notesSz cx="6858000" cy="9144000"/>
   <p:defaultTextStyle>
     <a:defPPr>
@@ -113,22 +113,6 @@
       </a:defRPr>
     </a:lvl9pPr>
   </p:defaultTextStyle>
-  <p:extLst>
-    <p:ext uri="{EFAFB233-063F-42B5-8137-9DF3F51BA10A}">
-      <p15:sldGuideLst xmlns:p15="http://schemas.microsoft.com/office/powerpoint/2012/main">
-        <p15:guide id="1" orient="horz" pos="2160">
-          <p15:clr>
-            <a:srgbClr val="A4A3A4"/>
-          </p15:clr>
-        </p15:guide>
-        <p15:guide id="2" pos="2880">
-          <p15:clr>
-            <a:srgbClr val="A4A3A4"/>
-          </p15:clr>
-        </p15:guide>
-      </p15:sldGuideLst>
-    </p:ext>
-  </p:extLst>
 </p:presentation>
 </file>
 
@@ -170,9 +154,10 @@
           <a:lstStyle/>
           <a:p>
             <a:r>
-              <a:rPr lang="en-US"/>
+              <a:rPr lang="en-US" smtClean="0"/>
               <a:t>Click to edit Master title style</a:t>
             </a:r>
+            <a:endParaRPr lang="en-US"/>
           </a:p>
         </p:txBody>
       </p:sp>
@@ -288,9 +273,10 @@
           </a:lstStyle>
           <a:p>
             <a:r>
-              <a:rPr lang="en-US"/>
+              <a:rPr lang="en-US" smtClean="0"/>
               <a:t>Click to edit Master subtitle style</a:t>
             </a:r>
+            <a:endParaRPr lang="en-US"/>
           </a:p>
         </p:txBody>
       </p:sp>
@@ -311,7 +297,7 @@
           <a:p>
             <a:fld id="{5BCAD085-E8A6-8845-BD4E-CB4CCA059FC4}" type="datetimeFigureOut">
               <a:rPr lang="en-US" smtClean="0"/>
-              <a:t>9/14/26</a:t>
+              <a:t>1/27/13</a:t>
             </a:fld>
             <a:endParaRPr lang="en-US"/>
           </a:p>
@@ -405,9 +391,10 @@
           <a:lstStyle/>
           <a:p>
             <a:r>
-              <a:rPr lang="en-US"/>
+              <a:rPr lang="en-US" smtClean="0"/>
               <a:t>Click to edit Master title style</a:t>
             </a:r>
+            <a:endParaRPr lang="en-US"/>
           </a:p>
         </p:txBody>
       </p:sp>
@@ -428,37 +415,38 @@
           <a:p>
             <a:pPr lvl="0"/>
             <a:r>
-              <a:rPr lang="en-US"/>
+              <a:rPr lang="en-US" smtClean="0"/>
               <a:t>Click to edit Master text styles</a:t>
             </a:r>
           </a:p>
           <a:p>
             <a:pPr lvl="1"/>
             <a:r>
-              <a:rPr lang="en-US"/>
+              <a:rPr lang="en-US" smtClean="0"/>
               <a:t>Second level</a:t>
             </a:r>
           </a:p>
           <a:p>
             <a:pPr lvl="2"/>
             <a:r>
-              <a:rPr lang="en-US"/>
+              <a:rPr lang="en-US" smtClean="0"/>
               <a:t>Third level</a:t>
             </a:r>
           </a:p>
           <a:p>
             <a:pPr lvl="3"/>
             <a:r>
-              <a:rPr lang="en-US"/>
+              <a:rPr lang="en-US" smtClean="0"/>
               <a:t>Fourth level</a:t>
             </a:r>
           </a:p>
           <a:p>
             <a:pPr lvl="4"/>
             <a:r>
-              <a:rPr lang="en-US"/>
+              <a:rPr lang="en-US" smtClean="0"/>
               <a:t>Fifth level</a:t>
             </a:r>
+            <a:endParaRPr lang="en-US"/>
           </a:p>
         </p:txBody>
       </p:sp>
@@ -479,7 +467,7 @@
           <a:p>
             <a:fld id="{5BCAD085-E8A6-8845-BD4E-CB4CCA059FC4}" type="datetimeFigureOut">
               <a:rPr lang="en-US" smtClean="0"/>
-              <a:t>9/14/26</a:t>
+              <a:t>1/27/13</a:t>
             </a:fld>
             <a:endParaRPr lang="en-US"/>
           </a:p>
@@ -578,9 +566,10 @@
           <a:lstStyle/>
           <a:p>
             <a:r>
-              <a:rPr lang="en-US"/>
+              <a:rPr lang="en-US" smtClean="0"/>
               <a:t>Click to edit Master title style</a:t>
             </a:r>
+            <a:endParaRPr lang="en-US"/>
           </a:p>
         </p:txBody>
       </p:sp>
@@ -606,37 +595,38 @@
           <a:p>
             <a:pPr lvl="0"/>
             <a:r>
-              <a:rPr lang="en-US"/>
+              <a:rPr lang="en-US" smtClean="0"/>
               <a:t>Click to edit Master text styles</a:t>
             </a:r>
           </a:p>
           <a:p>
             <a:pPr lvl="1"/>
             <a:r>
-              <a:rPr lang="en-US"/>
+              <a:rPr lang="en-US" smtClean="0"/>
               <a:t>Second level</a:t>
             </a:r>
           </a:p>
           <a:p>
             <a:pPr lvl="2"/>
             <a:r>
-              <a:rPr lang="en-US"/>
+              <a:rPr lang="en-US" smtClean="0"/>
               <a:t>Third level</a:t>
             </a:r>
           </a:p>
           <a:p>
             <a:pPr lvl="3"/>
             <a:r>
-              <a:rPr lang="en-US"/>
+              <a:rPr lang="en-US" smtClean="0"/>
               <a:t>Fourth level</a:t>
             </a:r>
           </a:p>
           <a:p>
             <a:pPr lvl="4"/>
             <a:r>
-              <a:rPr lang="en-US"/>
+              <a:rPr lang="en-US" smtClean="0"/>
               <a:t>Fifth level</a:t>
             </a:r>
+            <a:endParaRPr lang="en-US"/>
           </a:p>
         </p:txBody>
       </p:sp>
@@ -657,7 +647,7 @@
           <a:p>
             <a:fld id="{5BCAD085-E8A6-8845-BD4E-CB4CCA059FC4}" type="datetimeFigureOut">
               <a:rPr lang="en-US" smtClean="0"/>
-              <a:t>9/14/26</a:t>
+              <a:t>1/27/13</a:t>
             </a:fld>
             <a:endParaRPr lang="en-US"/>
           </a:p>
@@ -751,9 +741,10 @@
           <a:lstStyle/>
           <a:p>
             <a:r>
-              <a:rPr lang="en-US"/>
+              <a:rPr lang="en-US" smtClean="0"/>
               <a:t>Click to edit Master title style</a:t>
             </a:r>
+            <a:endParaRPr lang="en-US"/>
           </a:p>
         </p:txBody>
       </p:sp>
@@ -774,37 +765,38 @@
           <a:p>
             <a:pPr lvl="0"/>
             <a:r>
-              <a:rPr lang="en-US"/>
+              <a:rPr lang="en-US" smtClean="0"/>
               <a:t>Click to edit Master text styles</a:t>
             </a:r>
           </a:p>
           <a:p>
             <a:pPr lvl="1"/>
             <a:r>
-              <a:rPr lang="en-US"/>
+              <a:rPr lang="en-US" smtClean="0"/>
               <a:t>Second level</a:t>
             </a:r>
           </a:p>
           <a:p>
             <a:pPr lvl="2"/>
             <a:r>
-              <a:rPr lang="en-US"/>
+              <a:rPr lang="en-US" smtClean="0"/>
               <a:t>Third level</a:t>
             </a:r>
           </a:p>
           <a:p>
             <a:pPr lvl="3"/>
             <a:r>
-              <a:rPr lang="en-US"/>
+              <a:rPr lang="en-US" smtClean="0"/>
               <a:t>Fourth level</a:t>
             </a:r>
           </a:p>
           <a:p>
             <a:pPr lvl="4"/>
             <a:r>
-              <a:rPr lang="en-US"/>
+              <a:rPr lang="en-US" smtClean="0"/>
               <a:t>Fifth level</a:t>
             </a:r>
+            <a:endParaRPr lang="en-US"/>
           </a:p>
         </p:txBody>
       </p:sp>
@@ -825,7 +817,7 @@
           <a:p>
             <a:fld id="{5BCAD085-E8A6-8845-BD4E-CB4CCA059FC4}" type="datetimeFigureOut">
               <a:rPr lang="en-US" smtClean="0"/>
-              <a:t>9/14/26</a:t>
+              <a:t>1/27/13</a:t>
             </a:fld>
             <a:endParaRPr lang="en-US"/>
           </a:p>
@@ -928,9 +920,10 @@
           </a:lstStyle>
           <a:p>
             <a:r>
-              <a:rPr lang="en-US"/>
+              <a:rPr lang="en-US" smtClean="0"/>
               <a:t>Click to edit Master title style</a:t>
             </a:r>
+            <a:endParaRPr lang="en-US"/>
           </a:p>
         </p:txBody>
       </p:sp>
@@ -1047,7 +1040,7 @@
           <a:p>
             <a:pPr lvl="0"/>
             <a:r>
-              <a:rPr lang="en-US"/>
+              <a:rPr lang="en-US" smtClean="0"/>
               <a:t>Click to edit Master text styles</a:t>
             </a:r>
           </a:p>
@@ -1070,7 +1063,7 @@
           <a:p>
             <a:fld id="{5BCAD085-E8A6-8845-BD4E-CB4CCA059FC4}" type="datetimeFigureOut">
               <a:rPr lang="en-US" smtClean="0"/>
-              <a:t>9/14/26</a:t>
+              <a:t>1/27/13</a:t>
             </a:fld>
             <a:endParaRPr lang="en-US"/>
           </a:p>
@@ -1164,9 +1157,10 @@
           <a:lstStyle/>
           <a:p>
             <a:r>
-              <a:rPr lang="en-US"/>
+              <a:rPr lang="en-US" smtClean="0"/>
               <a:t>Click to edit Master title style</a:t>
             </a:r>
+            <a:endParaRPr lang="en-US"/>
           </a:p>
         </p:txBody>
       </p:sp>
@@ -1220,37 +1214,38 @@
           <a:p>
             <a:pPr lvl="0"/>
             <a:r>
-              <a:rPr lang="en-US"/>
+              <a:rPr lang="en-US" smtClean="0"/>
               <a:t>Click to edit Master text styles</a:t>
             </a:r>
           </a:p>
           <a:p>
             <a:pPr lvl="1"/>
             <a:r>
-              <a:rPr lang="en-US"/>
+              <a:rPr lang="en-US" smtClean="0"/>
               <a:t>Second level</a:t>
             </a:r>
           </a:p>
           <a:p>
             <a:pPr lvl="2"/>
             <a:r>
-              <a:rPr lang="en-US"/>
+              <a:rPr lang="en-US" smtClean="0"/>
               <a:t>Third level</a:t>
             </a:r>
           </a:p>
           <a:p>
             <a:pPr lvl="3"/>
             <a:r>
-              <a:rPr lang="en-US"/>
+              <a:rPr lang="en-US" smtClean="0"/>
               <a:t>Fourth level</a:t>
             </a:r>
           </a:p>
           <a:p>
             <a:pPr lvl="4"/>
             <a:r>
-              <a:rPr lang="en-US"/>
+              <a:rPr lang="en-US" smtClean="0"/>
               <a:t>Fifth level</a:t>
             </a:r>
+            <a:endParaRPr lang="en-US"/>
           </a:p>
         </p:txBody>
       </p:sp>
@@ -1304,37 +1299,38 @@
           <a:p>
             <a:pPr lvl="0"/>
             <a:r>
-              <a:rPr lang="en-US"/>
+              <a:rPr lang="en-US" smtClean="0"/>
               <a:t>Click to edit Master text styles</a:t>
             </a:r>
           </a:p>
           <a:p>
             <a:pPr lvl="1"/>
             <a:r>
-              <a:rPr lang="en-US"/>
+              <a:rPr lang="en-US" smtClean="0"/>
               <a:t>Second level</a:t>
             </a:r>
           </a:p>
           <a:p>
             <a:pPr lvl="2"/>
             <a:r>
-              <a:rPr lang="en-US"/>
+              <a:rPr lang="en-US" smtClean="0"/>
               <a:t>Third level</a:t>
             </a:r>
           </a:p>
           <a:p>
             <a:pPr lvl="3"/>
             <a:r>
-              <a:rPr lang="en-US"/>
+              <a:rPr lang="en-US" smtClean="0"/>
               <a:t>Fourth level</a:t>
             </a:r>
           </a:p>
           <a:p>
             <a:pPr lvl="4"/>
             <a:r>
-              <a:rPr lang="en-US"/>
+              <a:rPr lang="en-US" smtClean="0"/>
               <a:t>Fifth level</a:t>
             </a:r>
+            <a:endParaRPr lang="en-US"/>
           </a:p>
         </p:txBody>
       </p:sp>
@@ -1355,7 +1351,7 @@
           <a:p>
             <a:fld id="{5BCAD085-E8A6-8845-BD4E-CB4CCA059FC4}" type="datetimeFigureOut">
               <a:rPr lang="en-US" smtClean="0"/>
-              <a:t>9/14/26</a:t>
+              <a:t>1/27/13</a:t>
             </a:fld>
             <a:endParaRPr lang="en-US"/>
           </a:p>
@@ -1453,9 +1449,10 @@
           </a:lstStyle>
           <a:p>
             <a:r>
-              <a:rPr lang="en-US"/>
+              <a:rPr lang="en-US" smtClean="0"/>
               <a:t>Click to edit Master title style</a:t>
             </a:r>
+            <a:endParaRPr lang="en-US"/>
           </a:p>
         </p:txBody>
       </p:sp>
@@ -1518,7 +1515,7 @@
           <a:p>
             <a:pPr lvl="0"/>
             <a:r>
-              <a:rPr lang="en-US"/>
+              <a:rPr lang="en-US" smtClean="0"/>
               <a:t>Click to edit Master text styles</a:t>
             </a:r>
           </a:p>
@@ -1574,37 +1571,38 @@
           <a:p>
             <a:pPr lvl="0"/>
             <a:r>
-              <a:rPr lang="en-US"/>
+              <a:rPr lang="en-US" smtClean="0"/>
               <a:t>Click to edit Master text styles</a:t>
             </a:r>
           </a:p>
           <a:p>
             <a:pPr lvl="1"/>
             <a:r>
-              <a:rPr lang="en-US"/>
+              <a:rPr lang="en-US" smtClean="0"/>
               <a:t>Second level</a:t>
             </a:r>
           </a:p>
           <a:p>
             <a:pPr lvl="2"/>
             <a:r>
-              <a:rPr lang="en-US"/>
+              <a:rPr lang="en-US" smtClean="0"/>
               <a:t>Third level</a:t>
             </a:r>
           </a:p>
           <a:p>
             <a:pPr lvl="3"/>
             <a:r>
-              <a:rPr lang="en-US"/>
+              <a:rPr lang="en-US" smtClean="0"/>
               <a:t>Fourth level</a:t>
             </a:r>
           </a:p>
           <a:p>
             <a:pPr lvl="4"/>
             <a:r>
-              <a:rPr lang="en-US"/>
+              <a:rPr lang="en-US" smtClean="0"/>
               <a:t>Fifth level</a:t>
             </a:r>
+            <a:endParaRPr lang="en-US"/>
           </a:p>
         </p:txBody>
       </p:sp>
@@ -1667,7 +1665,7 @@
           <a:p>
             <a:pPr lvl="0"/>
             <a:r>
-              <a:rPr lang="en-US"/>
+              <a:rPr lang="en-US" smtClean="0"/>
               <a:t>Click to edit Master text styles</a:t>
             </a:r>
           </a:p>
@@ -1723,37 +1721,38 @@
           <a:p>
             <a:pPr lvl="0"/>
             <a:r>
-              <a:rPr lang="en-US"/>
+              <a:rPr lang="en-US" smtClean="0"/>
               <a:t>Click to edit Master text styles</a:t>
             </a:r>
           </a:p>
           <a:p>
             <a:pPr lvl="1"/>
             <a:r>
-              <a:rPr lang="en-US"/>
+              <a:rPr lang="en-US" smtClean="0"/>
               <a:t>Second level</a:t>
             </a:r>
           </a:p>
           <a:p>
             <a:pPr lvl="2"/>
             <a:r>
-              <a:rPr lang="en-US"/>
+              <a:rPr lang="en-US" smtClean="0"/>
               <a:t>Third level</a:t>
             </a:r>
           </a:p>
           <a:p>
             <a:pPr lvl="3"/>
             <a:r>
-              <a:rPr lang="en-US"/>
+              <a:rPr lang="en-US" smtClean="0"/>
               <a:t>Fourth level</a:t>
             </a:r>
           </a:p>
           <a:p>
             <a:pPr lvl="4"/>
             <a:r>
-              <a:rPr lang="en-US"/>
+              <a:rPr lang="en-US" smtClean="0"/>
               <a:t>Fifth level</a:t>
             </a:r>
+            <a:endParaRPr lang="en-US"/>
           </a:p>
         </p:txBody>
       </p:sp>
@@ -1774,7 +1773,7 @@
           <a:p>
             <a:fld id="{5BCAD085-E8A6-8845-BD4E-CB4CCA059FC4}" type="datetimeFigureOut">
               <a:rPr lang="en-US" smtClean="0"/>
-              <a:t>9/14/26</a:t>
+              <a:t>1/27/13</a:t>
             </a:fld>
             <a:endParaRPr lang="en-US"/>
           </a:p>
@@ -1868,9 +1867,10 @@
           <a:lstStyle/>
           <a:p>
             <a:r>
-              <a:rPr lang="en-US"/>
+              <a:rPr lang="en-US" smtClean="0"/>
               <a:t>Click to edit Master title style</a:t>
             </a:r>
+            <a:endParaRPr lang="en-US"/>
           </a:p>
         </p:txBody>
       </p:sp>
@@ -1891,7 +1891,7 @@
           <a:p>
             <a:fld id="{5BCAD085-E8A6-8845-BD4E-CB4CCA059FC4}" type="datetimeFigureOut">
               <a:rPr lang="en-US" smtClean="0"/>
-              <a:t>9/14/26</a:t>
+              <a:t>1/27/13</a:t>
             </a:fld>
             <a:endParaRPr lang="en-US"/>
           </a:p>
@@ -1986,7 +1986,7 @@
           <a:p>
             <a:fld id="{5BCAD085-E8A6-8845-BD4E-CB4CCA059FC4}" type="datetimeFigureOut">
               <a:rPr lang="en-US" smtClean="0"/>
-              <a:t>9/14/26</a:t>
+              <a:t>1/27/13</a:t>
             </a:fld>
             <a:endParaRPr lang="en-US"/>
           </a:p>
@@ -2089,9 +2089,10 @@
           </a:lstStyle>
           <a:p>
             <a:r>
-              <a:rPr lang="en-US"/>
+              <a:rPr lang="en-US" smtClean="0"/>
               <a:t>Click to edit Master title style</a:t>
             </a:r>
+            <a:endParaRPr lang="en-US"/>
           </a:p>
         </p:txBody>
       </p:sp>
@@ -2145,37 +2146,38 @@
           <a:p>
             <a:pPr lvl="0"/>
             <a:r>
-              <a:rPr lang="en-US"/>
+              <a:rPr lang="en-US" smtClean="0"/>
               <a:t>Click to edit Master text styles</a:t>
             </a:r>
           </a:p>
           <a:p>
             <a:pPr lvl="1"/>
             <a:r>
-              <a:rPr lang="en-US"/>
+              <a:rPr lang="en-US" smtClean="0"/>
               <a:t>Second level</a:t>
             </a:r>
           </a:p>
           <a:p>
             <a:pPr lvl="2"/>
             <a:r>
-              <a:rPr lang="en-US"/>
+              <a:rPr lang="en-US" smtClean="0"/>
               <a:t>Third level</a:t>
             </a:r>
           </a:p>
           <a:p>
             <a:pPr lvl="3"/>
             <a:r>
-              <a:rPr lang="en-US"/>
+              <a:rPr lang="en-US" smtClean="0"/>
               <a:t>Fourth level</a:t>
             </a:r>
           </a:p>
           <a:p>
             <a:pPr lvl="4"/>
             <a:r>
-              <a:rPr lang="en-US"/>
+              <a:rPr lang="en-US" smtClean="0"/>
               <a:t>Fifth level</a:t>
             </a:r>
+            <a:endParaRPr lang="en-US"/>
           </a:p>
         </p:txBody>
       </p:sp>
@@ -2238,7 +2240,7 @@
           <a:p>
             <a:pPr lvl="0"/>
             <a:r>
-              <a:rPr lang="en-US"/>
+              <a:rPr lang="en-US" smtClean="0"/>
               <a:t>Click to edit Master text styles</a:t>
             </a:r>
           </a:p>
@@ -2261,7 +2263,7 @@
           <a:p>
             <a:fld id="{5BCAD085-E8A6-8845-BD4E-CB4CCA059FC4}" type="datetimeFigureOut">
               <a:rPr lang="en-US" smtClean="0"/>
-              <a:t>9/14/26</a:t>
+              <a:t>1/27/13</a:t>
             </a:fld>
             <a:endParaRPr lang="en-US"/>
           </a:p>
@@ -2364,9 +2366,10 @@
           </a:lstStyle>
           <a:p>
             <a:r>
-              <a:rPr lang="en-US"/>
+              <a:rPr lang="en-US" smtClean="0"/>
               <a:t>Click to edit Master title style</a:t>
             </a:r>
+            <a:endParaRPr lang="en-US"/>
           </a:p>
         </p:txBody>
       </p:sp>
@@ -2490,7 +2493,7 @@
           <a:p>
             <a:pPr lvl="0"/>
             <a:r>
-              <a:rPr lang="en-US"/>
+              <a:rPr lang="en-US" smtClean="0"/>
               <a:t>Click to edit Master text styles</a:t>
             </a:r>
           </a:p>
@@ -2513,7 +2516,7 @@
           <a:p>
             <a:fld id="{5BCAD085-E8A6-8845-BD4E-CB4CCA059FC4}" type="datetimeFigureOut">
               <a:rPr lang="en-US" smtClean="0"/>
-              <a:t>9/14/26</a:t>
+              <a:t>1/27/13</a:t>
             </a:fld>
             <a:endParaRPr lang="en-US"/>
           </a:p>
@@ -2622,9 +2625,10 @@
           <a:lstStyle/>
           <a:p>
             <a:r>
-              <a:rPr lang="en-US"/>
+              <a:rPr lang="en-US" smtClean="0"/>
               <a:t>Click to edit Master title style</a:t>
             </a:r>
+            <a:endParaRPr lang="en-US"/>
           </a:p>
         </p:txBody>
       </p:sp>
@@ -2655,37 +2659,38 @@
           <a:p>
             <a:pPr lvl="0"/>
             <a:r>
-              <a:rPr lang="en-US"/>
+              <a:rPr lang="en-US" smtClean="0"/>
               <a:t>Click to edit Master text styles</a:t>
             </a:r>
           </a:p>
           <a:p>
             <a:pPr lvl="1"/>
             <a:r>
-              <a:rPr lang="en-US"/>
+              <a:rPr lang="en-US" smtClean="0"/>
               <a:t>Second level</a:t>
             </a:r>
           </a:p>
           <a:p>
             <a:pPr lvl="2"/>
             <a:r>
-              <a:rPr lang="en-US"/>
+              <a:rPr lang="en-US" smtClean="0"/>
               <a:t>Third level</a:t>
             </a:r>
           </a:p>
           <a:p>
             <a:pPr lvl="3"/>
             <a:r>
-              <a:rPr lang="en-US"/>
+              <a:rPr lang="en-US" smtClean="0"/>
               <a:t>Fourth level</a:t>
             </a:r>
           </a:p>
           <a:p>
             <a:pPr lvl="4"/>
             <a:r>
-              <a:rPr lang="en-US"/>
+              <a:rPr lang="en-US" smtClean="0"/>
               <a:t>Fifth level</a:t>
             </a:r>
+            <a:endParaRPr lang="en-US"/>
           </a:p>
         </p:txBody>
       </p:sp>
@@ -2724,7 +2729,7 @@
           <a:p>
             <a:fld id="{5BCAD085-E8A6-8845-BD4E-CB4CCA059FC4}" type="datetimeFigureOut">
               <a:rPr lang="en-US" smtClean="0"/>
-              <a:t>9/14/26</a:t>
+              <a:t>1/27/13</a:t>
             </a:fld>
             <a:endParaRPr lang="en-US"/>
           </a:p>
@@ -3083,7 +3088,7 @@
 </file>
 
 <file path=ppt/slides/slide1.xml><?xml version="1.0" encoding="utf-8"?>
-<p:sld xmlns:a="http://schemas.openxmlformats.org/drawingml/2006/main" xmlns:r="http://schemas.openxmlformats.org/officeDocument/2006/relationships" xmlns:p="http://schemas.openxmlformats.org/presentationml/2006/main">
+<p:sld xmlns:a="http://schemas.openxmlformats.org/drawingml/2006/main" xmlns:p="http://schemas.openxmlformats.org/presentationml/2006/main" xmlns:r="http://schemas.openxmlformats.org/officeDocument/2006/relationships">
   <p:cSld>
     <p:bg>
       <p:bgPr>
@@ -3099,14 +3104,7 @@
         <p:cNvGrpSpPr/>
         <p:nvPr/>
       </p:nvGrpSpPr>
-      <p:grpSpPr>
-        <a:xfrm>
-          <a:off x="0" y="0"/>
-          <a:ext cx="0" cy="0"/>
-          <a:chOff x="0" y="0"/>
-          <a:chExt cx="0" cy="0"/>
-        </a:xfrm>
-      </p:grpSpPr>
+      <p:grpSpPr/>
       <p:sp>
         <p:nvSpPr>
           <p:cNvPr id="2" name="Rectangle 1"/>
@@ -3148,7 +3146,6 @@
           <a:lstStyle/>
           <a:p>
             <a:pPr algn="ctr"/>
-            <a:endParaRPr/>
           </a:p>
         </p:txBody>
       </p:sp>
@@ -3169,7 +3166,7 @@
           <a:noFill/>
         </p:spPr>
         <p:txBody>
-          <a:bodyPr wrap="square" lIns="0" tIns="0" rIns="0" bIns="0" anchor="t">
+          <a:bodyPr wrap="square" anchor="t" lIns="0" rIns="0" tIns="0" bIns="0">
             <a:spAutoFit/>
           </a:bodyPr>
           <a:lstStyle/>
@@ -3211,7 +3208,7 @@
           <a:noFill/>
         </p:spPr>
         <p:txBody>
-          <a:bodyPr wrap="square" lIns="0" tIns="0" rIns="0" bIns="0" anchor="t">
+          <a:bodyPr wrap="square" anchor="t" lIns="0" rIns="0" tIns="0" bIns="0">
             <a:spAutoFit/>
           </a:bodyPr>
           <a:lstStyle/>
@@ -3277,7 +3274,6 @@
           <a:lstStyle/>
           <a:p>
             <a:pPr algn="ctr"/>
-            <a:endParaRPr/>
           </a:p>
         </p:txBody>
       </p:sp>
@@ -3298,7 +3294,7 @@
           <a:noFill/>
         </p:spPr>
         <p:txBody>
-          <a:bodyPr wrap="square" lIns="0" tIns="0" rIns="0" bIns="0" anchor="t">
+          <a:bodyPr wrap="square" anchor="t" lIns="0" rIns="0" tIns="0" bIns="0">
             <a:spAutoFit/>
           </a:bodyPr>
           <a:lstStyle/>
@@ -3340,7 +3336,7 @@
           <a:noFill/>
         </p:spPr>
         <p:txBody>
-          <a:bodyPr wrap="square" lIns="0" tIns="0" rIns="0" bIns="0" anchor="t">
+          <a:bodyPr wrap="square" anchor="t" lIns="0" rIns="0" tIns="0" bIns="0">
             <a:spAutoFit/>
           </a:bodyPr>
           <a:lstStyle/>
@@ -3374,7 +3370,7 @@
 </file>
 
 <file path=ppt/slides/slide10.xml><?xml version="1.0" encoding="utf-8"?>
-<p:sld xmlns:a="http://schemas.openxmlformats.org/drawingml/2006/main" xmlns:r="http://schemas.openxmlformats.org/officeDocument/2006/relationships" xmlns:p="http://schemas.openxmlformats.org/presentationml/2006/main">
+<p:sld xmlns:a="http://schemas.openxmlformats.org/drawingml/2006/main" xmlns:p="http://schemas.openxmlformats.org/presentationml/2006/main" xmlns:r="http://schemas.openxmlformats.org/officeDocument/2006/relationships">
   <p:cSld>
     <p:bg>
       <p:bgPr>
@@ -3390,14 +3386,7 @@
         <p:cNvGrpSpPr/>
         <p:nvPr/>
       </p:nvGrpSpPr>
-      <p:grpSpPr>
-        <a:xfrm>
-          <a:off x="0" y="0"/>
-          <a:ext cx="0" cy="0"/>
-          <a:chOff x="0" y="0"/>
-          <a:chExt cx="0" cy="0"/>
-        </a:xfrm>
-      </p:grpSpPr>
+      <p:grpSpPr/>
       <p:sp>
         <p:nvSpPr>
           <p:cNvPr id="2" name="Rectangle 1"/>
@@ -3439,7 +3428,6 @@
           <a:lstStyle/>
           <a:p>
             <a:pPr algn="ctr"/>
-            <a:endParaRPr/>
           </a:p>
         </p:txBody>
       </p:sp>
@@ -3460,7 +3448,7 @@
           <a:noFill/>
         </p:spPr>
         <p:txBody>
-          <a:bodyPr wrap="square" lIns="0" tIns="0" rIns="0" bIns="0" anchor="t">
+          <a:bodyPr wrap="square" anchor="t" lIns="0" rIns="0" tIns="0" bIns="0">
             <a:spAutoFit/>
           </a:bodyPr>
           <a:lstStyle/>
@@ -3502,7 +3490,7 @@
           <a:noFill/>
         </p:spPr>
         <p:txBody>
-          <a:bodyPr wrap="square" lIns="0" tIns="0" rIns="0" bIns="0" anchor="t">
+          <a:bodyPr wrap="square" anchor="t" lIns="0" rIns="0" tIns="0" bIns="0">
             <a:spAutoFit/>
           </a:bodyPr>
           <a:lstStyle/>
@@ -3568,7 +3556,6 @@
           <a:lstStyle/>
           <a:p>
             <a:pPr algn="ctr"/>
-            <a:endParaRPr/>
           </a:p>
         </p:txBody>
       </p:sp>
@@ -3589,7 +3576,7 @@
           <a:noFill/>
         </p:spPr>
         <p:txBody>
-          <a:bodyPr wrap="square" lIns="0" tIns="0" rIns="0" bIns="0" anchor="t">
+          <a:bodyPr wrap="square" anchor="t" lIns="0" rIns="0" tIns="0" bIns="0">
             <a:spAutoFit/>
           </a:bodyPr>
           <a:lstStyle/>
@@ -3631,7 +3618,7 @@
           <a:noFill/>
         </p:spPr>
         <p:txBody>
-          <a:bodyPr wrap="square" lIns="0" tIns="0" rIns="0" bIns="0" anchor="t">
+          <a:bodyPr wrap="square" anchor="t" lIns="0" rIns="0" tIns="0" bIns="0">
             <a:spAutoFit/>
           </a:bodyPr>
           <a:lstStyle/>
@@ -3672,8 +3659,8 @@
         </p:blipFill>
         <p:spPr>
           <a:xfrm>
-            <a:off x="365760" y="1431188"/>
-            <a:ext cx="7040880" cy="3081223"/>
+            <a:off x="365760" y="1429512"/>
+            <a:ext cx="7040880" cy="3084576"/>
           </a:xfrm>
           <a:prstGeom prst="rect">
             <a:avLst/>
@@ -3721,7 +3708,6 @@
           <a:lstStyle/>
           <a:p>
             <a:pPr algn="ctr"/>
-            <a:endParaRPr/>
           </a:p>
         </p:txBody>
       </p:sp>
@@ -3742,7 +3728,7 @@
           <a:noFill/>
         </p:spPr>
         <p:txBody>
-          <a:bodyPr wrap="square" lIns="0" tIns="0" rIns="0" bIns="0">
+          <a:bodyPr wrap="square" lIns="0" rIns="0" tIns="0" bIns="0">
             <a:spAutoFit/>
           </a:bodyPr>
           <a:lstStyle/>
@@ -3762,7 +3748,7 @@
                 </a:solidFill>
                 <a:latin typeface="Calibri"/>
               </a:rPr>
-              <a:t>—  Simple payback (capex ÷ 2023 backcast revenue, no financing/tax/O&amp;M): Standalone Solar ~22 yrs, Standalone Storage ~44 yrs, Combined ~22 yrs.</a:t>
+              <a:t>—  Simple payback (capex ÷ 2023 backcast revenue, no financing/tax/O&amp;M): Standalone Solar ~21 yrs, Standalone Storage ~30 yrs, Combined ~21 yrs.</a:t>
             </a:r>
           </a:p>
         </p:txBody>
@@ -3810,7 +3796,6 @@
           <a:lstStyle/>
           <a:p>
             <a:pPr algn="ctr"/>
-            <a:endParaRPr/>
           </a:p>
         </p:txBody>
       </p:sp>
@@ -3831,7 +3816,7 @@
           <a:noFill/>
         </p:spPr>
         <p:txBody>
-          <a:bodyPr wrap="square" lIns="0" tIns="0" rIns="0" bIns="0" anchor="t">
+          <a:bodyPr wrap="square" anchor="t" lIns="0" rIns="0" tIns="0" bIns="0">
             <a:spAutoFit/>
           </a:bodyPr>
           <a:lstStyle/>
@@ -3873,7 +3858,7 @@
           <a:noFill/>
         </p:spPr>
         <p:txBody>
-          <a:bodyPr wrap="square" lIns="0" tIns="0" rIns="0" bIns="0">
+          <a:bodyPr wrap="square" lIns="0" rIns="0" tIns="0" bIns="0">
             <a:spAutoFit/>
           </a:bodyPr>
           <a:lstStyle/>
@@ -3953,7 +3938,7 @@
           <a:noFill/>
         </p:spPr>
         <p:txBody>
-          <a:bodyPr wrap="square" lIns="0" tIns="0" rIns="0" bIns="0" anchor="t">
+          <a:bodyPr wrap="square" anchor="t" lIns="0" rIns="0" tIns="0" bIns="0">
             <a:spAutoFit/>
           </a:bodyPr>
           <a:lstStyle/>
@@ -3973,7 +3958,7 @@
                 </a:solidFill>
                 <a:latin typeface="Calibri"/>
               </a:rPr>
-              <a:t>Caveat: standalone storage looks uneconomic here because only day-ahead energy arbitrage was modeled. Real storage revenue also includes capacity &amp; ancillary services (Q3b) — revisit before committing capital.</a:t>
+              <a:t>Caveat: standalone storage still looks weak here because only real-time energy arbitrage was modeled. Real storage revenue also includes capacity &amp; ancillary services (Q3b) — revisit before committing capital.</a:t>
             </a:r>
           </a:p>
         </p:txBody>
@@ -3987,7 +3972,7 @@
 </file>
 
 <file path=ppt/slides/slide2.xml><?xml version="1.0" encoding="utf-8"?>
-<p:sld xmlns:a="http://schemas.openxmlformats.org/drawingml/2006/main" xmlns:r="http://schemas.openxmlformats.org/officeDocument/2006/relationships" xmlns:p="http://schemas.openxmlformats.org/presentationml/2006/main">
+<p:sld xmlns:a="http://schemas.openxmlformats.org/drawingml/2006/main" xmlns:p="http://schemas.openxmlformats.org/presentationml/2006/main" xmlns:r="http://schemas.openxmlformats.org/officeDocument/2006/relationships">
   <p:cSld>
     <p:bg>
       <p:bgPr>
@@ -4003,14 +3988,7 @@
         <p:cNvGrpSpPr/>
         <p:nvPr/>
       </p:nvGrpSpPr>
-      <p:grpSpPr>
-        <a:xfrm>
-          <a:off x="0" y="0"/>
-          <a:ext cx="0" cy="0"/>
-          <a:chOff x="0" y="0"/>
-          <a:chExt cx="0" cy="0"/>
-        </a:xfrm>
-      </p:grpSpPr>
+      <p:grpSpPr/>
       <p:sp>
         <p:nvSpPr>
           <p:cNvPr id="2" name="Rectangle 1"/>
@@ -4052,7 +4030,6 @@
           <a:lstStyle/>
           <a:p>
             <a:pPr algn="ctr"/>
-            <a:endParaRPr/>
           </a:p>
         </p:txBody>
       </p:sp>
@@ -4073,7 +4050,7 @@
           <a:noFill/>
         </p:spPr>
         <p:txBody>
-          <a:bodyPr wrap="square" lIns="0" tIns="0" rIns="0" bIns="0" anchor="t">
+          <a:bodyPr wrap="square" anchor="t" lIns="0" rIns="0" tIns="0" bIns="0">
             <a:spAutoFit/>
           </a:bodyPr>
           <a:lstStyle/>
@@ -4115,7 +4092,7 @@
           <a:noFill/>
         </p:spPr>
         <p:txBody>
-          <a:bodyPr wrap="square" lIns="0" tIns="0" rIns="0" bIns="0" anchor="t">
+          <a:bodyPr wrap="square" anchor="t" lIns="0" rIns="0" tIns="0" bIns="0">
             <a:spAutoFit/>
           </a:bodyPr>
           <a:lstStyle/>
@@ -4181,7 +4158,6 @@
           <a:lstStyle/>
           <a:p>
             <a:pPr algn="ctr"/>
-            <a:endParaRPr/>
           </a:p>
         </p:txBody>
       </p:sp>
@@ -4202,7 +4178,7 @@
           <a:noFill/>
         </p:spPr>
         <p:txBody>
-          <a:bodyPr wrap="square" lIns="0" tIns="0" rIns="0" bIns="0" anchor="t">
+          <a:bodyPr wrap="square" anchor="t" lIns="0" rIns="0" tIns="0" bIns="0">
             <a:spAutoFit/>
           </a:bodyPr>
           <a:lstStyle/>
@@ -4244,7 +4220,7 @@
           <a:noFill/>
         </p:spPr>
         <p:txBody>
-          <a:bodyPr wrap="square" lIns="0" tIns="0" rIns="0" bIns="0" anchor="t">
+          <a:bodyPr wrap="square" anchor="t" lIns="0" rIns="0" tIns="0" bIns="0">
             <a:spAutoFit/>
           </a:bodyPr>
           <a:lstStyle/>
@@ -4312,7 +4288,6 @@
           <a:lstStyle/>
           <a:p>
             <a:pPr algn="ctr"/>
-            <a:endParaRPr/>
           </a:p>
         </p:txBody>
       </p:sp>
@@ -4333,7 +4308,7 @@
           <a:noFill/>
         </p:spPr>
         <p:txBody>
-          <a:bodyPr wrap="square" lIns="0" tIns="0" rIns="0" bIns="0" anchor="t">
+          <a:bodyPr wrap="square" anchor="t" lIns="0" rIns="0" tIns="0" bIns="0">
             <a:spAutoFit/>
           </a:bodyPr>
           <a:lstStyle/>
@@ -4375,7 +4350,7 @@
           <a:noFill/>
         </p:spPr>
         <p:txBody>
-          <a:bodyPr wrap="square" lIns="0" tIns="0" rIns="0" bIns="0" anchor="t">
+          <a:bodyPr wrap="square" anchor="t" lIns="0" rIns="0" tIns="0" bIns="0">
             <a:spAutoFit/>
           </a:bodyPr>
           <a:lstStyle/>
@@ -4462,7 +4437,6 @@
           <a:lstStyle/>
           <a:p>
             <a:pPr algn="ctr"/>
-            <a:endParaRPr/>
           </a:p>
         </p:txBody>
       </p:sp>
@@ -4483,7 +4457,7 @@
           <a:noFill/>
         </p:spPr>
         <p:txBody>
-          <a:bodyPr wrap="square" lIns="0" tIns="0" rIns="0" bIns="0" anchor="t">
+          <a:bodyPr wrap="square" anchor="t" lIns="0" rIns="0" tIns="0" bIns="0">
             <a:spAutoFit/>
           </a:bodyPr>
           <a:lstStyle/>
@@ -4503,7 +4477,7 @@
                 </a:solidFill>
                 <a:latin typeface="Calibri"/>
               </a:rPr>
-              <a:t>$18.8M</a:t>
+              <a:t>$18.9M</a:t>
             </a:r>
           </a:p>
         </p:txBody>
@@ -4525,7 +4499,7 @@
           <a:noFill/>
         </p:spPr>
         <p:txBody>
-          <a:bodyPr wrap="square" lIns="0" tIns="0" rIns="0" bIns="0" anchor="t">
+          <a:bodyPr wrap="square" anchor="t" lIns="0" rIns="0" tIns="0" bIns="0">
             <a:spAutoFit/>
           </a:bodyPr>
           <a:lstStyle/>
@@ -4612,7 +4586,6 @@
           <a:lstStyle/>
           <a:p>
             <a:pPr algn="ctr"/>
-            <a:endParaRPr/>
           </a:p>
         </p:txBody>
       </p:sp>
@@ -4633,7 +4606,7 @@
           <a:noFill/>
         </p:spPr>
         <p:txBody>
-          <a:bodyPr wrap="square" lIns="0" tIns="0" rIns="0" bIns="0" anchor="t">
+          <a:bodyPr wrap="square" anchor="t" lIns="0" rIns="0" tIns="0" bIns="0">
             <a:spAutoFit/>
           </a:bodyPr>
           <a:lstStyle/>
@@ -4653,7 +4626,7 @@
                 </a:solidFill>
                 <a:latin typeface="Calibri"/>
               </a:rPr>
-              <a:t>$1.7M</a:t>
+              <a:t>$2.5M</a:t>
             </a:r>
           </a:p>
         </p:txBody>
@@ -4675,7 +4648,7 @@
           <a:noFill/>
         </p:spPr>
         <p:txBody>
-          <a:bodyPr wrap="square" lIns="0" tIns="0" rIns="0" bIns="0" anchor="t">
+          <a:bodyPr wrap="square" anchor="t" lIns="0" rIns="0" tIns="0" bIns="0">
             <a:spAutoFit/>
           </a:bodyPr>
           <a:lstStyle/>
@@ -4762,7 +4735,6 @@
           <a:lstStyle/>
           <a:p>
             <a:pPr algn="ctr"/>
-            <a:endParaRPr/>
           </a:p>
         </p:txBody>
       </p:sp>
@@ -4783,7 +4755,7 @@
           <a:noFill/>
         </p:spPr>
         <p:txBody>
-          <a:bodyPr wrap="square" lIns="0" tIns="0" rIns="0" bIns="0" anchor="t">
+          <a:bodyPr wrap="square" anchor="t" lIns="0" rIns="0" tIns="0" bIns="0">
             <a:spAutoFit/>
           </a:bodyPr>
           <a:lstStyle/>
@@ -4803,7 +4775,7 @@
                 </a:solidFill>
                 <a:latin typeface="Calibri"/>
               </a:rPr>
-              <a:t>$20.5M</a:t>
+              <a:t>$21.4M</a:t>
             </a:r>
           </a:p>
         </p:txBody>
@@ -4825,7 +4797,7 @@
           <a:noFill/>
         </p:spPr>
         <p:txBody>
-          <a:bodyPr wrap="square" lIns="0" tIns="0" rIns="0" bIns="0" anchor="t">
+          <a:bodyPr wrap="square" anchor="t" lIns="0" rIns="0" tIns="0" bIns="0">
             <a:spAutoFit/>
           </a:bodyPr>
           <a:lstStyle/>
@@ -4886,7 +4858,7 @@
           <a:noFill/>
         </p:spPr>
         <p:txBody>
-          <a:bodyPr wrap="square" lIns="0" tIns="0" rIns="0" bIns="0">
+          <a:bodyPr wrap="square" lIns="0" rIns="0" tIns="0" bIns="0">
             <a:spAutoFit/>
           </a:bodyPr>
           <a:lstStyle/>
@@ -4963,7 +4935,7 @@
                 </a:solidFill>
                 <a:latin typeface="Calibri"/>
               </a:rPr>
-              <a:t>—  Pairing solar + storage adds only a marginal energy-arbitrage benefit today (+0.04%) since inverter clipping is minimal, but the combined package's cheaper per-unit equipment pricing saves ~$35M in capex vs. building both standalone.</a:t>
+              <a:t>—  Pairing solar + storage adds only a marginal energy-arbitrage benefit today (+0.03%) since inverter clipping is minimal, but the combined package's cheaper per-unit equipment pricing saves ~$35M in capex vs. building both standalone.</a:t>
             </a:r>
           </a:p>
         </p:txBody>
@@ -5011,7 +4983,6 @@
           <a:lstStyle/>
           <a:p>
             <a:pPr algn="ctr"/>
-            <a:endParaRPr/>
           </a:p>
         </p:txBody>
       </p:sp>
@@ -5032,7 +5003,7 @@
           <a:noFill/>
         </p:spPr>
         <p:txBody>
-          <a:bodyPr wrap="square" lIns="0" tIns="0" rIns="0" bIns="0" anchor="t">
+          <a:bodyPr wrap="square" anchor="t" lIns="0" rIns="0" tIns="0" bIns="0">
             <a:spAutoFit/>
           </a:bodyPr>
           <a:lstStyle/>
@@ -5074,7 +5045,7 @@
           <a:noFill/>
         </p:spPr>
         <p:txBody>
-          <a:bodyPr wrap="square" lIns="0" tIns="0" rIns="0" bIns="0" anchor="t">
+          <a:bodyPr wrap="square" anchor="t" lIns="0" rIns="0" tIns="0" bIns="0">
             <a:spAutoFit/>
           </a:bodyPr>
           <a:lstStyle/>
@@ -5116,7 +5087,7 @@
           <a:noFill/>
         </p:spPr>
         <p:txBody>
-          <a:bodyPr wrap="square" lIns="0" tIns="0" rIns="0" bIns="0">
+          <a:bodyPr wrap="square" lIns="0" rIns="0" tIns="0" bIns="0">
             <a:spAutoFit/>
           </a:bodyPr>
           <a:lstStyle/>
@@ -5136,7 +5107,7 @@
                 </a:solidFill>
                 <a:latin typeface="Calibri"/>
               </a:rPr>
-              <a:t>—  ~22-year simple payback — matches standalone solar, so storage is effectively "added for free" from a payback standpoint.</a:t>
+              <a:t>—  ~21-year simple payback — matches standalone solar, so storage is effectively "added for free" from a payback standpoint.</a:t>
             </a:r>
           </a:p>
           <a:p>
@@ -5188,7 +5159,7 @@
 </file>
 
 <file path=ppt/slides/slide3.xml><?xml version="1.0" encoding="utf-8"?>
-<p:sld xmlns:a="http://schemas.openxmlformats.org/drawingml/2006/main" xmlns:r="http://schemas.openxmlformats.org/officeDocument/2006/relationships" xmlns:p="http://schemas.openxmlformats.org/presentationml/2006/main">
+<p:sld xmlns:a="http://schemas.openxmlformats.org/drawingml/2006/main" xmlns:p="http://schemas.openxmlformats.org/presentationml/2006/main" xmlns:r="http://schemas.openxmlformats.org/officeDocument/2006/relationships">
   <p:cSld>
     <p:bg>
       <p:bgPr>
@@ -5204,14 +5175,7 @@
         <p:cNvGrpSpPr/>
         <p:nvPr/>
       </p:nvGrpSpPr>
-      <p:grpSpPr>
-        <a:xfrm>
-          <a:off x="0" y="0"/>
-          <a:ext cx="0" cy="0"/>
-          <a:chOff x="0" y="0"/>
-          <a:chExt cx="0" cy="0"/>
-        </a:xfrm>
-      </p:grpSpPr>
+      <p:grpSpPr/>
       <p:sp>
         <p:nvSpPr>
           <p:cNvPr id="2" name="Rectangle 1"/>
@@ -5253,7 +5217,6 @@
           <a:lstStyle/>
           <a:p>
             <a:pPr algn="ctr"/>
-            <a:endParaRPr/>
           </a:p>
         </p:txBody>
       </p:sp>
@@ -5274,7 +5237,7 @@
           <a:noFill/>
         </p:spPr>
         <p:txBody>
-          <a:bodyPr wrap="square" lIns="0" tIns="0" rIns="0" bIns="0" anchor="t">
+          <a:bodyPr wrap="square" anchor="t" lIns="0" rIns="0" tIns="0" bIns="0">
             <a:spAutoFit/>
           </a:bodyPr>
           <a:lstStyle/>
@@ -5316,7 +5279,7 @@
           <a:noFill/>
         </p:spPr>
         <p:txBody>
-          <a:bodyPr wrap="square" lIns="0" tIns="0" rIns="0" bIns="0" anchor="t">
+          <a:bodyPr wrap="square" anchor="t" lIns="0" rIns="0" tIns="0" bIns="0">
             <a:spAutoFit/>
           </a:bodyPr>
           <a:lstStyle/>
@@ -5382,7 +5345,6 @@
           <a:lstStyle/>
           <a:p>
             <a:pPr algn="ctr"/>
-            <a:endParaRPr/>
           </a:p>
         </p:txBody>
       </p:sp>
@@ -5403,7 +5365,7 @@
           <a:noFill/>
         </p:spPr>
         <p:txBody>
-          <a:bodyPr wrap="square" lIns="0" tIns="0" rIns="0" bIns="0" anchor="t">
+          <a:bodyPr wrap="square" anchor="t" lIns="0" rIns="0" tIns="0" bIns="0">
             <a:spAutoFit/>
           </a:bodyPr>
           <a:lstStyle/>
@@ -5445,7 +5407,7 @@
           <a:noFill/>
         </p:spPr>
         <p:txBody>
-          <a:bodyPr wrap="square" lIns="0" tIns="0" rIns="0" bIns="0" anchor="t">
+          <a:bodyPr wrap="square" anchor="t" lIns="0" rIns="0" tIns="0" bIns="0">
             <a:spAutoFit/>
           </a:bodyPr>
           <a:lstStyle/>
@@ -5511,7 +5473,7 @@
           <a:noFill/>
         </p:spPr>
         <p:txBody>
-          <a:bodyPr wrap="square" lIns="0" tIns="0" rIns="0" bIns="0">
+          <a:bodyPr wrap="square" lIns="0" rIns="0" tIns="0" bIns="0">
             <a:spAutoFit/>
           </a:bodyPr>
           <a:lstStyle/>
@@ -5621,7 +5583,7 @@
 </file>
 
 <file path=ppt/slides/slide4.xml><?xml version="1.0" encoding="utf-8"?>
-<p:sld xmlns:a="http://schemas.openxmlformats.org/drawingml/2006/main" xmlns:r="http://schemas.openxmlformats.org/officeDocument/2006/relationships" xmlns:p="http://schemas.openxmlformats.org/presentationml/2006/main">
+<p:sld xmlns:a="http://schemas.openxmlformats.org/drawingml/2006/main" xmlns:p="http://schemas.openxmlformats.org/presentationml/2006/main" xmlns:r="http://schemas.openxmlformats.org/officeDocument/2006/relationships">
   <p:cSld>
     <p:bg>
       <p:bgPr>
@@ -5637,14 +5599,7 @@
         <p:cNvGrpSpPr/>
         <p:nvPr/>
       </p:nvGrpSpPr>
-      <p:grpSpPr>
-        <a:xfrm>
-          <a:off x="0" y="0"/>
-          <a:ext cx="0" cy="0"/>
-          <a:chOff x="0" y="0"/>
-          <a:chExt cx="0" cy="0"/>
-        </a:xfrm>
-      </p:grpSpPr>
+      <p:grpSpPr/>
       <p:sp>
         <p:nvSpPr>
           <p:cNvPr id="2" name="Rectangle 1"/>
@@ -5686,7 +5641,6 @@
           <a:lstStyle/>
           <a:p>
             <a:pPr algn="ctr"/>
-            <a:endParaRPr/>
           </a:p>
         </p:txBody>
       </p:sp>
@@ -5707,7 +5661,7 @@
           <a:noFill/>
         </p:spPr>
         <p:txBody>
-          <a:bodyPr wrap="square" lIns="0" tIns="0" rIns="0" bIns="0" anchor="t">
+          <a:bodyPr wrap="square" anchor="t" lIns="0" rIns="0" tIns="0" bIns="0">
             <a:spAutoFit/>
           </a:bodyPr>
           <a:lstStyle/>
@@ -5749,7 +5703,7 @@
           <a:noFill/>
         </p:spPr>
         <p:txBody>
-          <a:bodyPr wrap="square" lIns="0" tIns="0" rIns="0" bIns="0" anchor="t">
+          <a:bodyPr wrap="square" anchor="t" lIns="0" rIns="0" tIns="0" bIns="0">
             <a:spAutoFit/>
           </a:bodyPr>
           <a:lstStyle/>
@@ -5815,7 +5769,6 @@
           <a:lstStyle/>
           <a:p>
             <a:pPr algn="ctr"/>
-            <a:endParaRPr/>
           </a:p>
         </p:txBody>
       </p:sp>
@@ -5836,7 +5789,7 @@
           <a:noFill/>
         </p:spPr>
         <p:txBody>
-          <a:bodyPr wrap="square" lIns="0" tIns="0" rIns="0" bIns="0" anchor="t">
+          <a:bodyPr wrap="square" anchor="t" lIns="0" rIns="0" tIns="0" bIns="0">
             <a:spAutoFit/>
           </a:bodyPr>
           <a:lstStyle/>
@@ -5878,7 +5831,7 @@
           <a:noFill/>
         </p:spPr>
         <p:txBody>
-          <a:bodyPr wrap="square" lIns="0" tIns="0" rIns="0" bIns="0" anchor="t">
+          <a:bodyPr wrap="square" anchor="t" lIns="0" rIns="0" tIns="0" bIns="0">
             <a:spAutoFit/>
           </a:bodyPr>
           <a:lstStyle/>
@@ -5968,7 +5921,7 @@
           <a:noFill/>
         </p:spPr>
         <p:txBody>
-          <a:bodyPr wrap="square" lIns="0" tIns="0" rIns="0" bIns="0" anchor="t">
+          <a:bodyPr wrap="square" anchor="t" lIns="0" rIns="0" tIns="0" bIns="0">
             <a:spAutoFit/>
           </a:bodyPr>
           <a:lstStyle/>
@@ -6010,7 +5963,7 @@
           <a:noFill/>
         </p:spPr>
         <p:txBody>
-          <a:bodyPr wrap="square" lIns="0" tIns="0" rIns="0" bIns="0">
+          <a:bodyPr wrap="square" lIns="0" rIns="0" tIns="0" bIns="0">
             <a:spAutoFit/>
           </a:bodyPr>
           <a:lstStyle/>
@@ -6071,7 +6024,7 @@
           <a:noFill/>
         </p:spPr>
         <p:txBody>
-          <a:bodyPr wrap="square" lIns="0" tIns="0" rIns="0" bIns="0" anchor="t">
+          <a:bodyPr wrap="square" anchor="t" lIns="0" rIns="0" tIns="0" bIns="0">
             <a:spAutoFit/>
           </a:bodyPr>
           <a:lstStyle/>
@@ -6113,7 +6066,7 @@
           <a:noFill/>
         </p:spPr>
         <p:txBody>
-          <a:bodyPr wrap="square" lIns="0" tIns="0" rIns="0" bIns="0">
+          <a:bodyPr wrap="square" lIns="0" rIns="0" tIns="0" bIns="0">
             <a:spAutoFit/>
           </a:bodyPr>
           <a:lstStyle/>
@@ -6166,7 +6119,7 @@
 </file>
 
 <file path=ppt/slides/slide5.xml><?xml version="1.0" encoding="utf-8"?>
-<p:sld xmlns:a="http://schemas.openxmlformats.org/drawingml/2006/main" xmlns:r="http://schemas.openxmlformats.org/officeDocument/2006/relationships" xmlns:p="http://schemas.openxmlformats.org/presentationml/2006/main">
+<p:sld xmlns:a="http://schemas.openxmlformats.org/drawingml/2006/main" xmlns:p="http://schemas.openxmlformats.org/presentationml/2006/main" xmlns:r="http://schemas.openxmlformats.org/officeDocument/2006/relationships">
   <p:cSld>
     <p:bg>
       <p:bgPr>
@@ -6182,14 +6135,7 @@
         <p:cNvGrpSpPr/>
         <p:nvPr/>
       </p:nvGrpSpPr>
-      <p:grpSpPr>
-        <a:xfrm>
-          <a:off x="0" y="0"/>
-          <a:ext cx="0" cy="0"/>
-          <a:chOff x="0" y="0"/>
-          <a:chExt cx="0" cy="0"/>
-        </a:xfrm>
-      </p:grpSpPr>
+      <p:grpSpPr/>
       <p:sp>
         <p:nvSpPr>
           <p:cNvPr id="2" name="Rectangle 1"/>
@@ -6231,7 +6177,6 @@
           <a:lstStyle/>
           <a:p>
             <a:pPr algn="ctr"/>
-            <a:endParaRPr/>
           </a:p>
         </p:txBody>
       </p:sp>
@@ -6252,7 +6197,7 @@
           <a:noFill/>
         </p:spPr>
         <p:txBody>
-          <a:bodyPr wrap="square" lIns="0" tIns="0" rIns="0" bIns="0" anchor="t">
+          <a:bodyPr wrap="square" anchor="t" lIns="0" rIns="0" tIns="0" bIns="0">
             <a:spAutoFit/>
           </a:bodyPr>
           <a:lstStyle/>
@@ -6294,7 +6239,7 @@
           <a:noFill/>
         </p:spPr>
         <p:txBody>
-          <a:bodyPr wrap="square" lIns="0" tIns="0" rIns="0" bIns="0" anchor="t">
+          <a:bodyPr wrap="square" anchor="t" lIns="0" rIns="0" tIns="0" bIns="0">
             <a:spAutoFit/>
           </a:bodyPr>
           <a:lstStyle/>
@@ -6360,7 +6305,6 @@
           <a:lstStyle/>
           <a:p>
             <a:pPr algn="ctr"/>
-            <a:endParaRPr/>
           </a:p>
         </p:txBody>
       </p:sp>
@@ -6381,7 +6325,7 @@
           <a:noFill/>
         </p:spPr>
         <p:txBody>
-          <a:bodyPr wrap="square" lIns="0" tIns="0" rIns="0" bIns="0" anchor="t">
+          <a:bodyPr wrap="square" anchor="t" lIns="0" rIns="0" tIns="0" bIns="0">
             <a:spAutoFit/>
           </a:bodyPr>
           <a:lstStyle/>
@@ -6423,7 +6367,7 @@
           <a:noFill/>
         </p:spPr>
         <p:txBody>
-          <a:bodyPr wrap="square" lIns="0" tIns="0" rIns="0" bIns="0" anchor="t">
+          <a:bodyPr wrap="square" anchor="t" lIns="0" rIns="0" tIns="0" bIns="0">
             <a:spAutoFit/>
           </a:bodyPr>
           <a:lstStyle/>
@@ -6457,7 +6401,7 @@
         <p:spPr>
           <a:xfrm>
             <a:off x="502920" y="1417320"/>
-            <a:ext cx="11155680" cy="430887"/>
+            <a:ext cx="11155680" cy="365760"/>
           </a:xfrm>
           <a:prstGeom prst="rect">
             <a:avLst/>
@@ -6465,7 +6409,7 @@
           <a:noFill/>
         </p:spPr>
         <p:txBody>
-          <a:bodyPr wrap="square" lIns="0" tIns="0" rIns="0" bIns="0" anchor="t">
+          <a:bodyPr wrap="square" anchor="t" lIns="0" rIns="0" tIns="0" bIns="0">
             <a:spAutoFit/>
           </a:bodyPr>
           <a:lstStyle/>
@@ -6479,69 +6423,14 @@
               </a:spcAft>
             </a:pPr>
             <a:r>
-              <a:rPr sz="1400" b="0" i="1" dirty="0">
+              <a:rPr sz="1400" b="0" i="1">
                 <a:solidFill>
                   <a:srgbClr val="52514E"/>
                 </a:solidFill>
                 <a:latin typeface="Calibri"/>
               </a:rPr>
-              <a:t>Price basis: </a:t>
-            </a:r>
-            <a:r>
-              <a:rPr sz="1400" b="0" i="1" dirty="0">
-                <a:solidFill>
-                  <a:srgbClr val="52514E"/>
-                </a:solidFill>
-                <a:highlight>
-                  <a:srgbClr val="FFFF00"/>
-                </a:highlight>
-                <a:latin typeface="Calibri"/>
-              </a:rPr>
-              <a:t>Day-Ahead (DA) prices used throughout — the standard settlement mechanism for a utility-scale resource's bulk energy position.</a:t>
-            </a:r>
-            <a:r>
-              <a:rPr lang="en-US" sz="1400" b="0" i="1" dirty="0">
-                <a:solidFill>
-                  <a:srgbClr val="52514E"/>
-                </a:solidFill>
-                <a:highlight>
-                  <a:srgbClr val="FFFF00"/>
-                </a:highlight>
-                <a:latin typeface="Calibri"/>
-              </a:rPr>
-              <a:t>  </a:t>
-            </a:r>
-          </a:p>
-          <a:p>
-            <a:pPr algn="l">
-              <a:lnSpc>
-                <a:spcPct val="100000"/>
-              </a:lnSpc>
-              <a:spcAft>
-                <a:spcPts val="0"/>
-              </a:spcAft>
-            </a:pPr>
-            <a:r>
-              <a:rPr lang="en-US" sz="1400" b="0" i="1" u="sng" dirty="0">
-                <a:solidFill>
-                  <a:srgbClr val="52514E"/>
-                </a:solidFill>
-                <a:highlight>
-                  <a:srgbClr val="FFFF00"/>
-                </a:highlight>
-                <a:latin typeface="Calibri"/>
-              </a:rPr>
-              <a:t>Using real-time price because we evaluate the economic value of three different configurations.</a:t>
-            </a:r>
-            <a:endParaRPr sz="1400" b="0" i="1" u="sng" dirty="0">
-              <a:solidFill>
-                <a:srgbClr val="52514E"/>
-              </a:solidFill>
-              <a:highlight>
-                <a:srgbClr val="FFFF00"/>
-              </a:highlight>
-              <a:latin typeface="Calibri"/>
-            </a:endParaRPr>
+              <a:t>Price basis: Real-Time (RT) prices used throughout — reflects the actual settlement value of energy at the time it is physically delivered.</a:t>
+            </a:r>
           </a:p>
         </p:txBody>
       </p:sp>
@@ -6586,7 +6475,6 @@
           <a:lstStyle/>
           <a:p>
             <a:pPr algn="ctr"/>
-            <a:endParaRPr/>
           </a:p>
         </p:txBody>
       </p:sp>
@@ -6607,7 +6495,7 @@
           <a:noFill/>
         </p:spPr>
         <p:txBody>
-          <a:bodyPr wrap="square" lIns="0" tIns="0" rIns="0" bIns="0" anchor="t">
+          <a:bodyPr wrap="square" anchor="t" lIns="0" rIns="0" tIns="0" bIns="0">
             <a:spAutoFit/>
           </a:bodyPr>
           <a:lstStyle/>
@@ -6641,7 +6529,7 @@
         <p:spPr>
           <a:xfrm>
             <a:off x="3246120" y="2103120"/>
-            <a:ext cx="8549640" cy="676660"/>
+            <a:ext cx="8549640" cy="1051560"/>
           </a:xfrm>
           <a:prstGeom prst="rect">
             <a:avLst/>
@@ -6649,7 +6537,7 @@
           <a:noFill/>
         </p:spPr>
         <p:txBody>
-          <a:bodyPr wrap="square" lIns="0" tIns="0" rIns="0" bIns="0" anchor="t">
+          <a:bodyPr wrap="square" anchor="t" lIns="0" rIns="0" tIns="0" bIns="0">
             <a:spAutoFit/>
           </a:bodyPr>
           <a:lstStyle/>
@@ -6663,96 +6551,14 @@
               </a:spcAft>
             </a:pPr>
             <a:r>
-              <a:rPr sz="1300" b="0" i="0" dirty="0">
+              <a:rPr sz="1300" b="0" i="0">
                 <a:solidFill>
                   <a:srgbClr val="52514E"/>
                 </a:solidFill>
                 <a:latin typeface="Calibri"/>
               </a:rPr>
-              <a:t>Delivered output = min(Solar Shape × 300 MW-DC, 250 MW-AC inverter limit). Revenue = </a:t>
-            </a:r>
-            <a:r>
-              <a:rPr sz="1300" b="0" i="0" dirty="0" err="1">
-                <a:solidFill>
-                  <a:srgbClr val="52514E"/>
-                </a:solidFill>
-                <a:latin typeface="Calibri"/>
-              </a:rPr>
-              <a:t>Σ</a:t>
-            </a:r>
-            <a:r>
-              <a:rPr sz="1300" b="0" i="0" dirty="0">
-                <a:solidFill>
-                  <a:srgbClr val="52514E"/>
-                </a:solidFill>
-                <a:latin typeface="Calibri"/>
-              </a:rPr>
-              <a:t>(delivered MW × </a:t>
-            </a:r>
-            <a:r>
-              <a:rPr sz="1300" b="0" i="0" dirty="0">
-                <a:solidFill>
-                  <a:srgbClr val="52514E"/>
-                </a:solidFill>
-                <a:highlight>
-                  <a:srgbClr val="FFFF00"/>
-                </a:highlight>
-                <a:latin typeface="Calibri"/>
-              </a:rPr>
-              <a:t>DA price</a:t>
-            </a:r>
-            <a:r>
-              <a:rPr sz="1300" b="0" i="0" dirty="0">
-                <a:solidFill>
-                  <a:srgbClr val="52514E"/>
-                </a:solidFill>
-                <a:latin typeface="Calibri"/>
-              </a:rPr>
-              <a:t>).</a:t>
-            </a:r>
-            <a:r>
-              <a:rPr lang="en-US" sz="1300" b="0" i="0" dirty="0">
-                <a:solidFill>
-                  <a:srgbClr val="52514E"/>
-                </a:solidFill>
-                <a:latin typeface="Calibri"/>
-              </a:rPr>
-              <a:t> RT price</a:t>
-            </a:r>
-          </a:p>
-          <a:p>
-            <a:pPr marL="285750" indent="-285750">
-              <a:lnSpc>
-                <a:spcPct val="115000"/>
-              </a:lnSpc>
-              <a:buFont typeface="Arial" panose="020B0604020202020204" pitchFamily="34" charset="0"/>
-              <a:buChar char="•"/>
-            </a:pPr>
-            <a:r>
-              <a:rPr lang="en-US" sz="1300" dirty="0">
-                <a:solidFill>
-                  <a:srgbClr val="52514E"/>
-                </a:solidFill>
-                <a:latin typeface="Calibri"/>
-              </a:rPr>
-              <a:t>Foot-room (additional revenue)</a:t>
-            </a:r>
-          </a:p>
-          <a:p>
-            <a:pPr algn="l">
-              <a:lnSpc>
-                <a:spcPct val="115000"/>
-              </a:lnSpc>
-              <a:spcAft>
-                <a:spcPts val="0"/>
-              </a:spcAft>
-            </a:pPr>
-            <a:endParaRPr lang="en-US" sz="1300" dirty="0">
-              <a:solidFill>
-                <a:srgbClr val="52514E"/>
-              </a:solidFill>
-              <a:latin typeface="Calibri"/>
-            </a:endParaRPr>
+              <a:t>Delivered output = min(Solar Shape × 300 MW-DC, 250 MW-AC inverter limit). Revenue = Σ(delivered MW × RT price).</a:t>
+            </a:r>
           </a:p>
         </p:txBody>
       </p:sp>
@@ -6797,7 +6603,6 @@
           <a:lstStyle/>
           <a:p>
             <a:pPr algn="ctr"/>
-            <a:endParaRPr/>
           </a:p>
         </p:txBody>
       </p:sp>
@@ -6818,7 +6623,7 @@
           <a:noFill/>
         </p:spPr>
         <p:txBody>
-          <a:bodyPr wrap="square" lIns="0" tIns="0" rIns="0" bIns="0" anchor="t">
+          <a:bodyPr wrap="square" anchor="t" lIns="0" rIns="0" tIns="0" bIns="0">
             <a:spAutoFit/>
           </a:bodyPr>
           <a:lstStyle/>
@@ -6852,7 +6657,7 @@
         <p:spPr>
           <a:xfrm>
             <a:off x="3246120" y="3337560"/>
-            <a:ext cx="8549640" cy="1136786"/>
+            <a:ext cx="8549640" cy="1051560"/>
           </a:xfrm>
           <a:prstGeom prst="rect">
             <a:avLst/>
@@ -6860,7 +6665,7 @@
           <a:noFill/>
         </p:spPr>
         <p:txBody>
-          <a:bodyPr wrap="square" lIns="0" tIns="0" rIns="0" bIns="0" anchor="t">
+          <a:bodyPr wrap="square" anchor="t" lIns="0" rIns="0" tIns="0" bIns="0">
             <a:spAutoFit/>
           </a:bodyPr>
           <a:lstStyle/>
@@ -6874,95 +6679,14 @@
               </a:spcAft>
             </a:pPr>
             <a:r>
-              <a:rPr sz="1300" b="0" i="0" dirty="0">
+              <a:rPr sz="1300" b="0" i="0">
                 <a:solidFill>
                   <a:srgbClr val="52514E"/>
                 </a:solidFill>
                 <a:latin typeface="Calibri"/>
               </a:rPr>
-              <a:t>4-hr duration (200 MWh ÷ 50 MW). 1 full cycle/day: charge the day's 4 lowest-price hours, discharge the 4 highest-price hours. Perfect </a:t>
-            </a:r>
-            <a:r>
-              <a:rPr lang="en-US" sz="1300" b="0" i="0" dirty="0">
-                <a:solidFill>
-                  <a:srgbClr val="52514E"/>
-                </a:solidFill>
-                <a:highlight>
-                  <a:srgbClr val="FFFF00"/>
-                </a:highlight>
-                <a:latin typeface="Calibri"/>
-              </a:rPr>
-              <a:t>real-time (day-ahead)</a:t>
-            </a:r>
-            <a:r>
-              <a:rPr sz="1300" b="0" i="0" dirty="0">
-                <a:solidFill>
-                  <a:srgbClr val="52514E"/>
-                </a:solidFill>
-                <a:highlight>
-                  <a:srgbClr val="FFFF00"/>
-                </a:highlight>
-                <a:latin typeface="Calibri"/>
-              </a:rPr>
-              <a:t> </a:t>
-            </a:r>
-            <a:r>
-              <a:rPr sz="1300" b="0" i="0" dirty="0">
-                <a:solidFill>
-                  <a:srgbClr val="52514E"/>
-                </a:solidFill>
-                <a:latin typeface="Calibri"/>
-              </a:rPr>
-              <a:t>price foresight; round-trip efficiency = 100% (per given input); no degradation or cycling cost; energy arbitrage only (no capacity/ancillary revenue).</a:t>
-            </a:r>
-            <a:r>
-              <a:rPr lang="en-US" sz="1300" b="0" i="0" dirty="0">
-                <a:solidFill>
-                  <a:srgbClr val="52514E"/>
-                </a:solidFill>
-                <a:latin typeface="Calibri"/>
-              </a:rPr>
-              <a:t> </a:t>
-            </a:r>
-          </a:p>
-          <a:p>
-            <a:pPr marL="285750" indent="-285750" algn="l">
-              <a:lnSpc>
-                <a:spcPct val="115000"/>
-              </a:lnSpc>
-              <a:spcAft>
-                <a:spcPts val="0"/>
-              </a:spcAft>
-              <a:buFont typeface="Arial" panose="020B0604020202020204" pitchFamily="34" charset="0"/>
-              <a:buChar char="•"/>
-            </a:pPr>
-            <a:r>
-              <a:rPr lang="en-US" sz="1300" dirty="0">
-                <a:solidFill>
-                  <a:srgbClr val="52514E"/>
-                </a:solidFill>
-                <a:latin typeface="Calibri"/>
-              </a:rPr>
-              <a:t>Head-room and foot-room (additional revenue)</a:t>
-            </a:r>
-          </a:p>
-          <a:p>
-            <a:pPr marL="285750" indent="-285750" algn="l">
-              <a:lnSpc>
-                <a:spcPct val="115000"/>
-              </a:lnSpc>
-              <a:spcAft>
-                <a:spcPts val="0"/>
-              </a:spcAft>
-              <a:buFont typeface="Arial" panose="020B0604020202020204" pitchFamily="34" charset="0"/>
-              <a:buChar char="•"/>
-            </a:pPr>
-            <a:endParaRPr lang="en-US" sz="1300" dirty="0">
-              <a:solidFill>
-                <a:srgbClr val="52514E"/>
-              </a:solidFill>
-              <a:latin typeface="Calibri"/>
-            </a:endParaRPr>
+              <a:t>4-hr duration (200 MWh ÷ 50 MW). 1 full cycle/day: charge the day's 4 lowest-price hours, discharge the 4 highest-price hours. Perfect real-time price foresight; round-trip efficiency = 100% (per given input); no degradation or cycling cost; energy arbitrage only (no capacity/ancillary revenue).</a:t>
+            </a:r>
           </a:p>
         </p:txBody>
       </p:sp>
@@ -7007,7 +6731,6 @@
           <a:lstStyle/>
           <a:p>
             <a:pPr algn="ctr"/>
-            <a:endParaRPr/>
           </a:p>
         </p:txBody>
       </p:sp>
@@ -7028,7 +6751,7 @@
           <a:noFill/>
         </p:spPr>
         <p:txBody>
-          <a:bodyPr wrap="square" lIns="0" tIns="0" rIns="0" bIns="0" anchor="t">
+          <a:bodyPr wrap="square" anchor="t" lIns="0" rIns="0" tIns="0" bIns="0">
             <a:spAutoFit/>
           </a:bodyPr>
           <a:lstStyle/>
@@ -7062,7 +6785,7 @@
         <p:spPr>
           <a:xfrm>
             <a:off x="3246120" y="4572000"/>
-            <a:ext cx="8549640" cy="1136786"/>
+            <a:ext cx="8549640" cy="1051560"/>
           </a:xfrm>
           <a:prstGeom prst="rect">
             <a:avLst/>
@@ -7070,7 +6793,7 @@
           <a:noFill/>
         </p:spPr>
         <p:txBody>
-          <a:bodyPr wrap="square" lIns="0" tIns="0" rIns="0" bIns="0" anchor="t">
+          <a:bodyPr wrap="square" anchor="t" lIns="0" rIns="0" tIns="0" bIns="0">
             <a:spAutoFit/>
           </a:bodyPr>
           <a:lstStyle/>
@@ -7084,88 +6807,14 @@
               </a:spcAft>
             </a:pPr>
             <a:r>
-              <a:rPr sz="1300" b="0" i="0" dirty="0">
+              <a:rPr sz="1300" b="0" i="0">
                 <a:solidFill>
                   <a:srgbClr val="52514E"/>
                 </a:solidFill>
                 <a:latin typeface="Calibri"/>
               </a:rPr>
-              <a:t>Solar identical to standalone. Storage charges first from </a:t>
-            </a:r>
-            <a:r>
-              <a:rPr lang="en-US" sz="1300" b="0" i="0" dirty="0">
-                <a:solidFill>
-                  <a:srgbClr val="52514E"/>
-                </a:solidFill>
-                <a:latin typeface="Calibri"/>
-              </a:rPr>
-              <a:t>curtailed solar, </a:t>
-            </a:r>
-            <a:r>
-              <a:rPr sz="1300" b="0" i="0" dirty="0">
-                <a:solidFill>
-                  <a:srgbClr val="52514E"/>
-                </a:solidFill>
-                <a:latin typeface="Calibri"/>
-              </a:rPr>
-              <a:t>then tops up from the grid at the day's lowest remaining prices; discharge unchanged.</a:t>
-            </a:r>
-            <a:endParaRPr lang="en-US" sz="1300" b="0" i="0" dirty="0">
-              <a:solidFill>
-                <a:srgbClr val="52514E"/>
-              </a:solidFill>
-              <a:latin typeface="Calibri"/>
-            </a:endParaRPr>
-          </a:p>
-          <a:p>
-            <a:pPr marL="285750" indent="-285750">
-              <a:lnSpc>
-                <a:spcPct val="115000"/>
-              </a:lnSpc>
-              <a:buFont typeface="Arial" panose="020B0604020202020204" pitchFamily="34" charset="0"/>
-              <a:buChar char="•"/>
-            </a:pPr>
-            <a:r>
-              <a:rPr lang="en-US" sz="1300" dirty="0">
-                <a:solidFill>
-                  <a:srgbClr val="52514E"/>
-                </a:solidFill>
-                <a:latin typeface="Calibri"/>
-              </a:rPr>
-              <a:t>Head-room and foot-room (additional revenue)</a:t>
-            </a:r>
-          </a:p>
-          <a:p>
-            <a:pPr algn="l">
-              <a:lnSpc>
-                <a:spcPct val="115000"/>
-              </a:lnSpc>
-              <a:spcAft>
-                <a:spcPts val="0"/>
-              </a:spcAft>
-            </a:pPr>
-            <a:endParaRPr lang="en-US" sz="1300" dirty="0">
-              <a:solidFill>
-                <a:srgbClr val="52514E"/>
-              </a:solidFill>
-              <a:latin typeface="Calibri"/>
-            </a:endParaRPr>
-          </a:p>
-          <a:p>
-            <a:pPr algn="l">
-              <a:lnSpc>
-                <a:spcPct val="115000"/>
-              </a:lnSpc>
-              <a:spcAft>
-                <a:spcPts val="0"/>
-              </a:spcAft>
-            </a:pPr>
-            <a:endParaRPr sz="1300" b="0" i="0" dirty="0">
-              <a:solidFill>
-                <a:srgbClr val="52514E"/>
-              </a:solidFill>
-              <a:latin typeface="Calibri"/>
-            </a:endParaRPr>
+              <a:t>Solar identical to standalone. Storage charges first from otherwise-clipped/curtailed solar (zero cost), then tops up from the grid at the day's lowest remaining prices; discharge unchanged.</a:t>
+            </a:r>
           </a:p>
         </p:txBody>
       </p:sp>
@@ -7210,7 +6859,6 @@
           <a:lstStyle/>
           <a:p>
             <a:pPr algn="ctr"/>
-            <a:endParaRPr/>
           </a:p>
         </p:txBody>
       </p:sp>
@@ -7231,7 +6879,7 @@
           <a:noFill/>
         </p:spPr>
         <p:txBody>
-          <a:bodyPr wrap="square" lIns="0" tIns="0" rIns="0" bIns="0" anchor="t">
+          <a:bodyPr wrap="square" anchor="t" lIns="0" rIns="0" tIns="0" bIns="0">
             <a:spAutoFit/>
           </a:bodyPr>
           <a:lstStyle/>
@@ -7265,7 +6913,7 @@
 </file>
 
 <file path=ppt/slides/slide6.xml><?xml version="1.0" encoding="utf-8"?>
-<p:sld xmlns:a="http://schemas.openxmlformats.org/drawingml/2006/main" xmlns:r="http://schemas.openxmlformats.org/officeDocument/2006/relationships" xmlns:p="http://schemas.openxmlformats.org/presentationml/2006/main">
+<p:sld xmlns:a="http://schemas.openxmlformats.org/drawingml/2006/main" xmlns:p="http://schemas.openxmlformats.org/presentationml/2006/main" xmlns:r="http://schemas.openxmlformats.org/officeDocument/2006/relationships">
   <p:cSld>
     <p:bg>
       <p:bgPr>
@@ -7281,14 +6929,7 @@
         <p:cNvGrpSpPr/>
         <p:nvPr/>
       </p:nvGrpSpPr>
-      <p:grpSpPr>
-        <a:xfrm>
-          <a:off x="0" y="0"/>
-          <a:ext cx="0" cy="0"/>
-          <a:chOff x="0" y="0"/>
-          <a:chExt cx="0" cy="0"/>
-        </a:xfrm>
-      </p:grpSpPr>
+      <p:grpSpPr/>
       <p:sp>
         <p:nvSpPr>
           <p:cNvPr id="2" name="Rectangle 1"/>
@@ -7330,7 +6971,6 @@
           <a:lstStyle/>
           <a:p>
             <a:pPr algn="ctr"/>
-            <a:endParaRPr/>
           </a:p>
         </p:txBody>
       </p:sp>
@@ -7351,7 +6991,7 @@
           <a:noFill/>
         </p:spPr>
         <p:txBody>
-          <a:bodyPr wrap="square" lIns="0" tIns="0" rIns="0" bIns="0" anchor="t">
+          <a:bodyPr wrap="square" anchor="t" lIns="0" rIns="0" tIns="0" bIns="0">
             <a:spAutoFit/>
           </a:bodyPr>
           <a:lstStyle/>
@@ -7393,7 +7033,7 @@
           <a:noFill/>
         </p:spPr>
         <p:txBody>
-          <a:bodyPr wrap="square" lIns="0" tIns="0" rIns="0" bIns="0" anchor="t">
+          <a:bodyPr wrap="square" anchor="t" lIns="0" rIns="0" tIns="0" bIns="0">
             <a:spAutoFit/>
           </a:bodyPr>
           <a:lstStyle/>
@@ -7459,7 +7099,6 @@
           <a:lstStyle/>
           <a:p>
             <a:pPr algn="ctr"/>
-            <a:endParaRPr/>
           </a:p>
         </p:txBody>
       </p:sp>
@@ -7480,7 +7119,7 @@
           <a:noFill/>
         </p:spPr>
         <p:txBody>
-          <a:bodyPr wrap="square" lIns="0" tIns="0" rIns="0" bIns="0" anchor="t">
+          <a:bodyPr wrap="square" anchor="t" lIns="0" rIns="0" tIns="0" bIns="0">
             <a:spAutoFit/>
           </a:bodyPr>
           <a:lstStyle/>
@@ -7522,7 +7161,7 @@
           <a:noFill/>
         </p:spPr>
         <p:txBody>
-          <a:bodyPr wrap="square" lIns="0" tIns="0" rIns="0" bIns="0" anchor="t">
+          <a:bodyPr wrap="square" anchor="t" lIns="0" rIns="0" tIns="0" bIns="0">
             <a:spAutoFit/>
           </a:bodyPr>
           <a:lstStyle/>
@@ -7588,7 +7227,7 @@
           <a:noFill/>
         </p:spPr>
         <p:txBody>
-          <a:bodyPr wrap="square" lIns="0" tIns="0" rIns="0" bIns="0">
+          <a:bodyPr wrap="square" lIns="0" rIns="0" tIns="0" bIns="0">
             <a:spAutoFit/>
           </a:bodyPr>
           <a:lstStyle/>
@@ -7608,7 +7247,7 @@
                 </a:solidFill>
                 <a:latin typeface="Calibri"/>
               </a:rPr>
-              <a:t>—  Standalone Solar: $18.80M (551,454 MWh delivered; avg. capture price $34.10/MWh).</a:t>
+              <a:t>—  Standalone Solar: $18.91M (551,454 MWh delivered; avg. capture price $34.29/MWh).</a:t>
             </a:r>
           </a:p>
           <a:p>
@@ -7627,7 +7266,7 @@
                 </a:solidFill>
                 <a:latin typeface="Calibri"/>
               </a:rPr>
-              <a:t>—  Standalone Storage: $1.72M ($34.47/kW-yr, $8.62/kWh-yr) — energy arbitrage only.</a:t>
+              <a:t>—  Standalone Storage: $2.47M ($49.48/kW-yr, $12.37/kWh-yr) — energy arbitrage only.</a:t>
             </a:r>
           </a:p>
           <a:p>
@@ -7646,7 +7285,7 @@
                 </a:solidFill>
                 <a:latin typeface="Calibri"/>
               </a:rPr>
-              <a:t>—  Combined System: $20.54M — essentially the sum of the two standalone revenues.</a:t>
+              <a:t>—  Combined System: $21.39M — essentially the sum of the two standalone revenues.</a:t>
             </a:r>
           </a:p>
           <a:p>
@@ -7679,7 +7318,7 @@
 </file>
 
 <file path=ppt/slides/slide7.xml><?xml version="1.0" encoding="utf-8"?>
-<p:sld xmlns:a="http://schemas.openxmlformats.org/drawingml/2006/main" xmlns:r="http://schemas.openxmlformats.org/officeDocument/2006/relationships" xmlns:p="http://schemas.openxmlformats.org/presentationml/2006/main">
+<p:sld xmlns:a="http://schemas.openxmlformats.org/drawingml/2006/main" xmlns:p="http://schemas.openxmlformats.org/presentationml/2006/main" xmlns:r="http://schemas.openxmlformats.org/officeDocument/2006/relationships">
   <p:cSld>
     <p:bg>
       <p:bgPr>
@@ -7695,14 +7334,7 @@
         <p:cNvGrpSpPr/>
         <p:nvPr/>
       </p:nvGrpSpPr>
-      <p:grpSpPr>
-        <a:xfrm>
-          <a:off x="0" y="0"/>
-          <a:ext cx="0" cy="0"/>
-          <a:chOff x="0" y="0"/>
-          <a:chExt cx="0" cy="0"/>
-        </a:xfrm>
-      </p:grpSpPr>
+      <p:grpSpPr/>
       <p:sp>
         <p:nvSpPr>
           <p:cNvPr id="2" name="Rectangle 1"/>
@@ -7744,7 +7376,6 @@
           <a:lstStyle/>
           <a:p>
             <a:pPr algn="ctr"/>
-            <a:endParaRPr/>
           </a:p>
         </p:txBody>
       </p:sp>
@@ -7765,7 +7396,7 @@
           <a:noFill/>
         </p:spPr>
         <p:txBody>
-          <a:bodyPr wrap="square" lIns="0" tIns="0" rIns="0" bIns="0" anchor="t">
+          <a:bodyPr wrap="square" anchor="t" lIns="0" rIns="0" tIns="0" bIns="0">
             <a:spAutoFit/>
           </a:bodyPr>
           <a:lstStyle/>
@@ -7807,7 +7438,7 @@
           <a:noFill/>
         </p:spPr>
         <p:txBody>
-          <a:bodyPr wrap="square" lIns="0" tIns="0" rIns="0" bIns="0" anchor="t">
+          <a:bodyPr wrap="square" anchor="t" lIns="0" rIns="0" tIns="0" bIns="0">
             <a:spAutoFit/>
           </a:bodyPr>
           <a:lstStyle/>
@@ -7873,7 +7504,6 @@
           <a:lstStyle/>
           <a:p>
             <a:pPr algn="ctr"/>
-            <a:endParaRPr/>
           </a:p>
         </p:txBody>
       </p:sp>
@@ -7894,7 +7524,7 @@
           <a:noFill/>
         </p:spPr>
         <p:txBody>
-          <a:bodyPr wrap="square" lIns="0" tIns="0" rIns="0" bIns="0" anchor="t">
+          <a:bodyPr wrap="square" anchor="t" lIns="0" rIns="0" tIns="0" bIns="0">
             <a:spAutoFit/>
           </a:bodyPr>
           <a:lstStyle/>
@@ -7936,7 +7566,7 @@
           <a:noFill/>
         </p:spPr>
         <p:txBody>
-          <a:bodyPr wrap="square" lIns="0" tIns="0" rIns="0" bIns="0" anchor="t">
+          <a:bodyPr wrap="square" anchor="t" lIns="0" rIns="0" tIns="0" bIns="0">
             <a:spAutoFit/>
           </a:bodyPr>
           <a:lstStyle/>
@@ -7978,7 +7608,7 @@
           <a:noFill/>
         </p:spPr>
         <p:txBody>
-          <a:bodyPr wrap="square" lIns="0" tIns="0" rIns="0" bIns="0">
+          <a:bodyPr wrap="square" lIns="0" rIns="0" tIns="0" bIns="0">
             <a:spAutoFit/>
           </a:bodyPr>
           <a:lstStyle/>
@@ -8036,7 +7666,7 @@
                 </a:solidFill>
                 <a:latin typeface="Calibri"/>
               </a:rPr>
-              <a:t>—  Combined revenue ($20,535,198) exceeds the simple sum of standalone solar + standalone storage ($20,527,496) by just $7,701 (+0.04%).</a:t>
+              <a:t>—  Combined revenue ($21,391,036) exceeds the simple sum of standalone solar + standalone storage ($21,384,178) by just $6,857 (+0.03%).</a:t>
             </a:r>
           </a:p>
         </p:txBody>
@@ -8084,7 +7714,6 @@
           <a:lstStyle/>
           <a:p>
             <a:pPr algn="ctr"/>
-            <a:endParaRPr/>
           </a:p>
         </p:txBody>
       </p:sp>
@@ -8105,7 +7734,7 @@
           <a:noFill/>
         </p:spPr>
         <p:txBody>
-          <a:bodyPr wrap="square" lIns="0" tIns="0" rIns="0" bIns="0" anchor="t">
+          <a:bodyPr wrap="square" anchor="t" lIns="0" rIns="0" tIns="0" bIns="0">
             <a:spAutoFit/>
           </a:bodyPr>
           <a:lstStyle/>
@@ -8147,7 +7776,7 @@
           <a:noFill/>
         </p:spPr>
         <p:txBody>
-          <a:bodyPr wrap="square" lIns="0" tIns="0" rIns="0" bIns="0" anchor="t">
+          <a:bodyPr wrap="square" anchor="t" lIns="0" rIns="0" tIns="0" bIns="0">
             <a:spAutoFit/>
           </a:bodyPr>
           <a:lstStyle/>
@@ -8179,12 +7808,15 @@
                 <a:spcPts val="0"/>
               </a:spcAft>
             </a:pPr>
-            <a:endParaRPr sz="1400" b="0" i="0">
-              <a:solidFill>
-                <a:srgbClr val="52514E"/>
-              </a:solidFill>
-              <a:latin typeface="Calibri"/>
-            </a:endParaRPr>
+            <a:r>
+              <a:rPr sz="1400" b="0" i="0">
+                <a:solidFill>
+                  <a:srgbClr val="52514E"/>
+                </a:solidFill>
+                <a:latin typeface="Calibri"/>
+              </a:rPr>
+              <a:t/>
+            </a:r>
           </a:p>
           <a:p>
             <a:pPr algn="l">
@@ -8224,7 +7856,7 @@
           <a:noFill/>
         </p:spPr>
         <p:txBody>
-          <a:bodyPr wrap="square" lIns="0" tIns="0" rIns="0" bIns="0" anchor="t">
+          <a:bodyPr wrap="square" anchor="t" lIns="0" rIns="0" tIns="0" bIns="0">
             <a:spAutoFit/>
           </a:bodyPr>
           <a:lstStyle/>
@@ -8258,7 +7890,7 @@
 </file>
 
 <file path=ppt/slides/slide8.xml><?xml version="1.0" encoding="utf-8"?>
-<p:sld xmlns:a="http://schemas.openxmlformats.org/drawingml/2006/main" xmlns:r="http://schemas.openxmlformats.org/officeDocument/2006/relationships" xmlns:p="http://schemas.openxmlformats.org/presentationml/2006/main">
+<p:sld xmlns:a="http://schemas.openxmlformats.org/drawingml/2006/main" xmlns:p="http://schemas.openxmlformats.org/presentationml/2006/main" xmlns:r="http://schemas.openxmlformats.org/officeDocument/2006/relationships">
   <p:cSld>
     <p:bg>
       <p:bgPr>
@@ -8274,14 +7906,7 @@
         <p:cNvGrpSpPr/>
         <p:nvPr/>
       </p:nvGrpSpPr>
-      <p:grpSpPr>
-        <a:xfrm>
-          <a:off x="0" y="0"/>
-          <a:ext cx="0" cy="0"/>
-          <a:chOff x="0" y="0"/>
-          <a:chExt cx="0" cy="0"/>
-        </a:xfrm>
-      </p:grpSpPr>
+      <p:grpSpPr/>
       <p:sp>
         <p:nvSpPr>
           <p:cNvPr id="2" name="Rectangle 1"/>
@@ -8323,7 +7948,6 @@
           <a:lstStyle/>
           <a:p>
             <a:pPr algn="ctr"/>
-            <a:endParaRPr/>
           </a:p>
         </p:txBody>
       </p:sp>
@@ -8344,7 +7968,7 @@
           <a:noFill/>
         </p:spPr>
         <p:txBody>
-          <a:bodyPr wrap="square" lIns="0" tIns="0" rIns="0" bIns="0" anchor="t">
+          <a:bodyPr wrap="square" anchor="t" lIns="0" rIns="0" tIns="0" bIns="0">
             <a:spAutoFit/>
           </a:bodyPr>
           <a:lstStyle/>
@@ -8386,7 +8010,7 @@
           <a:noFill/>
         </p:spPr>
         <p:txBody>
-          <a:bodyPr wrap="square" lIns="0" tIns="0" rIns="0" bIns="0" anchor="t">
+          <a:bodyPr wrap="square" anchor="t" lIns="0" rIns="0" tIns="0" bIns="0">
             <a:spAutoFit/>
           </a:bodyPr>
           <a:lstStyle/>
@@ -8452,7 +8076,6 @@
           <a:lstStyle/>
           <a:p>
             <a:pPr algn="ctr"/>
-            <a:endParaRPr/>
           </a:p>
         </p:txBody>
       </p:sp>
@@ -8473,7 +8096,7 @@
           <a:noFill/>
         </p:spPr>
         <p:txBody>
-          <a:bodyPr wrap="square" lIns="0" tIns="0" rIns="0" bIns="0" anchor="t">
+          <a:bodyPr wrap="square" anchor="t" lIns="0" rIns="0" tIns="0" bIns="0">
             <a:spAutoFit/>
           </a:bodyPr>
           <a:lstStyle/>
@@ -8515,7 +8138,7 @@
           <a:noFill/>
         </p:spPr>
         <p:txBody>
-          <a:bodyPr wrap="square" lIns="0" tIns="0" rIns="0" bIns="0" anchor="t">
+          <a:bodyPr wrap="square" anchor="t" lIns="0" rIns="0" tIns="0" bIns="0">
             <a:spAutoFit/>
           </a:bodyPr>
           <a:lstStyle/>
@@ -8581,7 +8204,6 @@
           <a:lstStyle/>
           <a:p>
             <a:pPr algn="ctr"/>
-            <a:endParaRPr/>
           </a:p>
         </p:txBody>
       </p:sp>
@@ -8602,7 +8224,7 @@
           <a:noFill/>
         </p:spPr>
         <p:txBody>
-          <a:bodyPr wrap="square" lIns="0" tIns="0" rIns="0" bIns="0" anchor="t">
+          <a:bodyPr wrap="square" anchor="t" lIns="0" rIns="0" tIns="0" bIns="0">
             <a:spAutoFit/>
           </a:bodyPr>
           <a:lstStyle/>
@@ -8644,7 +8266,7 @@
           <a:noFill/>
         </p:spPr>
         <p:txBody>
-          <a:bodyPr wrap="square" lIns="0" tIns="0" rIns="0" bIns="0" anchor="t">
+          <a:bodyPr wrap="square" anchor="t" lIns="0" rIns="0" tIns="0" bIns="0">
             <a:spAutoFit/>
           </a:bodyPr>
           <a:lstStyle/>
@@ -8686,7 +8308,7 @@
           <a:noFill/>
         </p:spPr>
         <p:txBody>
-          <a:bodyPr wrap="square" lIns="0" tIns="0" rIns="0" bIns="0">
+          <a:bodyPr wrap="square" lIns="0" rIns="0" tIns="0" bIns="0">
             <a:spAutoFit/>
           </a:bodyPr>
           <a:lstStyle/>
@@ -8771,7 +8393,6 @@
           <a:lstStyle/>
           <a:p>
             <a:pPr algn="ctr"/>
-            <a:endParaRPr/>
           </a:p>
         </p:txBody>
       </p:sp>
@@ -8792,7 +8413,7 @@
           <a:noFill/>
         </p:spPr>
         <p:txBody>
-          <a:bodyPr wrap="square" lIns="0" tIns="0" rIns="0" bIns="0" anchor="t">
+          <a:bodyPr wrap="square" anchor="t" lIns="0" rIns="0" tIns="0" bIns="0">
             <a:spAutoFit/>
           </a:bodyPr>
           <a:lstStyle/>
@@ -8834,7 +8455,7 @@
           <a:noFill/>
         </p:spPr>
         <p:txBody>
-          <a:bodyPr wrap="square" lIns="0" tIns="0" rIns="0" bIns="0" anchor="t">
+          <a:bodyPr wrap="square" anchor="t" lIns="0" rIns="0" tIns="0" bIns="0">
             <a:spAutoFit/>
           </a:bodyPr>
           <a:lstStyle/>
@@ -8876,7 +8497,7 @@
           <a:noFill/>
         </p:spPr>
         <p:txBody>
-          <a:bodyPr wrap="square" lIns="0" tIns="0" rIns="0" bIns="0">
+          <a:bodyPr wrap="square" lIns="0" rIns="0" tIns="0" bIns="0">
             <a:spAutoFit/>
           </a:bodyPr>
           <a:lstStyle/>
@@ -8961,7 +8582,6 @@
           <a:lstStyle/>
           <a:p>
             <a:pPr algn="ctr"/>
-            <a:endParaRPr/>
           </a:p>
         </p:txBody>
       </p:sp>
@@ -8982,7 +8602,7 @@
           <a:noFill/>
         </p:spPr>
         <p:txBody>
-          <a:bodyPr wrap="square" lIns="0" tIns="0" rIns="0" bIns="0" anchor="t">
+          <a:bodyPr wrap="square" anchor="t" lIns="0" rIns="0" tIns="0" bIns="0">
             <a:spAutoFit/>
           </a:bodyPr>
           <a:lstStyle/>
@@ -9024,7 +8644,7 @@
           <a:noFill/>
         </p:spPr>
         <p:txBody>
-          <a:bodyPr wrap="square" lIns="0" tIns="0" rIns="0" bIns="0" anchor="t">
+          <a:bodyPr wrap="square" anchor="t" lIns="0" rIns="0" tIns="0" bIns="0">
             <a:spAutoFit/>
           </a:bodyPr>
           <a:lstStyle/>
@@ -9066,7 +8686,7 @@
           <a:noFill/>
         </p:spPr>
         <p:txBody>
-          <a:bodyPr wrap="square" lIns="0" tIns="0" rIns="0" bIns="0">
+          <a:bodyPr wrap="square" lIns="0" rIns="0" tIns="0" bIns="0">
             <a:spAutoFit/>
           </a:bodyPr>
           <a:lstStyle/>
@@ -9086,7 +8706,7 @@
                 </a:solidFill>
                 <a:latin typeface="Calibri"/>
               </a:rPr>
-              <a:t>—  Today's interaction (+0.04%) reflects minimal clipping.</a:t>
+              <a:t>—  Today's interaction (+0.03%) reflects minimal clipping.</a:t>
             </a:r>
           </a:p>
           <a:p>
@@ -9119,7 +8739,7 @@
 </file>
 
 <file path=ppt/slides/slide9.xml><?xml version="1.0" encoding="utf-8"?>
-<p:sld xmlns:a="http://schemas.openxmlformats.org/drawingml/2006/main" xmlns:r="http://schemas.openxmlformats.org/officeDocument/2006/relationships" xmlns:p="http://schemas.openxmlformats.org/presentationml/2006/main">
+<p:sld xmlns:a="http://schemas.openxmlformats.org/drawingml/2006/main" xmlns:p="http://schemas.openxmlformats.org/presentationml/2006/main" xmlns:r="http://schemas.openxmlformats.org/officeDocument/2006/relationships">
   <p:cSld>
     <p:bg>
       <p:bgPr>
@@ -9135,14 +8755,7 @@
         <p:cNvGrpSpPr/>
         <p:nvPr/>
       </p:nvGrpSpPr>
-      <p:grpSpPr>
-        <a:xfrm>
-          <a:off x="0" y="0"/>
-          <a:ext cx="0" cy="0"/>
-          <a:chOff x="0" y="0"/>
-          <a:chExt cx="0" cy="0"/>
-        </a:xfrm>
-      </p:grpSpPr>
+      <p:grpSpPr/>
       <p:sp>
         <p:nvSpPr>
           <p:cNvPr id="2" name="Rectangle 1"/>
@@ -9184,7 +8797,6 @@
           <a:lstStyle/>
           <a:p>
             <a:pPr algn="ctr"/>
-            <a:endParaRPr/>
           </a:p>
         </p:txBody>
       </p:sp>
@@ -9205,7 +8817,7 @@
           <a:noFill/>
         </p:spPr>
         <p:txBody>
-          <a:bodyPr wrap="square" lIns="0" tIns="0" rIns="0" bIns="0" anchor="t">
+          <a:bodyPr wrap="square" anchor="t" lIns="0" rIns="0" tIns="0" bIns="0">
             <a:spAutoFit/>
           </a:bodyPr>
           <a:lstStyle/>
@@ -9247,7 +8859,7 @@
           <a:noFill/>
         </p:spPr>
         <p:txBody>
-          <a:bodyPr wrap="square" lIns="0" tIns="0" rIns="0" bIns="0" anchor="t">
+          <a:bodyPr wrap="square" anchor="t" lIns="0" rIns="0" tIns="0" bIns="0">
             <a:spAutoFit/>
           </a:bodyPr>
           <a:lstStyle/>
@@ -9313,7 +8925,6 @@
           <a:lstStyle/>
           <a:p>
             <a:pPr algn="ctr"/>
-            <a:endParaRPr/>
           </a:p>
         </p:txBody>
       </p:sp>
@@ -9334,7 +8945,7 @@
           <a:noFill/>
         </p:spPr>
         <p:txBody>
-          <a:bodyPr wrap="square" lIns="0" tIns="0" rIns="0" bIns="0" anchor="t">
+          <a:bodyPr wrap="square" anchor="t" lIns="0" rIns="0" tIns="0" bIns="0">
             <a:spAutoFit/>
           </a:bodyPr>
           <a:lstStyle/>
@@ -9376,7 +8987,7 @@
           <a:noFill/>
         </p:spPr>
         <p:txBody>
-          <a:bodyPr wrap="square" lIns="0" tIns="0" rIns="0" bIns="0" anchor="t">
+          <a:bodyPr wrap="square" anchor="t" lIns="0" rIns="0" tIns="0" bIns="0">
             <a:spAutoFit/>
           </a:bodyPr>
           <a:lstStyle/>
@@ -9438,7 +9049,7 @@
           </a:fontRef>
         </p:style>
         <p:txBody>
-          <a:bodyPr wrap="none" rtlCol="0" anchor="ctr"/>
+          <a:bodyPr rtlCol="0" anchor="ctr" wrap="none"/>
           <a:lstStyle/>
           <a:p>
             <a:pPr algn="ctr"/>
@@ -9470,7 +9081,7 @@
           <a:noFill/>
         </p:spPr>
         <p:txBody>
-          <a:bodyPr wrap="square" lIns="0" tIns="0" rIns="0" bIns="0" anchor="t">
+          <a:bodyPr wrap="square" anchor="t" lIns="0" rIns="0" tIns="0" bIns="0">
             <a:spAutoFit/>
           </a:bodyPr>
           <a:lstStyle/>
@@ -9538,7 +9149,6 @@
           <a:lstStyle/>
           <a:p>
             <a:pPr algn="ctr"/>
-            <a:endParaRPr/>
           </a:p>
         </p:txBody>
       </p:sp>
@@ -9559,7 +9169,7 @@
           <a:noFill/>
         </p:spPr>
         <p:txBody>
-          <a:bodyPr wrap="square" lIns="0" tIns="0" rIns="0" bIns="0" anchor="t">
+          <a:bodyPr wrap="square" anchor="t" lIns="0" rIns="0" tIns="0" bIns="0">
             <a:spAutoFit/>
           </a:bodyPr>
           <a:lstStyle/>
@@ -9601,7 +9211,7 @@
           <a:noFill/>
         </p:spPr>
         <p:txBody>
-          <a:bodyPr wrap="square" lIns="0" tIns="0" rIns="0" bIns="0" anchor="t">
+          <a:bodyPr wrap="square" anchor="t" lIns="0" rIns="0" tIns="0" bIns="0">
             <a:spAutoFit/>
           </a:bodyPr>
           <a:lstStyle/>
@@ -9667,7 +9277,6 @@
           <a:lstStyle/>
           <a:p>
             <a:pPr algn="ctr"/>
-            <a:endParaRPr/>
           </a:p>
         </p:txBody>
       </p:sp>
@@ -9708,7 +9317,7 @@
           </a:fontRef>
         </p:style>
         <p:txBody>
-          <a:bodyPr wrap="none" rtlCol="0" anchor="ctr"/>
+          <a:bodyPr rtlCol="0" anchor="ctr" wrap="none"/>
           <a:lstStyle/>
           <a:p>
             <a:pPr algn="ctr"/>
@@ -9740,7 +9349,7 @@
           <a:noFill/>
         </p:spPr>
         <p:txBody>
-          <a:bodyPr wrap="square" lIns="0" tIns="0" rIns="0" bIns="0" anchor="t">
+          <a:bodyPr wrap="square" anchor="t" lIns="0" rIns="0" tIns="0" bIns="0">
             <a:spAutoFit/>
           </a:bodyPr>
           <a:lstStyle/>
@@ -9808,7 +9417,6 @@
           <a:lstStyle/>
           <a:p>
             <a:pPr algn="ctr"/>
-            <a:endParaRPr/>
           </a:p>
         </p:txBody>
       </p:sp>
@@ -9829,7 +9437,7 @@
           <a:noFill/>
         </p:spPr>
         <p:txBody>
-          <a:bodyPr wrap="square" lIns="0" tIns="0" rIns="0" bIns="0" anchor="t">
+          <a:bodyPr wrap="square" anchor="t" lIns="0" rIns="0" tIns="0" bIns="0">
             <a:spAutoFit/>
           </a:bodyPr>
           <a:lstStyle/>
@@ -9871,7 +9479,7 @@
           <a:noFill/>
         </p:spPr>
         <p:txBody>
-          <a:bodyPr wrap="square" lIns="0" tIns="0" rIns="0" bIns="0" anchor="t">
+          <a:bodyPr wrap="square" anchor="t" lIns="0" rIns="0" tIns="0" bIns="0">
             <a:spAutoFit/>
           </a:bodyPr>
           <a:lstStyle/>
@@ -9937,7 +9545,6 @@
           <a:lstStyle/>
           <a:p>
             <a:pPr algn="ctr"/>
-            <a:endParaRPr/>
           </a:p>
         </p:txBody>
       </p:sp>
@@ -9978,7 +9585,7 @@
           </a:fontRef>
         </p:style>
         <p:txBody>
-          <a:bodyPr wrap="none" rtlCol="0" anchor="ctr"/>
+          <a:bodyPr rtlCol="0" anchor="ctr" wrap="none"/>
           <a:lstStyle/>
           <a:p>
             <a:pPr algn="ctr"/>
@@ -10010,7 +9617,7 @@
           <a:noFill/>
         </p:spPr>
         <p:txBody>
-          <a:bodyPr wrap="square" lIns="0" tIns="0" rIns="0" bIns="0" anchor="t">
+          <a:bodyPr wrap="square" anchor="t" lIns="0" rIns="0" tIns="0" bIns="0">
             <a:spAutoFit/>
           </a:bodyPr>
           <a:lstStyle/>
@@ -10078,7 +9685,6 @@
           <a:lstStyle/>
           <a:p>
             <a:pPr algn="ctr"/>
-            <a:endParaRPr/>
           </a:p>
         </p:txBody>
       </p:sp>
@@ -10099,7 +9705,7 @@
           <a:noFill/>
         </p:spPr>
         <p:txBody>
-          <a:bodyPr wrap="square" lIns="0" tIns="0" rIns="0" bIns="0" anchor="t">
+          <a:bodyPr wrap="square" anchor="t" lIns="0" rIns="0" tIns="0" bIns="0">
             <a:spAutoFit/>
           </a:bodyPr>
           <a:lstStyle/>
@@ -10141,7 +9747,7 @@
           <a:noFill/>
         </p:spPr>
         <p:txBody>
-          <a:bodyPr wrap="square" lIns="0" tIns="0" rIns="0" bIns="0" anchor="t">
+          <a:bodyPr wrap="square" anchor="t" lIns="0" rIns="0" tIns="0" bIns="0">
             <a:spAutoFit/>
           </a:bodyPr>
           <a:lstStyle/>
@@ -10207,7 +9813,6 @@
           <a:lstStyle/>
           <a:p>
             <a:pPr algn="ctr"/>
-            <a:endParaRPr/>
           </a:p>
         </p:txBody>
       </p:sp>
@@ -10248,7 +9853,7 @@
           </a:fontRef>
         </p:style>
         <p:txBody>
-          <a:bodyPr wrap="none" rtlCol="0" anchor="ctr"/>
+          <a:bodyPr rtlCol="0" anchor="ctr" wrap="none"/>
           <a:lstStyle/>
           <a:p>
             <a:pPr algn="ctr"/>
@@ -10280,7 +9885,7 @@
           <a:noFill/>
         </p:spPr>
         <p:txBody>
-          <a:bodyPr wrap="square" lIns="0" tIns="0" rIns="0" bIns="0" anchor="t">
+          <a:bodyPr wrap="square" anchor="t" lIns="0" rIns="0" tIns="0" bIns="0">
             <a:spAutoFit/>
           </a:bodyPr>
           <a:lstStyle/>
@@ -10348,7 +9953,6 @@
           <a:lstStyle/>
           <a:p>
             <a:pPr algn="ctr"/>
-            <a:endParaRPr/>
           </a:p>
         </p:txBody>
       </p:sp>
@@ -10369,7 +9973,7 @@
           <a:noFill/>
         </p:spPr>
         <p:txBody>
-          <a:bodyPr wrap="square" lIns="0" tIns="0" rIns="0" bIns="0" anchor="t">
+          <a:bodyPr wrap="square" anchor="t" lIns="0" rIns="0" tIns="0" bIns="0">
             <a:spAutoFit/>
           </a:bodyPr>
           <a:lstStyle/>
@@ -10411,7 +10015,7 @@
           <a:noFill/>
         </p:spPr>
         <p:txBody>
-          <a:bodyPr wrap="square" lIns="0" tIns="0" rIns="0" bIns="0" anchor="t">
+          <a:bodyPr wrap="square" anchor="t" lIns="0" rIns="0" tIns="0" bIns="0">
             <a:spAutoFit/>
           </a:bodyPr>
           <a:lstStyle/>
@@ -10477,7 +10081,6 @@
           <a:lstStyle/>
           <a:p>
             <a:pPr algn="ctr"/>
-            <a:endParaRPr/>
           </a:p>
         </p:txBody>
       </p:sp>
@@ -10518,7 +10121,7 @@
           </a:fontRef>
         </p:style>
         <p:txBody>
-          <a:bodyPr wrap="none" rtlCol="0" anchor="ctr"/>
+          <a:bodyPr rtlCol="0" anchor="ctr" wrap="none"/>
           <a:lstStyle/>
           <a:p>
             <a:pPr algn="ctr"/>
@@ -10550,7 +10153,7 @@
           <a:noFill/>
         </p:spPr>
         <p:txBody>
-          <a:bodyPr wrap="square" lIns="0" tIns="0" rIns="0" bIns="0" anchor="t">
+          <a:bodyPr wrap="square" anchor="t" lIns="0" rIns="0" tIns="0" bIns="0">
             <a:spAutoFit/>
           </a:bodyPr>
           <a:lstStyle/>
@@ -10618,7 +10221,6 @@
           <a:lstStyle/>
           <a:p>
             <a:pPr algn="ctr"/>
-            <a:endParaRPr/>
           </a:p>
         </p:txBody>
       </p:sp>
@@ -10639,7 +10241,7 @@
           <a:noFill/>
         </p:spPr>
         <p:txBody>
-          <a:bodyPr wrap="square" lIns="0" tIns="0" rIns="0" bIns="0" anchor="t">
+          <a:bodyPr wrap="square" anchor="t" lIns="0" rIns="0" tIns="0" bIns="0">
             <a:spAutoFit/>
           </a:bodyPr>
           <a:lstStyle/>
@@ -10681,7 +10283,7 @@
           <a:noFill/>
         </p:spPr>
         <p:txBody>
-          <a:bodyPr wrap="square" lIns="0" tIns="0" rIns="0" bIns="0" anchor="t">
+          <a:bodyPr wrap="square" anchor="t" lIns="0" rIns="0" tIns="0" bIns="0">
             <a:spAutoFit/>
           </a:bodyPr>
           <a:lstStyle/>

</xml_diff>

<commit_message>
Add Q2d NYISO reserve (headroom/footroom) scenario
Estimates additional revenue from offering reserve capacity on top of
the energy-only backcast, at $1.25/MW-hr. Solar offers footroom only;
storage offers headroom/footroom per its daily charge/discharge
schedule; combined sums both. Adds a new Q2d section to the writeup
and a new slide to the deck, each showing energy-only vs.
energy+reserve revenue as two axis-matched charts.

Co-Authored-By: Claude Sonnet 5 <noreply@anthropic.com>
Claude-Session: https://claude.ai/code/session_01Wd98BoYaSaTQ6bNKBze8DQ
</commit_message>
<xml_diff>
--- a/GCV_Solar_Storage_Valuation.pptx
+++ b/GCV_Solar_Storage_Valuation.pptx
@@ -15,6 +15,7 @@
     <p:sldId id="263" r:id="rId14"/>
     <p:sldId id="264" r:id="rId15"/>
     <p:sldId id="265" r:id="rId16"/>
+    <p:sldId id="266" r:id="rId17"/>
   </p:sldIdLst>
   <p:sldSz cx="12191695" cy="6858000" type="screen4x3"/>
   <p:notesSz cx="6858000" cy="9144000"/>
@@ -3468,7 +3469,7 @@
                 </a:solidFill>
                 <a:latin typeface="Calibri"/>
               </a:rPr>
-              <a:t>Q3C  ·  RECOMMENDATION</a:t>
+              <a:t>Q3B  ·  PROPOSED FOLLOW-ON STUDY</a:t>
             </a:r>
           </a:p>
         </p:txBody>
@@ -3510,7 +3511,7 @@
                 </a:solidFill>
                 <a:latin typeface="Calibri"/>
               </a:rPr>
-              <a:t>Combined Solar + Storage Is the Recommended Installation</a:t>
+              <a:t>A More Complete Revenue Forecast — 10 Additional Hours</a:t>
             </a:r>
           </a:p>
         </p:txBody>
@@ -3638,7 +3639,1585 @@
                 </a:solidFill>
                 <a:latin typeface="Calibri"/>
               </a:rPr>
-              <a:t>10 / 10</a:t>
+              <a:t>10 / 11</a:t>
+            </a:r>
+          </a:p>
+        </p:txBody>
+      </p:sp>
+      <p:sp>
+        <p:nvSpPr>
+          <p:cNvPr id="8" name="Oval 7"/>
+          <p:cNvSpPr/>
+          <p:nvPr/>
+        </p:nvSpPr>
+        <p:spPr>
+          <a:xfrm>
+            <a:off x="502920" y="1508760"/>
+            <a:ext cx="457200" cy="457200"/>
+          </a:xfrm>
+          <a:prstGeom prst="ellipse">
+            <a:avLst/>
+          </a:prstGeom>
+          <a:solidFill>
+            <a:srgbClr val="2A78D6"/>
+          </a:solidFill>
+          <a:ln>
+            <a:noFill/>
+          </a:ln>
+          <a:effectLst/>
+        </p:spPr>
+        <p:style>
+          <a:lnRef idx="1">
+            <a:schemeClr val="accent1"/>
+          </a:lnRef>
+          <a:fillRef idx="3">
+            <a:schemeClr val="accent1"/>
+          </a:fillRef>
+          <a:effectRef idx="2">
+            <a:schemeClr val="accent1"/>
+          </a:effectRef>
+          <a:fontRef idx="minor">
+            <a:schemeClr val="lt1"/>
+          </a:fontRef>
+        </p:style>
+        <p:txBody>
+          <a:bodyPr rtlCol="0" anchor="ctr" wrap="none"/>
+          <a:lstStyle/>
+          <a:p>
+            <a:pPr algn="ctr"/>
+            <a:r>
+              <a:rPr sz="1600" b="1">
+                <a:solidFill>
+                  <a:srgbClr val="FFFFFF"/>
+                </a:solidFill>
+              </a:rPr>
+              <a:t>1</a:t>
+            </a:r>
+          </a:p>
+        </p:txBody>
+      </p:sp>
+      <p:sp>
+        <p:nvSpPr>
+          <p:cNvPr id="9" name="TextBox 8"/>
+          <p:cNvSpPr txBox="1"/>
+          <p:nvPr/>
+        </p:nvSpPr>
+        <p:spPr>
+          <a:xfrm>
+            <a:off x="1143000" y="1490472"/>
+            <a:ext cx="2834640" cy="365760"/>
+          </a:xfrm>
+          <a:prstGeom prst="rect">
+            <a:avLst/>
+          </a:prstGeom>
+          <a:noFill/>
+        </p:spPr>
+        <p:txBody>
+          <a:bodyPr wrap="square" anchor="t" lIns="0" rIns="0" tIns="0" bIns="0">
+            <a:spAutoFit/>
+          </a:bodyPr>
+          <a:lstStyle/>
+          <a:p>
+            <a:pPr algn="l">
+              <a:lnSpc>
+                <a:spcPct val="100000"/>
+              </a:lnSpc>
+              <a:spcAft>
+                <a:spcPts val="0"/>
+              </a:spcAft>
+            </a:pPr>
+            <a:r>
+              <a:rPr sz="1500" b="1" i="0">
+                <a:solidFill>
+                  <a:srgbClr val="0B0B0B"/>
+                </a:solidFill>
+                <a:latin typeface="Calibri"/>
+              </a:rPr>
+              <a:t>Forward price shapes</a:t>
+            </a:r>
+          </a:p>
+        </p:txBody>
+      </p:sp>
+      <p:sp>
+        <p:nvSpPr>
+          <p:cNvPr id="10" name="Rectangle 9"/>
+          <p:cNvSpPr/>
+          <p:nvPr/>
+        </p:nvSpPr>
+        <p:spPr>
+          <a:xfrm>
+            <a:off x="4069080" y="1527048"/>
+            <a:ext cx="777240" cy="292608"/>
+          </a:xfrm>
+          <a:prstGeom prst="rect">
+            <a:avLst/>
+          </a:prstGeom>
+          <a:solidFill>
+            <a:srgbClr val="FCFCFB"/>
+          </a:solidFill>
+          <a:ln w="9525">
+            <a:solidFill>
+              <a:srgbClr val="2A78D6"/>
+            </a:solidFill>
+          </a:ln>
+          <a:effectLst/>
+        </p:spPr>
+        <p:style>
+          <a:lnRef idx="1">
+            <a:schemeClr val="accent1"/>
+          </a:lnRef>
+          <a:fillRef idx="3">
+            <a:schemeClr val="accent1"/>
+          </a:fillRef>
+          <a:effectRef idx="2">
+            <a:schemeClr val="accent1"/>
+          </a:effectRef>
+          <a:fontRef idx="minor">
+            <a:schemeClr val="lt1"/>
+          </a:fontRef>
+        </p:style>
+        <p:txBody>
+          <a:bodyPr rtlCol="0" anchor="ctr"/>
+          <a:lstStyle/>
+          <a:p>
+            <a:pPr algn="ctr"/>
+          </a:p>
+        </p:txBody>
+      </p:sp>
+      <p:sp>
+        <p:nvSpPr>
+          <p:cNvPr id="11" name="TextBox 10"/>
+          <p:cNvSpPr txBox="1"/>
+          <p:nvPr/>
+        </p:nvSpPr>
+        <p:spPr>
+          <a:xfrm>
+            <a:off x="4069080" y="1563624"/>
+            <a:ext cx="777240" cy="256032"/>
+          </a:xfrm>
+          <a:prstGeom prst="rect">
+            <a:avLst/>
+          </a:prstGeom>
+          <a:noFill/>
+        </p:spPr>
+        <p:txBody>
+          <a:bodyPr wrap="square" anchor="t" lIns="0" rIns="0" tIns="0" bIns="0">
+            <a:spAutoFit/>
+          </a:bodyPr>
+          <a:lstStyle/>
+          <a:p>
+            <a:pPr algn="ctr">
+              <a:lnSpc>
+                <a:spcPct val="100000"/>
+              </a:lnSpc>
+              <a:spcAft>
+                <a:spcPts val="0"/>
+              </a:spcAft>
+            </a:pPr>
+            <a:r>
+              <a:rPr sz="1100" b="1" i="0">
+                <a:solidFill>
+                  <a:srgbClr val="2A78D6"/>
+                </a:solidFill>
+                <a:latin typeface="Calibri"/>
+              </a:rPr>
+              <a:t>~3 hrs</a:t>
+            </a:r>
+          </a:p>
+        </p:txBody>
+      </p:sp>
+      <p:sp>
+        <p:nvSpPr>
+          <p:cNvPr id="12" name="TextBox 11"/>
+          <p:cNvSpPr txBox="1"/>
+          <p:nvPr/>
+        </p:nvSpPr>
+        <p:spPr>
+          <a:xfrm>
+            <a:off x="5029200" y="1490472"/>
+            <a:ext cx="6675120" cy="777240"/>
+          </a:xfrm>
+          <a:prstGeom prst="rect">
+            <a:avLst/>
+          </a:prstGeom>
+          <a:noFill/>
+        </p:spPr>
+        <p:txBody>
+          <a:bodyPr wrap="square" anchor="t" lIns="0" rIns="0" tIns="0" bIns="0">
+            <a:spAutoFit/>
+          </a:bodyPr>
+          <a:lstStyle/>
+          <a:p>
+            <a:pPr algn="l">
+              <a:lnSpc>
+                <a:spcPct val="110000"/>
+              </a:lnSpc>
+              <a:spcAft>
+                <a:spcPts val="0"/>
+              </a:spcAft>
+            </a:pPr>
+            <a:r>
+              <a:rPr sz="1200" b="0" i="0">
+                <a:solidFill>
+                  <a:srgbClr val="52514E"/>
+                </a:solidFill>
+                <a:latin typeface="Calibri"/>
+              </a:rPr>
+              <a:t>Replace the 2023 backcast with a forward-looking hourly price shape reflecting expected capacity additions/retirements and load growth (electrification, data centers), grounded in published NYISO / NYSERDA CLCPA outlooks.</a:t>
+            </a:r>
+          </a:p>
+        </p:txBody>
+      </p:sp>
+      <p:sp>
+        <p:nvSpPr>
+          <p:cNvPr id="13" name="Rectangle 12"/>
+          <p:cNvSpPr/>
+          <p:nvPr/>
+        </p:nvSpPr>
+        <p:spPr>
+          <a:xfrm>
+            <a:off x="502920" y="2295144"/>
+            <a:ext cx="11201400" cy="9525"/>
+          </a:xfrm>
+          <a:prstGeom prst="rect">
+            <a:avLst/>
+          </a:prstGeom>
+          <a:solidFill>
+            <a:srgbClr val="E1E0D9"/>
+          </a:solidFill>
+          <a:ln>
+            <a:noFill/>
+          </a:ln>
+          <a:effectLst/>
+        </p:spPr>
+        <p:style>
+          <a:lnRef idx="1">
+            <a:schemeClr val="accent1"/>
+          </a:lnRef>
+          <a:fillRef idx="3">
+            <a:schemeClr val="accent1"/>
+          </a:fillRef>
+          <a:effectRef idx="2">
+            <a:schemeClr val="accent1"/>
+          </a:effectRef>
+          <a:fontRef idx="minor">
+            <a:schemeClr val="lt1"/>
+          </a:fontRef>
+        </p:style>
+        <p:txBody>
+          <a:bodyPr rtlCol="0" anchor="ctr"/>
+          <a:lstStyle/>
+          <a:p>
+            <a:pPr algn="ctr"/>
+          </a:p>
+        </p:txBody>
+      </p:sp>
+      <p:sp>
+        <p:nvSpPr>
+          <p:cNvPr id="14" name="Oval 13"/>
+          <p:cNvSpPr/>
+          <p:nvPr/>
+        </p:nvSpPr>
+        <p:spPr>
+          <a:xfrm>
+            <a:off x="502920" y="2404872"/>
+            <a:ext cx="457200" cy="457200"/>
+          </a:xfrm>
+          <a:prstGeom prst="ellipse">
+            <a:avLst/>
+          </a:prstGeom>
+          <a:solidFill>
+            <a:srgbClr val="2A78D6"/>
+          </a:solidFill>
+          <a:ln>
+            <a:noFill/>
+          </a:ln>
+          <a:effectLst/>
+        </p:spPr>
+        <p:style>
+          <a:lnRef idx="1">
+            <a:schemeClr val="accent1"/>
+          </a:lnRef>
+          <a:fillRef idx="3">
+            <a:schemeClr val="accent1"/>
+          </a:fillRef>
+          <a:effectRef idx="2">
+            <a:schemeClr val="accent1"/>
+          </a:effectRef>
+          <a:fontRef idx="minor">
+            <a:schemeClr val="lt1"/>
+          </a:fontRef>
+        </p:style>
+        <p:txBody>
+          <a:bodyPr rtlCol="0" anchor="ctr" wrap="none"/>
+          <a:lstStyle/>
+          <a:p>
+            <a:pPr algn="ctr"/>
+            <a:r>
+              <a:rPr sz="1600" b="1">
+                <a:solidFill>
+                  <a:srgbClr val="FFFFFF"/>
+                </a:solidFill>
+              </a:rPr>
+              <a:t>2</a:t>
+            </a:r>
+          </a:p>
+        </p:txBody>
+      </p:sp>
+      <p:sp>
+        <p:nvSpPr>
+          <p:cNvPr id="15" name="TextBox 14"/>
+          <p:cNvSpPr txBox="1"/>
+          <p:nvPr/>
+        </p:nvSpPr>
+        <p:spPr>
+          <a:xfrm>
+            <a:off x="1143000" y="2386584"/>
+            <a:ext cx="2834640" cy="365760"/>
+          </a:xfrm>
+          <a:prstGeom prst="rect">
+            <a:avLst/>
+          </a:prstGeom>
+          <a:noFill/>
+        </p:spPr>
+        <p:txBody>
+          <a:bodyPr wrap="square" anchor="t" lIns="0" rIns="0" tIns="0" bIns="0">
+            <a:spAutoFit/>
+          </a:bodyPr>
+          <a:lstStyle/>
+          <a:p>
+            <a:pPr algn="l">
+              <a:lnSpc>
+                <a:spcPct val="100000"/>
+              </a:lnSpc>
+              <a:spcAft>
+                <a:spcPts val="0"/>
+              </a:spcAft>
+            </a:pPr>
+            <a:r>
+              <a:rPr sz="1500" b="1" i="0">
+                <a:solidFill>
+                  <a:srgbClr val="0B0B0B"/>
+                </a:solidFill>
+                <a:latin typeface="Calibri"/>
+              </a:rPr>
+              <a:t>Realistic operating assumptions</a:t>
+            </a:r>
+          </a:p>
+        </p:txBody>
+      </p:sp>
+      <p:sp>
+        <p:nvSpPr>
+          <p:cNvPr id="16" name="Rectangle 15"/>
+          <p:cNvSpPr/>
+          <p:nvPr/>
+        </p:nvSpPr>
+        <p:spPr>
+          <a:xfrm>
+            <a:off x="4069080" y="2423160"/>
+            <a:ext cx="777240" cy="292608"/>
+          </a:xfrm>
+          <a:prstGeom prst="rect">
+            <a:avLst/>
+          </a:prstGeom>
+          <a:solidFill>
+            <a:srgbClr val="FCFCFB"/>
+          </a:solidFill>
+          <a:ln w="9525">
+            <a:solidFill>
+              <a:srgbClr val="2A78D6"/>
+            </a:solidFill>
+          </a:ln>
+          <a:effectLst/>
+        </p:spPr>
+        <p:style>
+          <a:lnRef idx="1">
+            <a:schemeClr val="accent1"/>
+          </a:lnRef>
+          <a:fillRef idx="3">
+            <a:schemeClr val="accent1"/>
+          </a:fillRef>
+          <a:effectRef idx="2">
+            <a:schemeClr val="accent1"/>
+          </a:effectRef>
+          <a:fontRef idx="minor">
+            <a:schemeClr val="lt1"/>
+          </a:fontRef>
+        </p:style>
+        <p:txBody>
+          <a:bodyPr rtlCol="0" anchor="ctr"/>
+          <a:lstStyle/>
+          <a:p>
+            <a:pPr algn="ctr"/>
+          </a:p>
+        </p:txBody>
+      </p:sp>
+      <p:sp>
+        <p:nvSpPr>
+          <p:cNvPr id="17" name="TextBox 16"/>
+          <p:cNvSpPr txBox="1"/>
+          <p:nvPr/>
+        </p:nvSpPr>
+        <p:spPr>
+          <a:xfrm>
+            <a:off x="4069080" y="2459736"/>
+            <a:ext cx="777240" cy="256032"/>
+          </a:xfrm>
+          <a:prstGeom prst="rect">
+            <a:avLst/>
+          </a:prstGeom>
+          <a:noFill/>
+        </p:spPr>
+        <p:txBody>
+          <a:bodyPr wrap="square" anchor="t" lIns="0" rIns="0" tIns="0" bIns="0">
+            <a:spAutoFit/>
+          </a:bodyPr>
+          <a:lstStyle/>
+          <a:p>
+            <a:pPr algn="ctr">
+              <a:lnSpc>
+                <a:spcPct val="100000"/>
+              </a:lnSpc>
+              <a:spcAft>
+                <a:spcPts val="0"/>
+              </a:spcAft>
+            </a:pPr>
+            <a:r>
+              <a:rPr sz="1100" b="1" i="0">
+                <a:solidFill>
+                  <a:srgbClr val="2A78D6"/>
+                </a:solidFill>
+                <a:latin typeface="Calibri"/>
+              </a:rPr>
+              <a:t>~2 hrs</a:t>
+            </a:r>
+          </a:p>
+        </p:txBody>
+      </p:sp>
+      <p:sp>
+        <p:nvSpPr>
+          <p:cNvPr id="18" name="TextBox 17"/>
+          <p:cNvSpPr txBox="1"/>
+          <p:nvPr/>
+        </p:nvSpPr>
+        <p:spPr>
+          <a:xfrm>
+            <a:off x="5029200" y="2386584"/>
+            <a:ext cx="6675120" cy="777240"/>
+          </a:xfrm>
+          <a:prstGeom prst="rect">
+            <a:avLst/>
+          </a:prstGeom>
+          <a:noFill/>
+        </p:spPr>
+        <p:txBody>
+          <a:bodyPr wrap="square" anchor="t" lIns="0" rIns="0" tIns="0" bIns="0">
+            <a:spAutoFit/>
+          </a:bodyPr>
+          <a:lstStyle/>
+          <a:p>
+            <a:pPr algn="l">
+              <a:lnSpc>
+                <a:spcPct val="110000"/>
+              </a:lnSpc>
+              <a:spcAft>
+                <a:spcPts val="0"/>
+              </a:spcAft>
+            </a:pPr>
+            <a:r>
+              <a:rPr sz="1200" b="0" i="0">
+                <a:solidFill>
+                  <a:srgbClr val="52514E"/>
+                </a:solidFill>
+                <a:latin typeface="Calibri"/>
+              </a:rPr>
+              <a:t>Round-trip efficiency ~85–90% (not 100%), solar degradation (~0.5%/yr), battery degradation/augmentation, multi-cycle-per-day dispatch where economic.</a:t>
+            </a:r>
+          </a:p>
+        </p:txBody>
+      </p:sp>
+      <p:sp>
+        <p:nvSpPr>
+          <p:cNvPr id="19" name="Rectangle 18"/>
+          <p:cNvSpPr/>
+          <p:nvPr/>
+        </p:nvSpPr>
+        <p:spPr>
+          <a:xfrm>
+            <a:off x="502920" y="3191256"/>
+            <a:ext cx="11201400" cy="9525"/>
+          </a:xfrm>
+          <a:prstGeom prst="rect">
+            <a:avLst/>
+          </a:prstGeom>
+          <a:solidFill>
+            <a:srgbClr val="E1E0D9"/>
+          </a:solidFill>
+          <a:ln>
+            <a:noFill/>
+          </a:ln>
+          <a:effectLst/>
+        </p:spPr>
+        <p:style>
+          <a:lnRef idx="1">
+            <a:schemeClr val="accent1"/>
+          </a:lnRef>
+          <a:fillRef idx="3">
+            <a:schemeClr val="accent1"/>
+          </a:fillRef>
+          <a:effectRef idx="2">
+            <a:schemeClr val="accent1"/>
+          </a:effectRef>
+          <a:fontRef idx="minor">
+            <a:schemeClr val="lt1"/>
+          </a:fontRef>
+        </p:style>
+        <p:txBody>
+          <a:bodyPr rtlCol="0" anchor="ctr"/>
+          <a:lstStyle/>
+          <a:p>
+            <a:pPr algn="ctr"/>
+          </a:p>
+        </p:txBody>
+      </p:sp>
+      <p:sp>
+        <p:nvSpPr>
+          <p:cNvPr id="20" name="Oval 19"/>
+          <p:cNvSpPr/>
+          <p:nvPr/>
+        </p:nvSpPr>
+        <p:spPr>
+          <a:xfrm>
+            <a:off x="502920" y="3300984"/>
+            <a:ext cx="457200" cy="457200"/>
+          </a:xfrm>
+          <a:prstGeom prst="ellipse">
+            <a:avLst/>
+          </a:prstGeom>
+          <a:solidFill>
+            <a:srgbClr val="2A78D6"/>
+          </a:solidFill>
+          <a:ln>
+            <a:noFill/>
+          </a:ln>
+          <a:effectLst/>
+        </p:spPr>
+        <p:style>
+          <a:lnRef idx="1">
+            <a:schemeClr val="accent1"/>
+          </a:lnRef>
+          <a:fillRef idx="3">
+            <a:schemeClr val="accent1"/>
+          </a:fillRef>
+          <a:effectRef idx="2">
+            <a:schemeClr val="accent1"/>
+          </a:effectRef>
+          <a:fontRef idx="minor">
+            <a:schemeClr val="lt1"/>
+          </a:fontRef>
+        </p:style>
+        <p:txBody>
+          <a:bodyPr rtlCol="0" anchor="ctr" wrap="none"/>
+          <a:lstStyle/>
+          <a:p>
+            <a:pPr algn="ctr"/>
+            <a:r>
+              <a:rPr sz="1600" b="1">
+                <a:solidFill>
+                  <a:srgbClr val="FFFFFF"/>
+                </a:solidFill>
+              </a:rPr>
+              <a:t>3</a:t>
+            </a:r>
+          </a:p>
+        </p:txBody>
+      </p:sp>
+      <p:sp>
+        <p:nvSpPr>
+          <p:cNvPr id="21" name="TextBox 20"/>
+          <p:cNvSpPr txBox="1"/>
+          <p:nvPr/>
+        </p:nvSpPr>
+        <p:spPr>
+          <a:xfrm>
+            <a:off x="1143000" y="3282696"/>
+            <a:ext cx="2834640" cy="365760"/>
+          </a:xfrm>
+          <a:prstGeom prst="rect">
+            <a:avLst/>
+          </a:prstGeom>
+          <a:noFill/>
+        </p:spPr>
+        <p:txBody>
+          <a:bodyPr wrap="square" anchor="t" lIns="0" rIns="0" tIns="0" bIns="0">
+            <a:spAutoFit/>
+          </a:bodyPr>
+          <a:lstStyle/>
+          <a:p>
+            <a:pPr algn="l">
+              <a:lnSpc>
+                <a:spcPct val="100000"/>
+              </a:lnSpc>
+              <a:spcAft>
+                <a:spcPts val="0"/>
+              </a:spcAft>
+            </a:pPr>
+            <a:r>
+              <a:rPr sz="1500" b="1" i="0">
+                <a:solidFill>
+                  <a:srgbClr val="0B0B0B"/>
+                </a:solidFill>
+                <a:latin typeface="Calibri"/>
+              </a:rPr>
+              <a:t>Capacity &amp; ancillary revenue</a:t>
+            </a:r>
+          </a:p>
+        </p:txBody>
+      </p:sp>
+      <p:sp>
+        <p:nvSpPr>
+          <p:cNvPr id="22" name="Rectangle 21"/>
+          <p:cNvSpPr/>
+          <p:nvPr/>
+        </p:nvSpPr>
+        <p:spPr>
+          <a:xfrm>
+            <a:off x="4069080" y="3319272"/>
+            <a:ext cx="777240" cy="292608"/>
+          </a:xfrm>
+          <a:prstGeom prst="rect">
+            <a:avLst/>
+          </a:prstGeom>
+          <a:solidFill>
+            <a:srgbClr val="FCFCFB"/>
+          </a:solidFill>
+          <a:ln w="9525">
+            <a:solidFill>
+              <a:srgbClr val="2A78D6"/>
+            </a:solidFill>
+          </a:ln>
+          <a:effectLst/>
+        </p:spPr>
+        <p:style>
+          <a:lnRef idx="1">
+            <a:schemeClr val="accent1"/>
+          </a:lnRef>
+          <a:fillRef idx="3">
+            <a:schemeClr val="accent1"/>
+          </a:fillRef>
+          <a:effectRef idx="2">
+            <a:schemeClr val="accent1"/>
+          </a:effectRef>
+          <a:fontRef idx="minor">
+            <a:schemeClr val="lt1"/>
+          </a:fontRef>
+        </p:style>
+        <p:txBody>
+          <a:bodyPr rtlCol="0" anchor="ctr"/>
+          <a:lstStyle/>
+          <a:p>
+            <a:pPr algn="ctr"/>
+          </a:p>
+        </p:txBody>
+      </p:sp>
+      <p:sp>
+        <p:nvSpPr>
+          <p:cNvPr id="23" name="TextBox 22"/>
+          <p:cNvSpPr txBox="1"/>
+          <p:nvPr/>
+        </p:nvSpPr>
+        <p:spPr>
+          <a:xfrm>
+            <a:off x="4069080" y="3355848"/>
+            <a:ext cx="777240" cy="256032"/>
+          </a:xfrm>
+          <a:prstGeom prst="rect">
+            <a:avLst/>
+          </a:prstGeom>
+          <a:noFill/>
+        </p:spPr>
+        <p:txBody>
+          <a:bodyPr wrap="square" anchor="t" lIns="0" rIns="0" tIns="0" bIns="0">
+            <a:spAutoFit/>
+          </a:bodyPr>
+          <a:lstStyle/>
+          <a:p>
+            <a:pPr algn="ctr">
+              <a:lnSpc>
+                <a:spcPct val="100000"/>
+              </a:lnSpc>
+              <a:spcAft>
+                <a:spcPts val="0"/>
+              </a:spcAft>
+            </a:pPr>
+            <a:r>
+              <a:rPr sz="1100" b="1" i="0">
+                <a:solidFill>
+                  <a:srgbClr val="2A78D6"/>
+                </a:solidFill>
+                <a:latin typeface="Calibri"/>
+              </a:rPr>
+              <a:t>~2 hrs</a:t>
+            </a:r>
+          </a:p>
+        </p:txBody>
+      </p:sp>
+      <p:sp>
+        <p:nvSpPr>
+          <p:cNvPr id="24" name="TextBox 23"/>
+          <p:cNvSpPr txBox="1"/>
+          <p:nvPr/>
+        </p:nvSpPr>
+        <p:spPr>
+          <a:xfrm>
+            <a:off x="5029200" y="3282696"/>
+            <a:ext cx="6675120" cy="777240"/>
+          </a:xfrm>
+          <a:prstGeom prst="rect">
+            <a:avLst/>
+          </a:prstGeom>
+          <a:noFill/>
+        </p:spPr>
+        <p:txBody>
+          <a:bodyPr wrap="square" anchor="t" lIns="0" rIns="0" tIns="0" bIns="0">
+            <a:spAutoFit/>
+          </a:bodyPr>
+          <a:lstStyle/>
+          <a:p>
+            <a:pPr algn="l">
+              <a:lnSpc>
+                <a:spcPct val="110000"/>
+              </a:lnSpc>
+              <a:spcAft>
+                <a:spcPts val="0"/>
+              </a:spcAft>
+            </a:pPr>
+            <a:r>
+              <a:rPr sz="1200" b="0" i="0">
+                <a:solidFill>
+                  <a:srgbClr val="52514E"/>
+                </a:solidFill>
+                <a:latin typeface="Calibri"/>
+              </a:rPr>
+              <a:t>Add NYISO capacity market (ICAP) and frequency regulation revenue — often the majority of a merchant battery's revenue stack. Q2d sketches an illustrative reserve add-on; a rigorous version (real product rules, co-optimization, capacity market) is still the single biggest gap.</a:t>
+            </a:r>
+          </a:p>
+        </p:txBody>
+      </p:sp>
+      <p:sp>
+        <p:nvSpPr>
+          <p:cNvPr id="25" name="Rectangle 24"/>
+          <p:cNvSpPr/>
+          <p:nvPr/>
+        </p:nvSpPr>
+        <p:spPr>
+          <a:xfrm>
+            <a:off x="502920" y="4087368"/>
+            <a:ext cx="11201400" cy="9525"/>
+          </a:xfrm>
+          <a:prstGeom prst="rect">
+            <a:avLst/>
+          </a:prstGeom>
+          <a:solidFill>
+            <a:srgbClr val="E1E0D9"/>
+          </a:solidFill>
+          <a:ln>
+            <a:noFill/>
+          </a:ln>
+          <a:effectLst/>
+        </p:spPr>
+        <p:style>
+          <a:lnRef idx="1">
+            <a:schemeClr val="accent1"/>
+          </a:lnRef>
+          <a:fillRef idx="3">
+            <a:schemeClr val="accent1"/>
+          </a:fillRef>
+          <a:effectRef idx="2">
+            <a:schemeClr val="accent1"/>
+          </a:effectRef>
+          <a:fontRef idx="minor">
+            <a:schemeClr val="lt1"/>
+          </a:fontRef>
+        </p:style>
+        <p:txBody>
+          <a:bodyPr rtlCol="0" anchor="ctr"/>
+          <a:lstStyle/>
+          <a:p>
+            <a:pPr algn="ctr"/>
+          </a:p>
+        </p:txBody>
+      </p:sp>
+      <p:sp>
+        <p:nvSpPr>
+          <p:cNvPr id="26" name="Oval 25"/>
+          <p:cNvSpPr/>
+          <p:nvPr/>
+        </p:nvSpPr>
+        <p:spPr>
+          <a:xfrm>
+            <a:off x="502920" y="4197096"/>
+            <a:ext cx="457200" cy="457200"/>
+          </a:xfrm>
+          <a:prstGeom prst="ellipse">
+            <a:avLst/>
+          </a:prstGeom>
+          <a:solidFill>
+            <a:srgbClr val="2A78D6"/>
+          </a:solidFill>
+          <a:ln>
+            <a:noFill/>
+          </a:ln>
+          <a:effectLst/>
+        </p:spPr>
+        <p:style>
+          <a:lnRef idx="1">
+            <a:schemeClr val="accent1"/>
+          </a:lnRef>
+          <a:fillRef idx="3">
+            <a:schemeClr val="accent1"/>
+          </a:fillRef>
+          <a:effectRef idx="2">
+            <a:schemeClr val="accent1"/>
+          </a:effectRef>
+          <a:fontRef idx="minor">
+            <a:schemeClr val="lt1"/>
+          </a:fontRef>
+        </p:style>
+        <p:txBody>
+          <a:bodyPr rtlCol="0" anchor="ctr" wrap="none"/>
+          <a:lstStyle/>
+          <a:p>
+            <a:pPr algn="ctr"/>
+            <a:r>
+              <a:rPr sz="1600" b="1">
+                <a:solidFill>
+                  <a:srgbClr val="FFFFFF"/>
+                </a:solidFill>
+              </a:rPr>
+              <a:t>4</a:t>
+            </a:r>
+          </a:p>
+        </p:txBody>
+      </p:sp>
+      <p:sp>
+        <p:nvSpPr>
+          <p:cNvPr id="27" name="TextBox 26"/>
+          <p:cNvSpPr txBox="1"/>
+          <p:nvPr/>
+        </p:nvSpPr>
+        <p:spPr>
+          <a:xfrm>
+            <a:off x="1143000" y="4178808"/>
+            <a:ext cx="2834640" cy="365760"/>
+          </a:xfrm>
+          <a:prstGeom prst="rect">
+            <a:avLst/>
+          </a:prstGeom>
+          <a:noFill/>
+        </p:spPr>
+        <p:txBody>
+          <a:bodyPr wrap="square" anchor="t" lIns="0" rIns="0" tIns="0" bIns="0">
+            <a:spAutoFit/>
+          </a:bodyPr>
+          <a:lstStyle/>
+          <a:p>
+            <a:pPr algn="l">
+              <a:lnSpc>
+                <a:spcPct val="100000"/>
+              </a:lnSpc>
+              <a:spcAft>
+                <a:spcPts val="0"/>
+              </a:spcAft>
+            </a:pPr>
+            <a:r>
+              <a:rPr sz="1500" b="1" i="0">
+                <a:solidFill>
+                  <a:srgbClr val="0B0B0B"/>
+                </a:solidFill>
+                <a:latin typeface="Calibri"/>
+              </a:rPr>
+              <a:t>Scenario / sensitivity analysis</a:t>
+            </a:r>
+          </a:p>
+        </p:txBody>
+      </p:sp>
+      <p:sp>
+        <p:nvSpPr>
+          <p:cNvPr id="28" name="Rectangle 27"/>
+          <p:cNvSpPr/>
+          <p:nvPr/>
+        </p:nvSpPr>
+        <p:spPr>
+          <a:xfrm>
+            <a:off x="4069080" y="4215384"/>
+            <a:ext cx="777240" cy="292608"/>
+          </a:xfrm>
+          <a:prstGeom prst="rect">
+            <a:avLst/>
+          </a:prstGeom>
+          <a:solidFill>
+            <a:srgbClr val="FCFCFB"/>
+          </a:solidFill>
+          <a:ln w="9525">
+            <a:solidFill>
+              <a:srgbClr val="2A78D6"/>
+            </a:solidFill>
+          </a:ln>
+          <a:effectLst/>
+        </p:spPr>
+        <p:style>
+          <a:lnRef idx="1">
+            <a:schemeClr val="accent1"/>
+          </a:lnRef>
+          <a:fillRef idx="3">
+            <a:schemeClr val="accent1"/>
+          </a:fillRef>
+          <a:effectRef idx="2">
+            <a:schemeClr val="accent1"/>
+          </a:effectRef>
+          <a:fontRef idx="minor">
+            <a:schemeClr val="lt1"/>
+          </a:fontRef>
+        </p:style>
+        <p:txBody>
+          <a:bodyPr rtlCol="0" anchor="ctr"/>
+          <a:lstStyle/>
+          <a:p>
+            <a:pPr algn="ctr"/>
+          </a:p>
+        </p:txBody>
+      </p:sp>
+      <p:sp>
+        <p:nvSpPr>
+          <p:cNvPr id="29" name="TextBox 28"/>
+          <p:cNvSpPr txBox="1"/>
+          <p:nvPr/>
+        </p:nvSpPr>
+        <p:spPr>
+          <a:xfrm>
+            <a:off x="4069080" y="4251960"/>
+            <a:ext cx="777240" cy="256032"/>
+          </a:xfrm>
+          <a:prstGeom prst="rect">
+            <a:avLst/>
+          </a:prstGeom>
+          <a:noFill/>
+        </p:spPr>
+        <p:txBody>
+          <a:bodyPr wrap="square" anchor="t" lIns="0" rIns="0" tIns="0" bIns="0">
+            <a:spAutoFit/>
+          </a:bodyPr>
+          <a:lstStyle/>
+          <a:p>
+            <a:pPr algn="ctr">
+              <a:lnSpc>
+                <a:spcPct val="100000"/>
+              </a:lnSpc>
+              <a:spcAft>
+                <a:spcPts val="0"/>
+              </a:spcAft>
+            </a:pPr>
+            <a:r>
+              <a:rPr sz="1100" b="1" i="0">
+                <a:solidFill>
+                  <a:srgbClr val="2A78D6"/>
+                </a:solidFill>
+                <a:latin typeface="Calibri"/>
+              </a:rPr>
+              <a:t>~2 hrs</a:t>
+            </a:r>
+          </a:p>
+        </p:txBody>
+      </p:sp>
+      <p:sp>
+        <p:nvSpPr>
+          <p:cNvPr id="30" name="TextBox 29"/>
+          <p:cNvSpPr txBox="1"/>
+          <p:nvPr/>
+        </p:nvSpPr>
+        <p:spPr>
+          <a:xfrm>
+            <a:off x="5029200" y="4178808"/>
+            <a:ext cx="6675120" cy="777240"/>
+          </a:xfrm>
+          <a:prstGeom prst="rect">
+            <a:avLst/>
+          </a:prstGeom>
+          <a:noFill/>
+        </p:spPr>
+        <p:txBody>
+          <a:bodyPr wrap="square" anchor="t" lIns="0" rIns="0" tIns="0" bIns="0">
+            <a:spAutoFit/>
+          </a:bodyPr>
+          <a:lstStyle/>
+          <a:p>
+            <a:pPr algn="l">
+              <a:lnSpc>
+                <a:spcPct val="110000"/>
+              </a:lnSpc>
+              <a:spcAft>
+                <a:spcPts val="0"/>
+              </a:spcAft>
+            </a:pPr>
+            <a:r>
+              <a:rPr sz="1200" b="0" i="0">
+                <a:solidFill>
+                  <a:srgbClr val="52514E"/>
+                </a:solidFill>
+                <a:latin typeface="Calibri"/>
+              </a:rPr>
+              <a:t>High/low cases on load growth, gas prices, and renewable build-out pace, given how uncertain the 10-year price path is.</a:t>
+            </a:r>
+          </a:p>
+        </p:txBody>
+      </p:sp>
+      <p:sp>
+        <p:nvSpPr>
+          <p:cNvPr id="31" name="Rectangle 30"/>
+          <p:cNvSpPr/>
+          <p:nvPr/>
+        </p:nvSpPr>
+        <p:spPr>
+          <a:xfrm>
+            <a:off x="502920" y="4983480"/>
+            <a:ext cx="11201400" cy="9525"/>
+          </a:xfrm>
+          <a:prstGeom prst="rect">
+            <a:avLst/>
+          </a:prstGeom>
+          <a:solidFill>
+            <a:srgbClr val="E1E0D9"/>
+          </a:solidFill>
+          <a:ln>
+            <a:noFill/>
+          </a:ln>
+          <a:effectLst/>
+        </p:spPr>
+        <p:style>
+          <a:lnRef idx="1">
+            <a:schemeClr val="accent1"/>
+          </a:lnRef>
+          <a:fillRef idx="3">
+            <a:schemeClr val="accent1"/>
+          </a:fillRef>
+          <a:effectRef idx="2">
+            <a:schemeClr val="accent1"/>
+          </a:effectRef>
+          <a:fontRef idx="minor">
+            <a:schemeClr val="lt1"/>
+          </a:fontRef>
+        </p:style>
+        <p:txBody>
+          <a:bodyPr rtlCol="0" anchor="ctr"/>
+          <a:lstStyle/>
+          <a:p>
+            <a:pPr algn="ctr"/>
+          </a:p>
+        </p:txBody>
+      </p:sp>
+      <p:sp>
+        <p:nvSpPr>
+          <p:cNvPr id="32" name="Oval 31"/>
+          <p:cNvSpPr/>
+          <p:nvPr/>
+        </p:nvSpPr>
+        <p:spPr>
+          <a:xfrm>
+            <a:off x="502920" y="5093208"/>
+            <a:ext cx="457200" cy="457200"/>
+          </a:xfrm>
+          <a:prstGeom prst="ellipse">
+            <a:avLst/>
+          </a:prstGeom>
+          <a:solidFill>
+            <a:srgbClr val="2A78D6"/>
+          </a:solidFill>
+          <a:ln>
+            <a:noFill/>
+          </a:ln>
+          <a:effectLst/>
+        </p:spPr>
+        <p:style>
+          <a:lnRef idx="1">
+            <a:schemeClr val="accent1"/>
+          </a:lnRef>
+          <a:fillRef idx="3">
+            <a:schemeClr val="accent1"/>
+          </a:fillRef>
+          <a:effectRef idx="2">
+            <a:schemeClr val="accent1"/>
+          </a:effectRef>
+          <a:fontRef idx="minor">
+            <a:schemeClr val="lt1"/>
+          </a:fontRef>
+        </p:style>
+        <p:txBody>
+          <a:bodyPr rtlCol="0" anchor="ctr" wrap="none"/>
+          <a:lstStyle/>
+          <a:p>
+            <a:pPr algn="ctr"/>
+            <a:r>
+              <a:rPr sz="1600" b="1">
+                <a:solidFill>
+                  <a:srgbClr val="FFFFFF"/>
+                </a:solidFill>
+              </a:rPr>
+              <a:t>5</a:t>
+            </a:r>
+          </a:p>
+        </p:txBody>
+      </p:sp>
+      <p:sp>
+        <p:nvSpPr>
+          <p:cNvPr id="33" name="TextBox 32"/>
+          <p:cNvSpPr txBox="1"/>
+          <p:nvPr/>
+        </p:nvSpPr>
+        <p:spPr>
+          <a:xfrm>
+            <a:off x="1143000" y="5074920"/>
+            <a:ext cx="2834640" cy="365760"/>
+          </a:xfrm>
+          <a:prstGeom prst="rect">
+            <a:avLst/>
+          </a:prstGeom>
+          <a:noFill/>
+        </p:spPr>
+        <p:txBody>
+          <a:bodyPr wrap="square" anchor="t" lIns="0" rIns="0" tIns="0" bIns="0">
+            <a:spAutoFit/>
+          </a:bodyPr>
+          <a:lstStyle/>
+          <a:p>
+            <a:pPr algn="l">
+              <a:lnSpc>
+                <a:spcPct val="100000"/>
+              </a:lnSpc>
+              <a:spcAft>
+                <a:spcPts val="0"/>
+              </a:spcAft>
+            </a:pPr>
+            <a:r>
+              <a:rPr sz="1500" b="1" i="0">
+                <a:solidFill>
+                  <a:srgbClr val="0B0B0B"/>
+                </a:solidFill>
+                <a:latin typeface="Calibri"/>
+              </a:rPr>
+              <a:t>Full pro forma</a:t>
+            </a:r>
+          </a:p>
+        </p:txBody>
+      </p:sp>
+      <p:sp>
+        <p:nvSpPr>
+          <p:cNvPr id="34" name="Rectangle 33"/>
+          <p:cNvSpPr/>
+          <p:nvPr/>
+        </p:nvSpPr>
+        <p:spPr>
+          <a:xfrm>
+            <a:off x="4069080" y="5111496"/>
+            <a:ext cx="777240" cy="292608"/>
+          </a:xfrm>
+          <a:prstGeom prst="rect">
+            <a:avLst/>
+          </a:prstGeom>
+          <a:solidFill>
+            <a:srgbClr val="FCFCFB"/>
+          </a:solidFill>
+          <a:ln w="9525">
+            <a:solidFill>
+              <a:srgbClr val="2A78D6"/>
+            </a:solidFill>
+          </a:ln>
+          <a:effectLst/>
+        </p:spPr>
+        <p:style>
+          <a:lnRef idx="1">
+            <a:schemeClr val="accent1"/>
+          </a:lnRef>
+          <a:fillRef idx="3">
+            <a:schemeClr val="accent1"/>
+          </a:fillRef>
+          <a:effectRef idx="2">
+            <a:schemeClr val="accent1"/>
+          </a:effectRef>
+          <a:fontRef idx="minor">
+            <a:schemeClr val="lt1"/>
+          </a:fontRef>
+        </p:style>
+        <p:txBody>
+          <a:bodyPr rtlCol="0" anchor="ctr"/>
+          <a:lstStyle/>
+          <a:p>
+            <a:pPr algn="ctr"/>
+          </a:p>
+        </p:txBody>
+      </p:sp>
+      <p:sp>
+        <p:nvSpPr>
+          <p:cNvPr id="35" name="TextBox 34"/>
+          <p:cNvSpPr txBox="1"/>
+          <p:nvPr/>
+        </p:nvSpPr>
+        <p:spPr>
+          <a:xfrm>
+            <a:off x="4069080" y="5148072"/>
+            <a:ext cx="777240" cy="256032"/>
+          </a:xfrm>
+          <a:prstGeom prst="rect">
+            <a:avLst/>
+          </a:prstGeom>
+          <a:noFill/>
+        </p:spPr>
+        <p:txBody>
+          <a:bodyPr wrap="square" anchor="t" lIns="0" rIns="0" tIns="0" bIns="0">
+            <a:spAutoFit/>
+          </a:bodyPr>
+          <a:lstStyle/>
+          <a:p>
+            <a:pPr algn="ctr">
+              <a:lnSpc>
+                <a:spcPct val="100000"/>
+              </a:lnSpc>
+              <a:spcAft>
+                <a:spcPts val="0"/>
+              </a:spcAft>
+            </a:pPr>
+            <a:r>
+              <a:rPr sz="1100" b="1" i="0">
+                <a:solidFill>
+                  <a:srgbClr val="2A78D6"/>
+                </a:solidFill>
+                <a:latin typeface="Calibri"/>
+              </a:rPr>
+              <a:t>~1 hr</a:t>
+            </a:r>
+          </a:p>
+        </p:txBody>
+      </p:sp>
+      <p:sp>
+        <p:nvSpPr>
+          <p:cNvPr id="36" name="TextBox 35"/>
+          <p:cNvSpPr txBox="1"/>
+          <p:nvPr/>
+        </p:nvSpPr>
+        <p:spPr>
+          <a:xfrm>
+            <a:off x="5029200" y="5074920"/>
+            <a:ext cx="6675120" cy="777240"/>
+          </a:xfrm>
+          <a:prstGeom prst="rect">
+            <a:avLst/>
+          </a:prstGeom>
+          <a:noFill/>
+        </p:spPr>
+        <p:txBody>
+          <a:bodyPr wrap="square" anchor="t" lIns="0" rIns="0" tIns="0" bIns="0">
+            <a:spAutoFit/>
+          </a:bodyPr>
+          <a:lstStyle/>
+          <a:p>
+            <a:pPr algn="l">
+              <a:lnSpc>
+                <a:spcPct val="110000"/>
+              </a:lnSpc>
+              <a:spcAft>
+                <a:spcPts val="0"/>
+              </a:spcAft>
+            </a:pPr>
+            <a:r>
+              <a:rPr sz="1200" b="0" i="0">
+                <a:solidFill>
+                  <a:srgbClr val="52514E"/>
+                </a:solidFill>
+                <a:latin typeface="Calibri"/>
+              </a:rPr>
+              <a:t>Layer in provided capex, O&amp;M, financing, and ITC/IRA tax credit treatment to compute NPV/IRR rather than simple payback.</a:t>
+            </a:r>
+          </a:p>
+        </p:txBody>
+      </p:sp>
+    </p:spTree>
+  </p:cSld>
+  <p:clrMapOvr>
+    <a:masterClrMapping/>
+  </p:clrMapOvr>
+</p:sld>
+</file>
+
+<file path=ppt/slides/slide11.xml><?xml version="1.0" encoding="utf-8"?>
+<p:sld xmlns:a="http://schemas.openxmlformats.org/drawingml/2006/main" xmlns:p="http://schemas.openxmlformats.org/presentationml/2006/main" xmlns:r="http://schemas.openxmlformats.org/officeDocument/2006/relationships">
+  <p:cSld>
+    <p:bg>
+      <p:bgPr>
+        <a:solidFill>
+          <a:srgbClr val="FFFFFF"/>
+        </a:solidFill>
+        <a:effectLst/>
+      </p:bgPr>
+    </p:bg>
+    <p:spTree>
+      <p:nvGrpSpPr>
+        <p:cNvPr id="1" name=""/>
+        <p:cNvGrpSpPr/>
+        <p:nvPr/>
+      </p:nvGrpSpPr>
+      <p:grpSpPr/>
+      <p:sp>
+        <p:nvSpPr>
+          <p:cNvPr id="2" name="Rectangle 1"/>
+          <p:cNvSpPr/>
+          <p:nvPr/>
+        </p:nvSpPr>
+        <p:spPr>
+          <a:xfrm>
+            <a:off x="0" y="0"/>
+            <a:ext cx="12191695" cy="82296"/>
+          </a:xfrm>
+          <a:prstGeom prst="rect">
+            <a:avLst/>
+          </a:prstGeom>
+          <a:solidFill>
+            <a:srgbClr val="2A78D6"/>
+          </a:solidFill>
+          <a:ln>
+            <a:noFill/>
+          </a:ln>
+          <a:effectLst/>
+        </p:spPr>
+        <p:style>
+          <a:lnRef idx="1">
+            <a:schemeClr val="accent1"/>
+          </a:lnRef>
+          <a:fillRef idx="3">
+            <a:schemeClr val="accent1"/>
+          </a:fillRef>
+          <a:effectRef idx="2">
+            <a:schemeClr val="accent1"/>
+          </a:effectRef>
+          <a:fontRef idx="minor">
+            <a:schemeClr val="lt1"/>
+          </a:fontRef>
+        </p:style>
+        <p:txBody>
+          <a:bodyPr rtlCol="0" anchor="ctr"/>
+          <a:lstStyle/>
+          <a:p>
+            <a:pPr algn="ctr"/>
+          </a:p>
+        </p:txBody>
+      </p:sp>
+      <p:sp>
+        <p:nvSpPr>
+          <p:cNvPr id="3" name="TextBox 2"/>
+          <p:cNvSpPr txBox="1"/>
+          <p:nvPr/>
+        </p:nvSpPr>
+        <p:spPr>
+          <a:xfrm>
+            <a:off x="502920" y="274320"/>
+            <a:ext cx="9601200" cy="320040"/>
+          </a:xfrm>
+          <a:prstGeom prst="rect">
+            <a:avLst/>
+          </a:prstGeom>
+          <a:noFill/>
+        </p:spPr>
+        <p:txBody>
+          <a:bodyPr wrap="square" anchor="t" lIns="0" rIns="0" tIns="0" bIns="0">
+            <a:spAutoFit/>
+          </a:bodyPr>
+          <a:lstStyle/>
+          <a:p>
+            <a:pPr algn="l">
+              <a:lnSpc>
+                <a:spcPct val="100000"/>
+              </a:lnSpc>
+              <a:spcAft>
+                <a:spcPts val="0"/>
+              </a:spcAft>
+            </a:pPr>
+            <a:r>
+              <a:rPr sz="1300" b="1" i="0">
+                <a:solidFill>
+                  <a:srgbClr val="2A78D6"/>
+                </a:solidFill>
+                <a:latin typeface="Calibri"/>
+              </a:rPr>
+              <a:t>Q3C  ·  RECOMMENDATION</a:t>
+            </a:r>
+          </a:p>
+        </p:txBody>
+      </p:sp>
+      <p:sp>
+        <p:nvSpPr>
+          <p:cNvPr id="4" name="TextBox 3"/>
+          <p:cNvSpPr txBox="1"/>
+          <p:nvPr/>
+        </p:nvSpPr>
+        <p:spPr>
+          <a:xfrm>
+            <a:off x="502920" y="566928"/>
+            <a:ext cx="10789920" cy="640080"/>
+          </a:xfrm>
+          <a:prstGeom prst="rect">
+            <a:avLst/>
+          </a:prstGeom>
+          <a:noFill/>
+        </p:spPr>
+        <p:txBody>
+          <a:bodyPr wrap="square" anchor="t" lIns="0" rIns="0" tIns="0" bIns="0">
+            <a:spAutoFit/>
+          </a:bodyPr>
+          <a:lstStyle/>
+          <a:p>
+            <a:pPr algn="l">
+              <a:lnSpc>
+                <a:spcPct val="100000"/>
+              </a:lnSpc>
+              <a:spcAft>
+                <a:spcPts val="0"/>
+              </a:spcAft>
+            </a:pPr>
+            <a:r>
+              <a:rPr sz="2700" b="1" i="0">
+                <a:solidFill>
+                  <a:srgbClr val="0B0B0B"/>
+                </a:solidFill>
+                <a:latin typeface="Calibri"/>
+              </a:rPr>
+              <a:t>Combined Solar + Storage Is the Recommended Installation</a:t>
+            </a:r>
+          </a:p>
+        </p:txBody>
+      </p:sp>
+      <p:sp>
+        <p:nvSpPr>
+          <p:cNvPr id="5" name="Rectangle 4"/>
+          <p:cNvSpPr/>
+          <p:nvPr/>
+        </p:nvSpPr>
+        <p:spPr>
+          <a:xfrm>
+            <a:off x="502920" y="1207008"/>
+            <a:ext cx="914400" cy="38100"/>
+          </a:xfrm>
+          <a:prstGeom prst="rect">
+            <a:avLst/>
+          </a:prstGeom>
+          <a:solidFill>
+            <a:srgbClr val="2A78D6"/>
+          </a:solidFill>
+          <a:ln>
+            <a:noFill/>
+          </a:ln>
+          <a:effectLst/>
+        </p:spPr>
+        <p:style>
+          <a:lnRef idx="1">
+            <a:schemeClr val="accent1"/>
+          </a:lnRef>
+          <a:fillRef idx="3">
+            <a:schemeClr val="accent1"/>
+          </a:fillRef>
+          <a:effectRef idx="2">
+            <a:schemeClr val="accent1"/>
+          </a:effectRef>
+          <a:fontRef idx="minor">
+            <a:schemeClr val="lt1"/>
+          </a:fontRef>
+        </p:style>
+        <p:txBody>
+          <a:bodyPr rtlCol="0" anchor="ctr"/>
+          <a:lstStyle/>
+          <a:p>
+            <a:pPr algn="ctr"/>
+          </a:p>
+        </p:txBody>
+      </p:sp>
+      <p:sp>
+        <p:nvSpPr>
+          <p:cNvPr id="6" name="TextBox 5"/>
+          <p:cNvSpPr txBox="1"/>
+          <p:nvPr/>
+        </p:nvSpPr>
+        <p:spPr>
+          <a:xfrm>
+            <a:off x="502920" y="6473952"/>
+            <a:ext cx="7315200" cy="274320"/>
+          </a:xfrm>
+          <a:prstGeom prst="rect">
+            <a:avLst/>
+          </a:prstGeom>
+          <a:noFill/>
+        </p:spPr>
+        <p:txBody>
+          <a:bodyPr wrap="square" anchor="t" lIns="0" rIns="0" tIns="0" bIns="0">
+            <a:spAutoFit/>
+          </a:bodyPr>
+          <a:lstStyle/>
+          <a:p>
+            <a:pPr algn="l">
+              <a:lnSpc>
+                <a:spcPct val="100000"/>
+              </a:lnSpc>
+              <a:spcAft>
+                <a:spcPts val="0"/>
+              </a:spcAft>
+            </a:pPr>
+            <a:r>
+              <a:rPr sz="950" b="0" i="0">
+                <a:solidFill>
+                  <a:srgbClr val="898781"/>
+                </a:solidFill>
+                <a:latin typeface="Calibri"/>
+              </a:rPr>
+              <a:t>GCV Solar + Storage Valuation  |  E3 Applicant Exercise</a:t>
+            </a:r>
+          </a:p>
+        </p:txBody>
+      </p:sp>
+      <p:sp>
+        <p:nvSpPr>
+          <p:cNvPr id="7" name="TextBox 6"/>
+          <p:cNvSpPr txBox="1"/>
+          <p:nvPr/>
+        </p:nvSpPr>
+        <p:spPr>
+          <a:xfrm>
+            <a:off x="11094415" y="6473952"/>
+            <a:ext cx="640080" cy="274320"/>
+          </a:xfrm>
+          <a:prstGeom prst="rect">
+            <a:avLst/>
+          </a:prstGeom>
+          <a:noFill/>
+        </p:spPr>
+        <p:txBody>
+          <a:bodyPr wrap="square" anchor="t" lIns="0" rIns="0" tIns="0" bIns="0">
+            <a:spAutoFit/>
+          </a:bodyPr>
+          <a:lstStyle/>
+          <a:p>
+            <a:pPr algn="r">
+              <a:lnSpc>
+                <a:spcPct val="100000"/>
+              </a:lnSpc>
+              <a:spcAft>
+                <a:spcPts val="0"/>
+              </a:spcAft>
+            </a:pPr>
+            <a:r>
+              <a:rPr sz="950" b="0" i="0">
+                <a:solidFill>
+                  <a:srgbClr val="898781"/>
+                </a:solidFill>
+                <a:latin typeface="Calibri"/>
+              </a:rPr>
+              <a:t>11 / 11</a:t>
             </a:r>
           </a:p>
         </p:txBody>
@@ -4240,7 +5819,7 @@
                 </a:solidFill>
                 <a:latin typeface="Calibri"/>
               </a:rPr>
-              <a:t>2 / 10</a:t>
+              <a:t>2 / 11</a:t>
             </a:r>
           </a:p>
         </p:txBody>
@@ -5427,7 +7006,7 @@
                 </a:solidFill>
                 <a:latin typeface="Calibri"/>
               </a:rPr>
-              <a:t>3 / 10</a:t>
+              <a:t>3 / 11</a:t>
             </a:r>
           </a:p>
         </p:txBody>
@@ -5851,7 +7430,7 @@
                 </a:solidFill>
                 <a:latin typeface="Calibri"/>
               </a:rPr>
-              <a:t>4 / 10</a:t>
+              <a:t>4 / 11</a:t>
             </a:r>
           </a:p>
         </p:txBody>
@@ -6387,7 +7966,7 @@
                 </a:solidFill>
                 <a:latin typeface="Calibri"/>
               </a:rPr>
-              <a:t>5 / 10</a:t>
+              <a:t>5 / 11</a:t>
             </a:r>
           </a:p>
         </p:txBody>
@@ -7181,7 +8760,7 @@
                 </a:solidFill>
                 <a:latin typeface="Calibri"/>
               </a:rPr>
-              <a:t>6 / 10</a:t>
+              <a:t>6 / 11</a:t>
             </a:r>
           </a:p>
         </p:txBody>
@@ -7586,7 +9165,7 @@
                 </a:solidFill>
                 <a:latin typeface="Calibri"/>
               </a:rPr>
-              <a:t>7 / 10</a:t>
+              <a:t>7 / 11</a:t>
             </a:r>
           </a:p>
         </p:txBody>
@@ -7988,7 +9567,7 @@
                 </a:solidFill>
                 <a:latin typeface="Calibri"/>
               </a:rPr>
-              <a:t>Q3A  ·  FORWARD OUTLOOK</a:t>
+              <a:t>Q2D  ·  RESERVE SCENARIO (EXTENSION)</a:t>
             </a:r>
           </a:p>
         </p:txBody>
@@ -8030,7 +9609,7 @@
                 </a:solidFill>
                 <a:latin typeface="Calibri"/>
               </a:rPr>
-              <a:t>How Will Each Revenue Stream Evolve Over the Next Decade?</a:t>
+              <a:t>Layering NYISO Reserve Revenue on Top of Energy Arbitrage</a:t>
             </a:r>
           </a:p>
         </p:txBody>
@@ -8158,65 +9737,130 @@
                 </a:solidFill>
                 <a:latin typeface="Calibri"/>
               </a:rPr>
-              <a:t>8 / 10</a:t>
-            </a:r>
-          </a:p>
-        </p:txBody>
-      </p:sp>
-      <p:sp>
-        <p:nvSpPr>
-          <p:cNvPr id="8" name="Rectangle 7"/>
-          <p:cNvSpPr/>
-          <p:nvPr/>
-        </p:nvSpPr>
-        <p:spPr>
-          <a:xfrm>
-            <a:off x="502920" y="1463040"/>
-            <a:ext cx="3611880" cy="73152"/>
-          </a:xfrm>
-          <a:prstGeom prst="rect">
-            <a:avLst/>
-          </a:prstGeom>
-          <a:solidFill>
-            <a:srgbClr val="2A78D6"/>
-          </a:solidFill>
-          <a:ln>
-            <a:noFill/>
-          </a:ln>
-          <a:effectLst/>
-        </p:spPr>
-        <p:style>
-          <a:lnRef idx="1">
-            <a:schemeClr val="accent1"/>
-          </a:lnRef>
-          <a:fillRef idx="3">
-            <a:schemeClr val="accent1"/>
-          </a:fillRef>
-          <a:effectRef idx="2">
-            <a:schemeClr val="accent1"/>
-          </a:effectRef>
-          <a:fontRef idx="minor">
-            <a:schemeClr val="lt1"/>
-          </a:fontRef>
-        </p:style>
-        <p:txBody>
-          <a:bodyPr rtlCol="0" anchor="ctr"/>
-          <a:lstStyle/>
-          <a:p>
-            <a:pPr algn="ctr"/>
-          </a:p>
-        </p:txBody>
-      </p:sp>
-      <p:sp>
-        <p:nvSpPr>
-          <p:cNvPr id="9" name="TextBox 8"/>
+              <a:t>8 / 11</a:t>
+            </a:r>
+          </a:p>
+        </p:txBody>
+      </p:sp>
+      <p:pic>
+        <p:nvPicPr>
+          <p:cNvPr id="8" name="Picture 7" descr="q2_energy_only_by_config.png"/>
+          <p:cNvPicPr>
+            <a:picLocks noChangeAspect="1"/>
+          </p:cNvPicPr>
+          <p:nvPr/>
+        </p:nvPicPr>
+        <p:blipFill>
+          <a:blip r:embed="rId2"/>
+          <a:stretch>
+            <a:fillRect/>
+          </a:stretch>
+        </p:blipFill>
+        <p:spPr>
+          <a:xfrm>
+            <a:off x="375680" y="1371600"/>
+            <a:ext cx="5512279" cy="3246120"/>
+          </a:xfrm>
+          <a:prstGeom prst="rect">
+            <a:avLst/>
+          </a:prstGeom>
+        </p:spPr>
+      </p:pic>
+      <p:pic>
+        <p:nvPicPr>
+          <p:cNvPr id="9" name="Picture 8" descr="q2_energy_plus_reserve_by_config.png"/>
+          <p:cNvPicPr>
+            <a:picLocks noChangeAspect="1"/>
+          </p:cNvPicPr>
+          <p:nvPr/>
+        </p:nvPicPr>
+        <p:blipFill>
+          <a:blip r:embed="rId3"/>
+          <a:stretch>
+            <a:fillRect/>
+          </a:stretch>
+        </p:blipFill>
+        <p:spPr>
+          <a:xfrm>
+            <a:off x="6273560" y="1371600"/>
+            <a:ext cx="5512279" cy="3246120"/>
+          </a:xfrm>
+          <a:prstGeom prst="rect">
+            <a:avLst/>
+          </a:prstGeom>
+        </p:spPr>
+      </p:pic>
+      <p:sp>
+        <p:nvSpPr>
+          <p:cNvPr id="10" name="TextBox 9"/>
           <p:cNvSpPr txBox="1"/>
           <p:nvPr/>
         </p:nvSpPr>
         <p:spPr>
           <a:xfrm>
-            <a:off x="502920" y="1691640"/>
-            <a:ext cx="3611880" cy="457200"/>
+            <a:off x="502920" y="4754880"/>
+            <a:ext cx="11155680" cy="1463040"/>
+          </a:xfrm>
+          <a:prstGeom prst="rect">
+            <a:avLst/>
+          </a:prstGeom>
+          <a:noFill/>
+        </p:spPr>
+        <p:txBody>
+          <a:bodyPr wrap="square" lIns="0" rIns="0" tIns="0" bIns="0">
+            <a:spAutoFit/>
+          </a:bodyPr>
+          <a:lstStyle/>
+          <a:p>
+            <a:pPr algn="l">
+              <a:lnSpc>
+                <a:spcPct val="108000"/>
+              </a:lnSpc>
+              <a:spcAft>
+                <a:spcPts val="800"/>
+              </a:spcAft>
+            </a:pPr>
+            <a:r>
+              <a:rPr sz="1250">
+                <a:solidFill>
+                  <a:srgbClr val="52514E"/>
+                </a:solidFill>
+                <a:latin typeface="Calibri"/>
+              </a:rPr>
+              <a:t>—  Beyond the base exercise: estimates additional revenue from offering NYISO reserve capacity at $1.25/MW-hr (midpoint of the $1–1.5/MW range you flagged). Headroom = capacity to increase output on call; footroom = capacity to decrease output on call.</a:t>
+            </a:r>
+          </a:p>
+          <a:p>
+            <a:pPr algn="l">
+              <a:lnSpc>
+                <a:spcPct val="108000"/>
+              </a:lnSpc>
+              <a:spcAft>
+                <a:spcPts val="800"/>
+              </a:spcAft>
+            </a:pPr>
+            <a:r>
+              <a:rPr sz="1250">
+                <a:solidFill>
+                  <a:srgbClr val="52514E"/>
+                </a:solidFill>
+                <a:latin typeface="Calibri"/>
+              </a:rPr>
+              <a:t>—  Solar offers footroom only (already at its irradiance-limited max) = that hour's delivered MW → +$0.69M (+3.6%). Storage reuses the Q2b/c daily schedule (footroom while charging, headroom while discharging, both simultaneously while idle) → +$0.91M (+36.9%). Combined sums the two → +$1.60M (+7.5%).</a:t>
+            </a:r>
+          </a:p>
+        </p:txBody>
+      </p:sp>
+      <p:sp>
+        <p:nvSpPr>
+          <p:cNvPr id="11" name="TextBox 10"/>
+          <p:cNvSpPr txBox="1"/>
+          <p:nvPr/>
+        </p:nvSpPr>
+        <p:spPr>
+          <a:xfrm>
+            <a:off x="502920" y="6355080"/>
+            <a:ext cx="11155680" cy="457200"/>
           </a:xfrm>
           <a:prstGeom prst="rect">
             <a:avLst/>
@@ -8238,494 +9882,13 @@
               </a:spcAft>
             </a:pPr>
             <a:r>
-              <a:rPr sz="1700" b="1" i="0">
-                <a:solidFill>
-                  <a:srgbClr val="0B0B0B"/>
-                </a:solidFill>
-                <a:latin typeface="Calibri"/>
-              </a:rPr>
-              <a:t>Standalone Solar</a:t>
-            </a:r>
-          </a:p>
-        </p:txBody>
-      </p:sp>
-      <p:sp>
-        <p:nvSpPr>
-          <p:cNvPr id="10" name="TextBox 9"/>
-          <p:cNvSpPr txBox="1"/>
-          <p:nvPr/>
-        </p:nvSpPr>
-        <p:spPr>
-          <a:xfrm>
-            <a:off x="502920" y="2148840"/>
-            <a:ext cx="3611880" cy="457200"/>
-          </a:xfrm>
-          <a:prstGeom prst="rect">
-            <a:avLst/>
-          </a:prstGeom>
-          <a:noFill/>
-        </p:spPr>
-        <p:txBody>
-          <a:bodyPr wrap="square" anchor="t" lIns="0" rIns="0" tIns="0" bIns="0">
-            <a:spAutoFit/>
-          </a:bodyPr>
-          <a:lstStyle/>
-          <a:p>
-            <a:pPr algn="l">
-              <a:lnSpc>
-                <a:spcPct val="100000"/>
-              </a:lnSpc>
-              <a:spcAft>
-                <a:spcPts val="0"/>
-              </a:spcAft>
-            </a:pPr>
-            <a:r>
-              <a:rPr sz="1350" b="1" i="1">
-                <a:solidFill>
-                  <a:srgbClr val="2A78D6"/>
-                </a:solidFill>
-                <a:latin typeface="Calibri"/>
-              </a:rPr>
-              <a:t>Capture price likely erodes</a:t>
-            </a:r>
-          </a:p>
-        </p:txBody>
-      </p:sp>
-      <p:sp>
-        <p:nvSpPr>
-          <p:cNvPr id="11" name="TextBox 10"/>
-          <p:cNvSpPr txBox="1"/>
-          <p:nvPr/>
-        </p:nvSpPr>
-        <p:spPr>
-          <a:xfrm>
-            <a:off x="502920" y="2697480"/>
-            <a:ext cx="3611880" cy="3474720"/>
-          </a:xfrm>
-          <a:prstGeom prst="rect">
-            <a:avLst/>
-          </a:prstGeom>
-          <a:noFill/>
-        </p:spPr>
-        <p:txBody>
-          <a:bodyPr wrap="square" lIns="0" rIns="0" tIns="0" bIns="0">
-            <a:spAutoFit/>
-          </a:bodyPr>
-          <a:lstStyle/>
-          <a:p>
-            <a:pPr algn="l">
-              <a:lnSpc>
-                <a:spcPct val="115000"/>
-              </a:lnSpc>
-              <a:spcAft>
-                <a:spcPts val="1400"/>
-              </a:spcAft>
-            </a:pPr>
-            <a:r>
-              <a:rPr sz="1300">
-                <a:solidFill>
-                  <a:srgbClr val="52514E"/>
-                </a:solidFill>
-                <a:latin typeface="Calibri"/>
-              </a:rPr>
-              <a:t>—  CLCPA mandates 70% renewables by 2030, 100% zero-emission grid by 2040 — a large wave of new solar enters NYISO.</a:t>
-            </a:r>
-          </a:p>
-          <a:p>
-            <a:pPr algn="l">
-              <a:lnSpc>
-                <a:spcPct val="115000"/>
-              </a:lnSpc>
-              <a:spcAft>
-                <a:spcPts val="1400"/>
-              </a:spcAft>
-            </a:pPr>
-            <a:r>
-              <a:rPr sz="1300">
-                <a:solidFill>
-                  <a:srgbClr val="52514E"/>
-                </a:solidFill>
-                <a:latin typeface="Calibri"/>
-              </a:rPr>
-              <a:t>—  More solar depresses midday prices ("duck curve" / cannibalization), even as the overall price level may rise with electrification-driven demand.</a:t>
-            </a:r>
-          </a:p>
-        </p:txBody>
-      </p:sp>
-      <p:sp>
-        <p:nvSpPr>
-          <p:cNvPr id="12" name="Rectangle 11"/>
-          <p:cNvSpPr/>
-          <p:nvPr/>
-        </p:nvSpPr>
-        <p:spPr>
-          <a:xfrm>
-            <a:off x="4297680" y="1463040"/>
-            <a:ext cx="3611880" cy="73152"/>
-          </a:xfrm>
-          <a:prstGeom prst="rect">
-            <a:avLst/>
-          </a:prstGeom>
-          <a:solidFill>
-            <a:srgbClr val="EB6834"/>
-          </a:solidFill>
-          <a:ln>
-            <a:noFill/>
-          </a:ln>
-          <a:effectLst/>
-        </p:spPr>
-        <p:style>
-          <a:lnRef idx="1">
-            <a:schemeClr val="accent1"/>
-          </a:lnRef>
-          <a:fillRef idx="3">
-            <a:schemeClr val="accent1"/>
-          </a:fillRef>
-          <a:effectRef idx="2">
-            <a:schemeClr val="accent1"/>
-          </a:effectRef>
-          <a:fontRef idx="minor">
-            <a:schemeClr val="lt1"/>
-          </a:fontRef>
-        </p:style>
-        <p:txBody>
-          <a:bodyPr rtlCol="0" anchor="ctr"/>
-          <a:lstStyle/>
-          <a:p>
-            <a:pPr algn="ctr"/>
-          </a:p>
-        </p:txBody>
-      </p:sp>
-      <p:sp>
-        <p:nvSpPr>
-          <p:cNvPr id="13" name="TextBox 12"/>
-          <p:cNvSpPr txBox="1"/>
-          <p:nvPr/>
-        </p:nvSpPr>
-        <p:spPr>
-          <a:xfrm>
-            <a:off x="4297680" y="1691640"/>
-            <a:ext cx="3611880" cy="457200"/>
-          </a:xfrm>
-          <a:prstGeom prst="rect">
-            <a:avLst/>
-          </a:prstGeom>
-          <a:noFill/>
-        </p:spPr>
-        <p:txBody>
-          <a:bodyPr wrap="square" anchor="t" lIns="0" rIns="0" tIns="0" bIns="0">
-            <a:spAutoFit/>
-          </a:bodyPr>
-          <a:lstStyle/>
-          <a:p>
-            <a:pPr algn="l">
-              <a:lnSpc>
-                <a:spcPct val="100000"/>
-              </a:lnSpc>
-              <a:spcAft>
-                <a:spcPts val="0"/>
-              </a:spcAft>
-            </a:pPr>
-            <a:r>
-              <a:rPr sz="1700" b="1" i="0">
-                <a:solidFill>
-                  <a:srgbClr val="0B0B0B"/>
-                </a:solidFill>
-                <a:latin typeface="Calibri"/>
-              </a:rPr>
-              <a:t>Standalone Storage</a:t>
-            </a:r>
-          </a:p>
-        </p:txBody>
-      </p:sp>
-      <p:sp>
-        <p:nvSpPr>
-          <p:cNvPr id="14" name="TextBox 13"/>
-          <p:cNvSpPr txBox="1"/>
-          <p:nvPr/>
-        </p:nvSpPr>
-        <p:spPr>
-          <a:xfrm>
-            <a:off x="4297680" y="2148840"/>
-            <a:ext cx="3611880" cy="457200"/>
-          </a:xfrm>
-          <a:prstGeom prst="rect">
-            <a:avLst/>
-          </a:prstGeom>
-          <a:noFill/>
-        </p:spPr>
-        <p:txBody>
-          <a:bodyPr wrap="square" anchor="t" lIns="0" rIns="0" tIns="0" bIns="0">
-            <a:spAutoFit/>
-          </a:bodyPr>
-          <a:lstStyle/>
-          <a:p>
-            <a:pPr algn="l">
-              <a:lnSpc>
-                <a:spcPct val="100000"/>
-              </a:lnSpc>
-              <a:spcAft>
-                <a:spcPts val="0"/>
-              </a:spcAft>
-            </a:pPr>
-            <a:r>
-              <a:rPr sz="1350" b="1" i="1">
-                <a:solidFill>
-                  <a:srgbClr val="EB6834"/>
-                </a:solidFill>
-                <a:latin typeface="Calibri"/>
-              </a:rPr>
-              <a:t>Value likely increases</a:t>
-            </a:r>
-          </a:p>
-        </p:txBody>
-      </p:sp>
-      <p:sp>
-        <p:nvSpPr>
-          <p:cNvPr id="15" name="TextBox 14"/>
-          <p:cNvSpPr txBox="1"/>
-          <p:nvPr/>
-        </p:nvSpPr>
-        <p:spPr>
-          <a:xfrm>
-            <a:off x="4297680" y="2697480"/>
-            <a:ext cx="3611880" cy="3474720"/>
-          </a:xfrm>
-          <a:prstGeom prst="rect">
-            <a:avLst/>
-          </a:prstGeom>
-          <a:noFill/>
-        </p:spPr>
-        <p:txBody>
-          <a:bodyPr wrap="square" lIns="0" rIns="0" tIns="0" bIns="0">
-            <a:spAutoFit/>
-          </a:bodyPr>
-          <a:lstStyle/>
-          <a:p>
-            <a:pPr algn="l">
-              <a:lnSpc>
-                <a:spcPct val="115000"/>
-              </a:lnSpc>
-              <a:spcAft>
-                <a:spcPts val="1400"/>
-              </a:spcAft>
-            </a:pPr>
-            <a:r>
-              <a:rPr sz="1300">
-                <a:solidFill>
-                  <a:srgbClr val="52514E"/>
-                </a:solidFill>
-                <a:latin typeface="Calibri"/>
-              </a:rPr>
-              <a:t>—  Same trend that hurts solar helps storage: steeper evening ramps widen the daily price spread storage arbitrages.</a:t>
-            </a:r>
-          </a:p>
-          <a:p>
-            <a:pPr algn="l">
-              <a:lnSpc>
-                <a:spcPct val="115000"/>
-              </a:lnSpc>
-              <a:spcAft>
-                <a:spcPts val="1400"/>
-              </a:spcAft>
-            </a:pPr>
-            <a:r>
-              <a:rPr sz="1300">
-                <a:solidFill>
-                  <a:srgbClr val="52514E"/>
-                </a:solidFill>
-                <a:latin typeface="Calibri"/>
-              </a:rPr>
-              <a:t>—  NYC's Peaker Rule retirements tighten local capacity. Risk: storage cannibalization if buildout outpaces the opportunity.</a:t>
-            </a:r>
-          </a:p>
-        </p:txBody>
-      </p:sp>
-      <p:sp>
-        <p:nvSpPr>
-          <p:cNvPr id="16" name="Rectangle 15"/>
-          <p:cNvSpPr/>
-          <p:nvPr/>
-        </p:nvSpPr>
-        <p:spPr>
-          <a:xfrm>
-            <a:off x="8092440" y="1463040"/>
-            <a:ext cx="3611880" cy="73152"/>
-          </a:xfrm>
-          <a:prstGeom prst="rect">
-            <a:avLst/>
-          </a:prstGeom>
-          <a:solidFill>
-            <a:srgbClr val="0B0B0B"/>
-          </a:solidFill>
-          <a:ln>
-            <a:noFill/>
-          </a:ln>
-          <a:effectLst/>
-        </p:spPr>
-        <p:style>
-          <a:lnRef idx="1">
-            <a:schemeClr val="accent1"/>
-          </a:lnRef>
-          <a:fillRef idx="3">
-            <a:schemeClr val="accent1"/>
-          </a:fillRef>
-          <a:effectRef idx="2">
-            <a:schemeClr val="accent1"/>
-          </a:effectRef>
-          <a:fontRef idx="minor">
-            <a:schemeClr val="lt1"/>
-          </a:fontRef>
-        </p:style>
-        <p:txBody>
-          <a:bodyPr rtlCol="0" anchor="ctr"/>
-          <a:lstStyle/>
-          <a:p>
-            <a:pPr algn="ctr"/>
-          </a:p>
-        </p:txBody>
-      </p:sp>
-      <p:sp>
-        <p:nvSpPr>
-          <p:cNvPr id="17" name="TextBox 16"/>
-          <p:cNvSpPr txBox="1"/>
-          <p:nvPr/>
-        </p:nvSpPr>
-        <p:spPr>
-          <a:xfrm>
-            <a:off x="8092440" y="1691640"/>
-            <a:ext cx="3611880" cy="457200"/>
-          </a:xfrm>
-          <a:prstGeom prst="rect">
-            <a:avLst/>
-          </a:prstGeom>
-          <a:noFill/>
-        </p:spPr>
-        <p:txBody>
-          <a:bodyPr wrap="square" anchor="t" lIns="0" rIns="0" tIns="0" bIns="0">
-            <a:spAutoFit/>
-          </a:bodyPr>
-          <a:lstStyle/>
-          <a:p>
-            <a:pPr algn="l">
-              <a:lnSpc>
-                <a:spcPct val="100000"/>
-              </a:lnSpc>
-              <a:spcAft>
-                <a:spcPts val="0"/>
-              </a:spcAft>
-            </a:pPr>
-            <a:r>
-              <a:rPr sz="1700" b="1" i="0">
-                <a:solidFill>
-                  <a:srgbClr val="0B0B0B"/>
-                </a:solidFill>
-                <a:latin typeface="Calibri"/>
-              </a:rPr>
-              <a:t>Combined System</a:t>
-            </a:r>
-          </a:p>
-        </p:txBody>
-      </p:sp>
-      <p:sp>
-        <p:nvSpPr>
-          <p:cNvPr id="18" name="TextBox 17"/>
-          <p:cNvSpPr txBox="1"/>
-          <p:nvPr/>
-        </p:nvSpPr>
-        <p:spPr>
-          <a:xfrm>
-            <a:off x="8092440" y="2148840"/>
-            <a:ext cx="3611880" cy="457200"/>
-          </a:xfrm>
-          <a:prstGeom prst="rect">
-            <a:avLst/>
-          </a:prstGeom>
-          <a:noFill/>
-        </p:spPr>
-        <p:txBody>
-          <a:bodyPr wrap="square" anchor="t" lIns="0" rIns="0" tIns="0" bIns="0">
-            <a:spAutoFit/>
-          </a:bodyPr>
-          <a:lstStyle/>
-          <a:p>
-            <a:pPr algn="l">
-              <a:lnSpc>
-                <a:spcPct val="100000"/>
-              </a:lnSpc>
-              <a:spcAft>
-                <a:spcPts val="0"/>
-              </a:spcAft>
-            </a:pPr>
-            <a:r>
-              <a:rPr sz="1350" b="1" i="1">
-                <a:solidFill>
-                  <a:srgbClr val="0B0B0B"/>
-                </a:solidFill>
-                <a:latin typeface="Calibri"/>
-              </a:rPr>
-              <a:t>Interaction benefit should grow</a:t>
-            </a:r>
-          </a:p>
-        </p:txBody>
-      </p:sp>
-      <p:sp>
-        <p:nvSpPr>
-          <p:cNvPr id="19" name="TextBox 18"/>
-          <p:cNvSpPr txBox="1"/>
-          <p:nvPr/>
-        </p:nvSpPr>
-        <p:spPr>
-          <a:xfrm>
-            <a:off x="8092440" y="2697480"/>
-            <a:ext cx="3611880" cy="3474720"/>
-          </a:xfrm>
-          <a:prstGeom prst="rect">
-            <a:avLst/>
-          </a:prstGeom>
-          <a:noFill/>
-        </p:spPr>
-        <p:txBody>
-          <a:bodyPr wrap="square" lIns="0" rIns="0" tIns="0" bIns="0">
-            <a:spAutoFit/>
-          </a:bodyPr>
-          <a:lstStyle/>
-          <a:p>
-            <a:pPr algn="l">
-              <a:lnSpc>
-                <a:spcPct val="115000"/>
-              </a:lnSpc>
-              <a:spcAft>
-                <a:spcPts val="1400"/>
-              </a:spcAft>
-            </a:pPr>
-            <a:r>
-              <a:rPr sz="1300">
-                <a:solidFill>
-                  <a:srgbClr val="52514E"/>
-                </a:solidFill>
-                <a:latin typeface="Calibri"/>
-              </a:rPr>
-              <a:t>—  Today's interaction (+0.03%) reflects minimal clipping.</a:t>
-            </a:r>
-          </a:p>
-          <a:p>
-            <a:pPr algn="l">
-              <a:lnSpc>
-                <a:spcPct val="115000"/>
-              </a:lnSpc>
-              <a:spcAft>
-                <a:spcPts val="1400"/>
-              </a:spcAft>
-            </a:pPr>
-            <a:r>
-              <a:rPr sz="1300">
-                <a:solidFill>
-                  <a:srgbClr val="52514E"/>
-                </a:solidFill>
-                <a:latin typeface="Calibri"/>
-              </a:rPr>
-              <a:t>—  As solar penetration rises, a co-located battery's ability to absorb otherwise-curtailed solar becomes more valuable — strengthening the strategic case for pairing.</a:t>
+              <a:rPr sz="1150" b="0" i="1">
+                <a:solidFill>
+                  <a:srgbClr val="898781"/>
+                </a:solidFill>
+                <a:latin typeface="Calibri"/>
+              </a:rPr>
+              <a:t>Illustrative only: real NYISO reserve products carry response-time, minimum-run, and co-optimization rules stricter than modeled here — a more rigorous treatment is part of the Q3b follow-on scope.</a:t>
             </a:r>
           </a:p>
         </p:txBody>
@@ -8837,7 +10000,7 @@
                 </a:solidFill>
                 <a:latin typeface="Calibri"/>
               </a:rPr>
-              <a:t>Q3B  ·  PROPOSED FOLLOW-ON STUDY</a:t>
+              <a:t>Q3A  ·  FORWARD OUTLOOK</a:t>
             </a:r>
           </a:p>
         </p:txBody>
@@ -8879,7 +10042,7 @@
                 </a:solidFill>
                 <a:latin typeface="Calibri"/>
               </a:rPr>
-              <a:t>A More Complete Revenue Forecast — 10 Additional Hours</a:t>
+              <a:t>How Will Each Revenue Stream Evolve Over the Next Decade?</a:t>
             </a:r>
           </a:p>
         </p:txBody>
@@ -9007,23 +10170,23 @@
                 </a:solidFill>
                 <a:latin typeface="Calibri"/>
               </a:rPr>
-              <a:t>9 / 10</a:t>
-            </a:r>
-          </a:p>
-        </p:txBody>
-      </p:sp>
-      <p:sp>
-        <p:nvSpPr>
-          <p:cNvPr id="8" name="Oval 7"/>
+              <a:t>9 / 11</a:t>
+            </a:r>
+          </a:p>
+        </p:txBody>
+      </p:sp>
+      <p:sp>
+        <p:nvSpPr>
+          <p:cNvPr id="8" name="Rectangle 7"/>
           <p:cNvSpPr/>
           <p:nvPr/>
         </p:nvSpPr>
         <p:spPr>
           <a:xfrm>
-            <a:off x="502920" y="1508760"/>
-            <a:ext cx="457200" cy="457200"/>
-          </a:xfrm>
-          <a:prstGeom prst="ellipse">
+            <a:off x="502920" y="1463040"/>
+            <a:ext cx="3611880" cy="73152"/>
+          </a:xfrm>
+          <a:prstGeom prst="rect">
             <a:avLst/>
           </a:prstGeom>
           <a:solidFill>
@@ -9049,18 +10212,10 @@
           </a:fontRef>
         </p:style>
         <p:txBody>
-          <a:bodyPr rtlCol="0" anchor="ctr" wrap="none"/>
+          <a:bodyPr rtlCol="0" anchor="ctr"/>
           <a:lstStyle/>
           <a:p>
             <a:pPr algn="ctr"/>
-            <a:r>
-              <a:rPr sz="1600" b="1">
-                <a:solidFill>
-                  <a:srgbClr val="FFFFFF"/>
-                </a:solidFill>
-              </a:rPr>
-              <a:t>1</a:t>
-            </a:r>
           </a:p>
         </p:txBody>
       </p:sp>
@@ -9072,8 +10227,8 @@
         </p:nvSpPr>
         <p:spPr>
           <a:xfrm>
-            <a:off x="1143000" y="1490472"/>
-            <a:ext cx="2834640" cy="365760"/>
+            <a:off x="502920" y="1691640"/>
+            <a:ext cx="3611880" cy="457200"/>
           </a:xfrm>
           <a:prstGeom prst="rect">
             <a:avLst/>
@@ -9095,38 +10250,139 @@
               </a:spcAft>
             </a:pPr>
             <a:r>
-              <a:rPr sz="1500" b="1" i="0">
+              <a:rPr sz="1700" b="1" i="0">
                 <a:solidFill>
                   <a:srgbClr val="0B0B0B"/>
                 </a:solidFill>
                 <a:latin typeface="Calibri"/>
               </a:rPr>
-              <a:t>Forward price shapes</a:t>
-            </a:r>
-          </a:p>
-        </p:txBody>
-      </p:sp>
-      <p:sp>
-        <p:nvSpPr>
-          <p:cNvPr id="10" name="Rectangle 9"/>
+              <a:t>Standalone Solar</a:t>
+            </a:r>
+          </a:p>
+        </p:txBody>
+      </p:sp>
+      <p:sp>
+        <p:nvSpPr>
+          <p:cNvPr id="10" name="TextBox 9"/>
+          <p:cNvSpPr txBox="1"/>
+          <p:nvPr/>
+        </p:nvSpPr>
+        <p:spPr>
+          <a:xfrm>
+            <a:off x="502920" y="2148840"/>
+            <a:ext cx="3611880" cy="457200"/>
+          </a:xfrm>
+          <a:prstGeom prst="rect">
+            <a:avLst/>
+          </a:prstGeom>
+          <a:noFill/>
+        </p:spPr>
+        <p:txBody>
+          <a:bodyPr wrap="square" anchor="t" lIns="0" rIns="0" tIns="0" bIns="0">
+            <a:spAutoFit/>
+          </a:bodyPr>
+          <a:lstStyle/>
+          <a:p>
+            <a:pPr algn="l">
+              <a:lnSpc>
+                <a:spcPct val="100000"/>
+              </a:lnSpc>
+              <a:spcAft>
+                <a:spcPts val="0"/>
+              </a:spcAft>
+            </a:pPr>
+            <a:r>
+              <a:rPr sz="1350" b="1" i="1">
+                <a:solidFill>
+                  <a:srgbClr val="2A78D6"/>
+                </a:solidFill>
+                <a:latin typeface="Calibri"/>
+              </a:rPr>
+              <a:t>Capture price likely erodes</a:t>
+            </a:r>
+          </a:p>
+        </p:txBody>
+      </p:sp>
+      <p:sp>
+        <p:nvSpPr>
+          <p:cNvPr id="11" name="TextBox 10"/>
+          <p:cNvSpPr txBox="1"/>
+          <p:nvPr/>
+        </p:nvSpPr>
+        <p:spPr>
+          <a:xfrm>
+            <a:off x="502920" y="2697480"/>
+            <a:ext cx="3611880" cy="3474720"/>
+          </a:xfrm>
+          <a:prstGeom prst="rect">
+            <a:avLst/>
+          </a:prstGeom>
+          <a:noFill/>
+        </p:spPr>
+        <p:txBody>
+          <a:bodyPr wrap="square" lIns="0" rIns="0" tIns="0" bIns="0">
+            <a:spAutoFit/>
+          </a:bodyPr>
+          <a:lstStyle/>
+          <a:p>
+            <a:pPr algn="l">
+              <a:lnSpc>
+                <a:spcPct val="115000"/>
+              </a:lnSpc>
+              <a:spcAft>
+                <a:spcPts val="1400"/>
+              </a:spcAft>
+            </a:pPr>
+            <a:r>
+              <a:rPr sz="1300">
+                <a:solidFill>
+                  <a:srgbClr val="52514E"/>
+                </a:solidFill>
+                <a:latin typeface="Calibri"/>
+              </a:rPr>
+              <a:t>—  CLCPA mandates 70% renewables by 2030, 100% zero-emission grid by 2040 — a large wave of new solar enters NYISO.</a:t>
+            </a:r>
+          </a:p>
+          <a:p>
+            <a:pPr algn="l">
+              <a:lnSpc>
+                <a:spcPct val="115000"/>
+              </a:lnSpc>
+              <a:spcAft>
+                <a:spcPts val="1400"/>
+              </a:spcAft>
+            </a:pPr>
+            <a:r>
+              <a:rPr sz="1300">
+                <a:solidFill>
+                  <a:srgbClr val="52514E"/>
+                </a:solidFill>
+                <a:latin typeface="Calibri"/>
+              </a:rPr>
+              <a:t>—  More solar depresses midday prices ("duck curve" / cannibalization), even as the overall price level may rise with electrification-driven demand.</a:t>
+            </a:r>
+          </a:p>
+        </p:txBody>
+      </p:sp>
+      <p:sp>
+        <p:nvSpPr>
+          <p:cNvPr id="12" name="Rectangle 11"/>
           <p:cNvSpPr/>
           <p:nvPr/>
         </p:nvSpPr>
         <p:spPr>
           <a:xfrm>
-            <a:off x="4069080" y="1527048"/>
-            <a:ext cx="777240" cy="292608"/>
+            <a:off x="4297680" y="1463040"/>
+            <a:ext cx="3611880" cy="73152"/>
           </a:xfrm>
           <a:prstGeom prst="rect">
             <a:avLst/>
           </a:prstGeom>
           <a:solidFill>
-            <a:srgbClr val="FCFCFB"/>
+            <a:srgbClr val="EB6834"/>
           </a:solidFill>
-          <a:ln w="9525">
-            <a:solidFill>
-              <a:srgbClr val="2A78D6"/>
-            </a:solidFill>
+          <a:ln>
+            <a:noFill/>
           </a:ln>
           <a:effectLst/>
         </p:spPr>
@@ -9154,14 +10410,14 @@
       </p:sp>
       <p:sp>
         <p:nvSpPr>
-          <p:cNvPr id="11" name="TextBox 10"/>
+          <p:cNvPr id="13" name="TextBox 12"/>
           <p:cNvSpPr txBox="1"/>
           <p:nvPr/>
         </p:nvSpPr>
         <p:spPr>
           <a:xfrm>
-            <a:off x="4069080" y="1563624"/>
-            <a:ext cx="777240" cy="256032"/>
+            <a:off x="4297680" y="1691640"/>
+            <a:ext cx="3611880" cy="457200"/>
           </a:xfrm>
           <a:prstGeom prst="rect">
             <a:avLst/>
@@ -9174,7 +10430,7 @@
           </a:bodyPr>
           <a:lstStyle/>
           <a:p>
-            <a:pPr algn="ctr">
+            <a:pPr algn="l">
               <a:lnSpc>
                 <a:spcPct val="100000"/>
               </a:lnSpc>
@@ -9183,27 +10439,27 @@
               </a:spcAft>
             </a:pPr>
             <a:r>
-              <a:rPr sz="1100" b="1" i="0">
-                <a:solidFill>
-                  <a:srgbClr val="2A78D6"/>
-                </a:solidFill>
-                <a:latin typeface="Calibri"/>
-              </a:rPr>
-              <a:t>~3 hrs</a:t>
-            </a:r>
-          </a:p>
-        </p:txBody>
-      </p:sp>
-      <p:sp>
-        <p:nvSpPr>
-          <p:cNvPr id="12" name="TextBox 11"/>
+              <a:rPr sz="1700" b="1" i="0">
+                <a:solidFill>
+                  <a:srgbClr val="0B0B0B"/>
+                </a:solidFill>
+                <a:latin typeface="Calibri"/>
+              </a:rPr>
+              <a:t>Standalone Storage</a:t>
+            </a:r>
+          </a:p>
+        </p:txBody>
+      </p:sp>
+      <p:sp>
+        <p:nvSpPr>
+          <p:cNvPr id="14" name="TextBox 13"/>
           <p:cNvSpPr txBox="1"/>
           <p:nvPr/>
         </p:nvSpPr>
         <p:spPr>
           <a:xfrm>
-            <a:off x="5029200" y="1490472"/>
-            <a:ext cx="6675120" cy="777240"/>
+            <a:off x="4297680" y="2148840"/>
+            <a:ext cx="3611880" cy="457200"/>
           </a:xfrm>
           <a:prstGeom prst="rect">
             <a:avLst/>
@@ -9218,40 +10474,101 @@
           <a:p>
             <a:pPr algn="l">
               <a:lnSpc>
-                <a:spcPct val="110000"/>
+                <a:spcPct val="100000"/>
               </a:lnSpc>
               <a:spcAft>
                 <a:spcPts val="0"/>
               </a:spcAft>
             </a:pPr>
             <a:r>
-              <a:rPr sz="1200" b="0" i="0">
+              <a:rPr sz="1350" b="1" i="1">
+                <a:solidFill>
+                  <a:srgbClr val="EB6834"/>
+                </a:solidFill>
+                <a:latin typeface="Calibri"/>
+              </a:rPr>
+              <a:t>Value likely increases</a:t>
+            </a:r>
+          </a:p>
+        </p:txBody>
+      </p:sp>
+      <p:sp>
+        <p:nvSpPr>
+          <p:cNvPr id="15" name="TextBox 14"/>
+          <p:cNvSpPr txBox="1"/>
+          <p:nvPr/>
+        </p:nvSpPr>
+        <p:spPr>
+          <a:xfrm>
+            <a:off x="4297680" y="2697480"/>
+            <a:ext cx="3611880" cy="3474720"/>
+          </a:xfrm>
+          <a:prstGeom prst="rect">
+            <a:avLst/>
+          </a:prstGeom>
+          <a:noFill/>
+        </p:spPr>
+        <p:txBody>
+          <a:bodyPr wrap="square" lIns="0" rIns="0" tIns="0" bIns="0">
+            <a:spAutoFit/>
+          </a:bodyPr>
+          <a:lstStyle/>
+          <a:p>
+            <a:pPr algn="l">
+              <a:lnSpc>
+                <a:spcPct val="115000"/>
+              </a:lnSpc>
+              <a:spcAft>
+                <a:spcPts val="1400"/>
+              </a:spcAft>
+            </a:pPr>
+            <a:r>
+              <a:rPr sz="1300">
                 <a:solidFill>
                   <a:srgbClr val="52514E"/>
                 </a:solidFill>
                 <a:latin typeface="Calibri"/>
               </a:rPr>
-              <a:t>Replace the 2023 backcast with a forward-looking hourly price shape reflecting expected capacity additions/retirements and load growth (electrification, data centers), grounded in published NYISO / NYSERDA CLCPA outlooks.</a:t>
-            </a:r>
-          </a:p>
-        </p:txBody>
-      </p:sp>
-      <p:sp>
-        <p:nvSpPr>
-          <p:cNvPr id="13" name="Rectangle 12"/>
+              <a:t>—  Same trend that hurts solar helps storage: steeper evening ramps widen the daily price spread storage arbitrages.</a:t>
+            </a:r>
+          </a:p>
+          <a:p>
+            <a:pPr algn="l">
+              <a:lnSpc>
+                <a:spcPct val="115000"/>
+              </a:lnSpc>
+              <a:spcAft>
+                <a:spcPts val="1400"/>
+              </a:spcAft>
+            </a:pPr>
+            <a:r>
+              <a:rPr sz="1300">
+                <a:solidFill>
+                  <a:srgbClr val="52514E"/>
+                </a:solidFill>
+                <a:latin typeface="Calibri"/>
+              </a:rPr>
+              <a:t>—  NYC's Peaker Rule retirements tighten local capacity. Risk: storage cannibalization if buildout outpaces the opportunity.</a:t>
+            </a:r>
+          </a:p>
+        </p:txBody>
+      </p:sp>
+      <p:sp>
+        <p:nvSpPr>
+          <p:cNvPr id="16" name="Rectangle 15"/>
           <p:cNvSpPr/>
           <p:nvPr/>
         </p:nvSpPr>
         <p:spPr>
           <a:xfrm>
-            <a:off x="502920" y="2295144"/>
-            <a:ext cx="11201400" cy="9525"/>
+            <a:off x="8092440" y="1463040"/>
+            <a:ext cx="3611880" cy="73152"/>
           </a:xfrm>
           <a:prstGeom prst="rect">
             <a:avLst/>
           </a:prstGeom>
           <a:solidFill>
-            <a:srgbClr val="E1E0D9"/>
+            <a:srgbClr val="0B0B0B"/>
           </a:solidFill>
           <a:ln>
             <a:noFill/>
@@ -9282,66 +10599,14 @@
       </p:sp>
       <p:sp>
         <p:nvSpPr>
-          <p:cNvPr id="14" name="Oval 13"/>
-          <p:cNvSpPr/>
-          <p:nvPr/>
-        </p:nvSpPr>
-        <p:spPr>
-          <a:xfrm>
-            <a:off x="502920" y="2404872"/>
-            <a:ext cx="457200" cy="457200"/>
-          </a:xfrm>
-          <a:prstGeom prst="ellipse">
-            <a:avLst/>
-          </a:prstGeom>
-          <a:solidFill>
-            <a:srgbClr val="2A78D6"/>
-          </a:solidFill>
-          <a:ln>
-            <a:noFill/>
-          </a:ln>
-          <a:effectLst/>
-        </p:spPr>
-        <p:style>
-          <a:lnRef idx="1">
-            <a:schemeClr val="accent1"/>
-          </a:lnRef>
-          <a:fillRef idx="3">
-            <a:schemeClr val="accent1"/>
-          </a:fillRef>
-          <a:effectRef idx="2">
-            <a:schemeClr val="accent1"/>
-          </a:effectRef>
-          <a:fontRef idx="minor">
-            <a:schemeClr val="lt1"/>
-          </a:fontRef>
-        </p:style>
-        <p:txBody>
-          <a:bodyPr rtlCol="0" anchor="ctr" wrap="none"/>
-          <a:lstStyle/>
-          <a:p>
-            <a:pPr algn="ctr"/>
-            <a:r>
-              <a:rPr sz="1600" b="1">
-                <a:solidFill>
-                  <a:srgbClr val="FFFFFF"/>
-                </a:solidFill>
-              </a:rPr>
-              <a:t>2</a:t>
-            </a:r>
-          </a:p>
-        </p:txBody>
-      </p:sp>
-      <p:sp>
-        <p:nvSpPr>
-          <p:cNvPr id="15" name="TextBox 14"/>
+          <p:cNvPr id="17" name="TextBox 16"/>
           <p:cNvSpPr txBox="1"/>
           <p:nvPr/>
         </p:nvSpPr>
         <p:spPr>
           <a:xfrm>
-            <a:off x="1143000" y="2386584"/>
-            <a:ext cx="2834640" cy="365760"/>
+            <a:off x="8092440" y="1691640"/>
+            <a:ext cx="3611880" cy="457200"/>
           </a:xfrm>
           <a:prstGeom prst="rect">
             <a:avLst/>
@@ -9363,73 +10628,27 @@
               </a:spcAft>
             </a:pPr>
             <a:r>
-              <a:rPr sz="1500" b="1" i="0">
+              <a:rPr sz="1700" b="1" i="0">
                 <a:solidFill>
                   <a:srgbClr val="0B0B0B"/>
                 </a:solidFill>
                 <a:latin typeface="Calibri"/>
               </a:rPr>
-              <a:t>Realistic operating assumptions</a:t>
-            </a:r>
-          </a:p>
-        </p:txBody>
-      </p:sp>
-      <p:sp>
-        <p:nvSpPr>
-          <p:cNvPr id="16" name="Rectangle 15"/>
-          <p:cNvSpPr/>
-          <p:nvPr/>
-        </p:nvSpPr>
-        <p:spPr>
-          <a:xfrm>
-            <a:off x="4069080" y="2423160"/>
-            <a:ext cx="777240" cy="292608"/>
-          </a:xfrm>
-          <a:prstGeom prst="rect">
-            <a:avLst/>
-          </a:prstGeom>
-          <a:solidFill>
-            <a:srgbClr val="FCFCFB"/>
-          </a:solidFill>
-          <a:ln w="9525">
-            <a:solidFill>
-              <a:srgbClr val="2A78D6"/>
-            </a:solidFill>
-          </a:ln>
-          <a:effectLst/>
-        </p:spPr>
-        <p:style>
-          <a:lnRef idx="1">
-            <a:schemeClr val="accent1"/>
-          </a:lnRef>
-          <a:fillRef idx="3">
-            <a:schemeClr val="accent1"/>
-          </a:fillRef>
-          <a:effectRef idx="2">
-            <a:schemeClr val="accent1"/>
-          </a:effectRef>
-          <a:fontRef idx="minor">
-            <a:schemeClr val="lt1"/>
-          </a:fontRef>
-        </p:style>
-        <p:txBody>
-          <a:bodyPr rtlCol="0" anchor="ctr"/>
-          <a:lstStyle/>
-          <a:p>
-            <a:pPr algn="ctr"/>
-          </a:p>
-        </p:txBody>
-      </p:sp>
-      <p:sp>
-        <p:nvSpPr>
-          <p:cNvPr id="17" name="TextBox 16"/>
+              <a:t>Combined System</a:t>
+            </a:r>
+          </a:p>
+        </p:txBody>
+      </p:sp>
+      <p:sp>
+        <p:nvSpPr>
+          <p:cNvPr id="18" name="TextBox 17"/>
           <p:cNvSpPr txBox="1"/>
           <p:nvPr/>
         </p:nvSpPr>
         <p:spPr>
           <a:xfrm>
-            <a:off x="4069080" y="2459736"/>
-            <a:ext cx="777240" cy="256032"/>
+            <a:off x="8092440" y="2148840"/>
+            <a:ext cx="3611880" cy="457200"/>
           </a:xfrm>
           <a:prstGeom prst="rect">
             <a:avLst/>
@@ -9442,7 +10661,7 @@
           </a:bodyPr>
           <a:lstStyle/>
           <a:p>
-            <a:pPr algn="ctr">
+            <a:pPr algn="l">
               <a:lnSpc>
                 <a:spcPct val="100000"/>
               </a:lnSpc>
@@ -9451,27 +10670,27 @@
               </a:spcAft>
             </a:pPr>
             <a:r>
-              <a:rPr sz="1100" b="1" i="0">
-                <a:solidFill>
-                  <a:srgbClr val="2A78D6"/>
-                </a:solidFill>
-                <a:latin typeface="Calibri"/>
-              </a:rPr>
-              <a:t>~2 hrs</a:t>
-            </a:r>
-          </a:p>
-        </p:txBody>
-      </p:sp>
-      <p:sp>
-        <p:nvSpPr>
-          <p:cNvPr id="18" name="TextBox 17"/>
+              <a:rPr sz="1350" b="1" i="1">
+                <a:solidFill>
+                  <a:srgbClr val="0B0B0B"/>
+                </a:solidFill>
+                <a:latin typeface="Calibri"/>
+              </a:rPr>
+              <a:t>Interaction benefit should grow</a:t>
+            </a:r>
+          </a:p>
+        </p:txBody>
+      </p:sp>
+      <p:sp>
+        <p:nvSpPr>
+          <p:cNvPr id="19" name="TextBox 18"/>
           <p:cNvSpPr txBox="1"/>
           <p:nvPr/>
         </p:nvSpPr>
         <p:spPr>
           <a:xfrm>
-            <a:off x="5029200" y="2386584"/>
-            <a:ext cx="6675120" cy="777240"/>
+            <a:off x="8092440" y="2697480"/>
+            <a:ext cx="3611880" cy="3474720"/>
           </a:xfrm>
           <a:prstGeom prst="rect">
             <a:avLst/>
@@ -9479,831 +10698,46 @@
           <a:noFill/>
         </p:spPr>
         <p:txBody>
-          <a:bodyPr wrap="square" anchor="t" lIns="0" rIns="0" tIns="0" bIns="0">
+          <a:bodyPr wrap="square" lIns="0" rIns="0" tIns="0" bIns="0">
             <a:spAutoFit/>
           </a:bodyPr>
           <a:lstStyle/>
           <a:p>
             <a:pPr algn="l">
               <a:lnSpc>
-                <a:spcPct val="110000"/>
-              </a:lnSpc>
-              <a:spcAft>
-                <a:spcPts val="0"/>
-              </a:spcAft>
-            </a:pPr>
-            <a:r>
-              <a:rPr sz="1200" b="0" i="0">
+                <a:spcPct val="115000"/>
+              </a:lnSpc>
+              <a:spcAft>
+                <a:spcPts val="1400"/>
+              </a:spcAft>
+            </a:pPr>
+            <a:r>
+              <a:rPr sz="1300">
                 <a:solidFill>
                   <a:srgbClr val="52514E"/>
                 </a:solidFill>
                 <a:latin typeface="Calibri"/>
               </a:rPr>
-              <a:t>Round-trip efficiency ~85–90% (not 100%), solar degradation (~0.5%/yr), battery degradation/augmentation, multi-cycle-per-day dispatch where economic.</a:t>
-            </a:r>
-          </a:p>
-        </p:txBody>
-      </p:sp>
-      <p:sp>
-        <p:nvSpPr>
-          <p:cNvPr id="19" name="Rectangle 18"/>
-          <p:cNvSpPr/>
-          <p:nvPr/>
-        </p:nvSpPr>
-        <p:spPr>
-          <a:xfrm>
-            <a:off x="502920" y="3191256"/>
-            <a:ext cx="11201400" cy="9525"/>
-          </a:xfrm>
-          <a:prstGeom prst="rect">
-            <a:avLst/>
-          </a:prstGeom>
-          <a:solidFill>
-            <a:srgbClr val="E1E0D9"/>
-          </a:solidFill>
-          <a:ln>
-            <a:noFill/>
-          </a:ln>
-          <a:effectLst/>
-        </p:spPr>
-        <p:style>
-          <a:lnRef idx="1">
-            <a:schemeClr val="accent1"/>
-          </a:lnRef>
-          <a:fillRef idx="3">
-            <a:schemeClr val="accent1"/>
-          </a:fillRef>
-          <a:effectRef idx="2">
-            <a:schemeClr val="accent1"/>
-          </a:effectRef>
-          <a:fontRef idx="minor">
-            <a:schemeClr val="lt1"/>
-          </a:fontRef>
-        </p:style>
-        <p:txBody>
-          <a:bodyPr rtlCol="0" anchor="ctr"/>
-          <a:lstStyle/>
-          <a:p>
-            <a:pPr algn="ctr"/>
-          </a:p>
-        </p:txBody>
-      </p:sp>
-      <p:sp>
-        <p:nvSpPr>
-          <p:cNvPr id="20" name="Oval 19"/>
-          <p:cNvSpPr/>
-          <p:nvPr/>
-        </p:nvSpPr>
-        <p:spPr>
-          <a:xfrm>
-            <a:off x="502920" y="3300984"/>
-            <a:ext cx="457200" cy="457200"/>
-          </a:xfrm>
-          <a:prstGeom prst="ellipse">
-            <a:avLst/>
-          </a:prstGeom>
-          <a:solidFill>
-            <a:srgbClr val="2A78D6"/>
-          </a:solidFill>
-          <a:ln>
-            <a:noFill/>
-          </a:ln>
-          <a:effectLst/>
-        </p:spPr>
-        <p:style>
-          <a:lnRef idx="1">
-            <a:schemeClr val="accent1"/>
-          </a:lnRef>
-          <a:fillRef idx="3">
-            <a:schemeClr val="accent1"/>
-          </a:fillRef>
-          <a:effectRef idx="2">
-            <a:schemeClr val="accent1"/>
-          </a:effectRef>
-          <a:fontRef idx="minor">
-            <a:schemeClr val="lt1"/>
-          </a:fontRef>
-        </p:style>
-        <p:txBody>
-          <a:bodyPr rtlCol="0" anchor="ctr" wrap="none"/>
-          <a:lstStyle/>
-          <a:p>
-            <a:pPr algn="ctr"/>
-            <a:r>
-              <a:rPr sz="1600" b="1">
-                <a:solidFill>
-                  <a:srgbClr val="FFFFFF"/>
-                </a:solidFill>
-              </a:rPr>
-              <a:t>3</a:t>
-            </a:r>
-          </a:p>
-        </p:txBody>
-      </p:sp>
-      <p:sp>
-        <p:nvSpPr>
-          <p:cNvPr id="21" name="TextBox 20"/>
-          <p:cNvSpPr txBox="1"/>
-          <p:nvPr/>
-        </p:nvSpPr>
-        <p:spPr>
-          <a:xfrm>
-            <a:off x="1143000" y="3282696"/>
-            <a:ext cx="2834640" cy="365760"/>
-          </a:xfrm>
-          <a:prstGeom prst="rect">
-            <a:avLst/>
-          </a:prstGeom>
-          <a:noFill/>
-        </p:spPr>
-        <p:txBody>
-          <a:bodyPr wrap="square" anchor="t" lIns="0" rIns="0" tIns="0" bIns="0">
-            <a:spAutoFit/>
-          </a:bodyPr>
-          <a:lstStyle/>
-          <a:p>
-            <a:pPr algn="l">
-              <a:lnSpc>
-                <a:spcPct val="100000"/>
-              </a:lnSpc>
-              <a:spcAft>
-                <a:spcPts val="0"/>
-              </a:spcAft>
-            </a:pPr>
-            <a:r>
-              <a:rPr sz="1500" b="1" i="0">
-                <a:solidFill>
-                  <a:srgbClr val="0B0B0B"/>
-                </a:solidFill>
-                <a:latin typeface="Calibri"/>
-              </a:rPr>
-              <a:t>Capacity &amp; ancillary revenue</a:t>
-            </a:r>
-          </a:p>
-        </p:txBody>
-      </p:sp>
-      <p:sp>
-        <p:nvSpPr>
-          <p:cNvPr id="22" name="Rectangle 21"/>
-          <p:cNvSpPr/>
-          <p:nvPr/>
-        </p:nvSpPr>
-        <p:spPr>
-          <a:xfrm>
-            <a:off x="4069080" y="3319272"/>
-            <a:ext cx="777240" cy="292608"/>
-          </a:xfrm>
-          <a:prstGeom prst="rect">
-            <a:avLst/>
-          </a:prstGeom>
-          <a:solidFill>
-            <a:srgbClr val="FCFCFB"/>
-          </a:solidFill>
-          <a:ln w="9525">
-            <a:solidFill>
-              <a:srgbClr val="2A78D6"/>
-            </a:solidFill>
-          </a:ln>
-          <a:effectLst/>
-        </p:spPr>
-        <p:style>
-          <a:lnRef idx="1">
-            <a:schemeClr val="accent1"/>
-          </a:lnRef>
-          <a:fillRef idx="3">
-            <a:schemeClr val="accent1"/>
-          </a:fillRef>
-          <a:effectRef idx="2">
-            <a:schemeClr val="accent1"/>
-          </a:effectRef>
-          <a:fontRef idx="minor">
-            <a:schemeClr val="lt1"/>
-          </a:fontRef>
-        </p:style>
-        <p:txBody>
-          <a:bodyPr rtlCol="0" anchor="ctr"/>
-          <a:lstStyle/>
-          <a:p>
-            <a:pPr algn="ctr"/>
-          </a:p>
-        </p:txBody>
-      </p:sp>
-      <p:sp>
-        <p:nvSpPr>
-          <p:cNvPr id="23" name="TextBox 22"/>
-          <p:cNvSpPr txBox="1"/>
-          <p:nvPr/>
-        </p:nvSpPr>
-        <p:spPr>
-          <a:xfrm>
-            <a:off x="4069080" y="3355848"/>
-            <a:ext cx="777240" cy="256032"/>
-          </a:xfrm>
-          <a:prstGeom prst="rect">
-            <a:avLst/>
-          </a:prstGeom>
-          <a:noFill/>
-        </p:spPr>
-        <p:txBody>
-          <a:bodyPr wrap="square" anchor="t" lIns="0" rIns="0" tIns="0" bIns="0">
-            <a:spAutoFit/>
-          </a:bodyPr>
-          <a:lstStyle/>
-          <a:p>
-            <a:pPr algn="ctr">
-              <a:lnSpc>
-                <a:spcPct val="100000"/>
-              </a:lnSpc>
-              <a:spcAft>
-                <a:spcPts val="0"/>
-              </a:spcAft>
-            </a:pPr>
-            <a:r>
-              <a:rPr sz="1100" b="1" i="0">
-                <a:solidFill>
-                  <a:srgbClr val="2A78D6"/>
-                </a:solidFill>
-                <a:latin typeface="Calibri"/>
-              </a:rPr>
-              <a:t>~2 hrs</a:t>
-            </a:r>
-          </a:p>
-        </p:txBody>
-      </p:sp>
-      <p:sp>
-        <p:nvSpPr>
-          <p:cNvPr id="24" name="TextBox 23"/>
-          <p:cNvSpPr txBox="1"/>
-          <p:nvPr/>
-        </p:nvSpPr>
-        <p:spPr>
-          <a:xfrm>
-            <a:off x="5029200" y="3282696"/>
-            <a:ext cx="6675120" cy="777240"/>
-          </a:xfrm>
-          <a:prstGeom prst="rect">
-            <a:avLst/>
-          </a:prstGeom>
-          <a:noFill/>
-        </p:spPr>
-        <p:txBody>
-          <a:bodyPr wrap="square" anchor="t" lIns="0" rIns="0" tIns="0" bIns="0">
-            <a:spAutoFit/>
-          </a:bodyPr>
-          <a:lstStyle/>
-          <a:p>
-            <a:pPr algn="l">
-              <a:lnSpc>
-                <a:spcPct val="110000"/>
-              </a:lnSpc>
-              <a:spcAft>
-                <a:spcPts val="0"/>
-              </a:spcAft>
-            </a:pPr>
-            <a:r>
-              <a:rPr sz="1200" b="0" i="0">
+              <a:t>—  Today's interaction (+0.03%) reflects minimal clipping.</a:t>
+            </a:r>
+          </a:p>
+          <a:p>
+            <a:pPr algn="l">
+              <a:lnSpc>
+                <a:spcPct val="115000"/>
+              </a:lnSpc>
+              <a:spcAft>
+                <a:spcPts val="1400"/>
+              </a:spcAft>
+            </a:pPr>
+            <a:r>
+              <a:rPr sz="1300">
                 <a:solidFill>
                   <a:srgbClr val="52514E"/>
                 </a:solidFill>
                 <a:latin typeface="Calibri"/>
               </a:rPr>
-              <a:t>Add NYISO capacity market (ICAP) and frequency regulation revenue — often the majority of a merchant battery's revenue stack. Likely the single biggest gap in the Q2 analysis.</a:t>
-            </a:r>
-          </a:p>
-        </p:txBody>
-      </p:sp>
-      <p:sp>
-        <p:nvSpPr>
-          <p:cNvPr id="25" name="Rectangle 24"/>
-          <p:cNvSpPr/>
-          <p:nvPr/>
-        </p:nvSpPr>
-        <p:spPr>
-          <a:xfrm>
-            <a:off x="502920" y="4087368"/>
-            <a:ext cx="11201400" cy="9525"/>
-          </a:xfrm>
-          <a:prstGeom prst="rect">
-            <a:avLst/>
-          </a:prstGeom>
-          <a:solidFill>
-            <a:srgbClr val="E1E0D9"/>
-          </a:solidFill>
-          <a:ln>
-            <a:noFill/>
-          </a:ln>
-          <a:effectLst/>
-        </p:spPr>
-        <p:style>
-          <a:lnRef idx="1">
-            <a:schemeClr val="accent1"/>
-          </a:lnRef>
-          <a:fillRef idx="3">
-            <a:schemeClr val="accent1"/>
-          </a:fillRef>
-          <a:effectRef idx="2">
-            <a:schemeClr val="accent1"/>
-          </a:effectRef>
-          <a:fontRef idx="minor">
-            <a:schemeClr val="lt1"/>
-          </a:fontRef>
-        </p:style>
-        <p:txBody>
-          <a:bodyPr rtlCol="0" anchor="ctr"/>
-          <a:lstStyle/>
-          <a:p>
-            <a:pPr algn="ctr"/>
-          </a:p>
-        </p:txBody>
-      </p:sp>
-      <p:sp>
-        <p:nvSpPr>
-          <p:cNvPr id="26" name="Oval 25"/>
-          <p:cNvSpPr/>
-          <p:nvPr/>
-        </p:nvSpPr>
-        <p:spPr>
-          <a:xfrm>
-            <a:off x="502920" y="4197096"/>
-            <a:ext cx="457200" cy="457200"/>
-          </a:xfrm>
-          <a:prstGeom prst="ellipse">
-            <a:avLst/>
-          </a:prstGeom>
-          <a:solidFill>
-            <a:srgbClr val="2A78D6"/>
-          </a:solidFill>
-          <a:ln>
-            <a:noFill/>
-          </a:ln>
-          <a:effectLst/>
-        </p:spPr>
-        <p:style>
-          <a:lnRef idx="1">
-            <a:schemeClr val="accent1"/>
-          </a:lnRef>
-          <a:fillRef idx="3">
-            <a:schemeClr val="accent1"/>
-          </a:fillRef>
-          <a:effectRef idx="2">
-            <a:schemeClr val="accent1"/>
-          </a:effectRef>
-          <a:fontRef idx="minor">
-            <a:schemeClr val="lt1"/>
-          </a:fontRef>
-        </p:style>
-        <p:txBody>
-          <a:bodyPr rtlCol="0" anchor="ctr" wrap="none"/>
-          <a:lstStyle/>
-          <a:p>
-            <a:pPr algn="ctr"/>
-            <a:r>
-              <a:rPr sz="1600" b="1">
-                <a:solidFill>
-                  <a:srgbClr val="FFFFFF"/>
-                </a:solidFill>
-              </a:rPr>
-              <a:t>4</a:t>
-            </a:r>
-          </a:p>
-        </p:txBody>
-      </p:sp>
-      <p:sp>
-        <p:nvSpPr>
-          <p:cNvPr id="27" name="TextBox 26"/>
-          <p:cNvSpPr txBox="1"/>
-          <p:nvPr/>
-        </p:nvSpPr>
-        <p:spPr>
-          <a:xfrm>
-            <a:off x="1143000" y="4178808"/>
-            <a:ext cx="2834640" cy="365760"/>
-          </a:xfrm>
-          <a:prstGeom prst="rect">
-            <a:avLst/>
-          </a:prstGeom>
-          <a:noFill/>
-        </p:spPr>
-        <p:txBody>
-          <a:bodyPr wrap="square" anchor="t" lIns="0" rIns="0" tIns="0" bIns="0">
-            <a:spAutoFit/>
-          </a:bodyPr>
-          <a:lstStyle/>
-          <a:p>
-            <a:pPr algn="l">
-              <a:lnSpc>
-                <a:spcPct val="100000"/>
-              </a:lnSpc>
-              <a:spcAft>
-                <a:spcPts val="0"/>
-              </a:spcAft>
-            </a:pPr>
-            <a:r>
-              <a:rPr sz="1500" b="1" i="0">
-                <a:solidFill>
-                  <a:srgbClr val="0B0B0B"/>
-                </a:solidFill>
-                <a:latin typeface="Calibri"/>
-              </a:rPr>
-              <a:t>Scenario / sensitivity analysis</a:t>
-            </a:r>
-          </a:p>
-        </p:txBody>
-      </p:sp>
-      <p:sp>
-        <p:nvSpPr>
-          <p:cNvPr id="28" name="Rectangle 27"/>
-          <p:cNvSpPr/>
-          <p:nvPr/>
-        </p:nvSpPr>
-        <p:spPr>
-          <a:xfrm>
-            <a:off x="4069080" y="4215384"/>
-            <a:ext cx="777240" cy="292608"/>
-          </a:xfrm>
-          <a:prstGeom prst="rect">
-            <a:avLst/>
-          </a:prstGeom>
-          <a:solidFill>
-            <a:srgbClr val="FCFCFB"/>
-          </a:solidFill>
-          <a:ln w="9525">
-            <a:solidFill>
-              <a:srgbClr val="2A78D6"/>
-            </a:solidFill>
-          </a:ln>
-          <a:effectLst/>
-        </p:spPr>
-        <p:style>
-          <a:lnRef idx="1">
-            <a:schemeClr val="accent1"/>
-          </a:lnRef>
-          <a:fillRef idx="3">
-            <a:schemeClr val="accent1"/>
-          </a:fillRef>
-          <a:effectRef idx="2">
-            <a:schemeClr val="accent1"/>
-          </a:effectRef>
-          <a:fontRef idx="minor">
-            <a:schemeClr val="lt1"/>
-          </a:fontRef>
-        </p:style>
-        <p:txBody>
-          <a:bodyPr rtlCol="0" anchor="ctr"/>
-          <a:lstStyle/>
-          <a:p>
-            <a:pPr algn="ctr"/>
-          </a:p>
-        </p:txBody>
-      </p:sp>
-      <p:sp>
-        <p:nvSpPr>
-          <p:cNvPr id="29" name="TextBox 28"/>
-          <p:cNvSpPr txBox="1"/>
-          <p:nvPr/>
-        </p:nvSpPr>
-        <p:spPr>
-          <a:xfrm>
-            <a:off x="4069080" y="4251960"/>
-            <a:ext cx="777240" cy="256032"/>
-          </a:xfrm>
-          <a:prstGeom prst="rect">
-            <a:avLst/>
-          </a:prstGeom>
-          <a:noFill/>
-        </p:spPr>
-        <p:txBody>
-          <a:bodyPr wrap="square" anchor="t" lIns="0" rIns="0" tIns="0" bIns="0">
-            <a:spAutoFit/>
-          </a:bodyPr>
-          <a:lstStyle/>
-          <a:p>
-            <a:pPr algn="ctr">
-              <a:lnSpc>
-                <a:spcPct val="100000"/>
-              </a:lnSpc>
-              <a:spcAft>
-                <a:spcPts val="0"/>
-              </a:spcAft>
-            </a:pPr>
-            <a:r>
-              <a:rPr sz="1100" b="1" i="0">
-                <a:solidFill>
-                  <a:srgbClr val="2A78D6"/>
-                </a:solidFill>
-                <a:latin typeface="Calibri"/>
-              </a:rPr>
-              <a:t>~2 hrs</a:t>
-            </a:r>
-          </a:p>
-        </p:txBody>
-      </p:sp>
-      <p:sp>
-        <p:nvSpPr>
-          <p:cNvPr id="30" name="TextBox 29"/>
-          <p:cNvSpPr txBox="1"/>
-          <p:nvPr/>
-        </p:nvSpPr>
-        <p:spPr>
-          <a:xfrm>
-            <a:off x="5029200" y="4178808"/>
-            <a:ext cx="6675120" cy="777240"/>
-          </a:xfrm>
-          <a:prstGeom prst="rect">
-            <a:avLst/>
-          </a:prstGeom>
-          <a:noFill/>
-        </p:spPr>
-        <p:txBody>
-          <a:bodyPr wrap="square" anchor="t" lIns="0" rIns="0" tIns="0" bIns="0">
-            <a:spAutoFit/>
-          </a:bodyPr>
-          <a:lstStyle/>
-          <a:p>
-            <a:pPr algn="l">
-              <a:lnSpc>
-                <a:spcPct val="110000"/>
-              </a:lnSpc>
-              <a:spcAft>
-                <a:spcPts val="0"/>
-              </a:spcAft>
-            </a:pPr>
-            <a:r>
-              <a:rPr sz="1200" b="0" i="0">
-                <a:solidFill>
-                  <a:srgbClr val="52514E"/>
-                </a:solidFill>
-                <a:latin typeface="Calibri"/>
-              </a:rPr>
-              <a:t>High/low cases on load growth, gas prices, and renewable build-out pace, given how uncertain the 10-year price path is.</a:t>
-            </a:r>
-          </a:p>
-        </p:txBody>
-      </p:sp>
-      <p:sp>
-        <p:nvSpPr>
-          <p:cNvPr id="31" name="Rectangle 30"/>
-          <p:cNvSpPr/>
-          <p:nvPr/>
-        </p:nvSpPr>
-        <p:spPr>
-          <a:xfrm>
-            <a:off x="502920" y="4983480"/>
-            <a:ext cx="11201400" cy="9525"/>
-          </a:xfrm>
-          <a:prstGeom prst="rect">
-            <a:avLst/>
-          </a:prstGeom>
-          <a:solidFill>
-            <a:srgbClr val="E1E0D9"/>
-          </a:solidFill>
-          <a:ln>
-            <a:noFill/>
-          </a:ln>
-          <a:effectLst/>
-        </p:spPr>
-        <p:style>
-          <a:lnRef idx="1">
-            <a:schemeClr val="accent1"/>
-          </a:lnRef>
-          <a:fillRef idx="3">
-            <a:schemeClr val="accent1"/>
-          </a:fillRef>
-          <a:effectRef idx="2">
-            <a:schemeClr val="accent1"/>
-          </a:effectRef>
-          <a:fontRef idx="minor">
-            <a:schemeClr val="lt1"/>
-          </a:fontRef>
-        </p:style>
-        <p:txBody>
-          <a:bodyPr rtlCol="0" anchor="ctr"/>
-          <a:lstStyle/>
-          <a:p>
-            <a:pPr algn="ctr"/>
-          </a:p>
-        </p:txBody>
-      </p:sp>
-      <p:sp>
-        <p:nvSpPr>
-          <p:cNvPr id="32" name="Oval 31"/>
-          <p:cNvSpPr/>
-          <p:nvPr/>
-        </p:nvSpPr>
-        <p:spPr>
-          <a:xfrm>
-            <a:off x="502920" y="5093208"/>
-            <a:ext cx="457200" cy="457200"/>
-          </a:xfrm>
-          <a:prstGeom prst="ellipse">
-            <a:avLst/>
-          </a:prstGeom>
-          <a:solidFill>
-            <a:srgbClr val="2A78D6"/>
-          </a:solidFill>
-          <a:ln>
-            <a:noFill/>
-          </a:ln>
-          <a:effectLst/>
-        </p:spPr>
-        <p:style>
-          <a:lnRef idx="1">
-            <a:schemeClr val="accent1"/>
-          </a:lnRef>
-          <a:fillRef idx="3">
-            <a:schemeClr val="accent1"/>
-          </a:fillRef>
-          <a:effectRef idx="2">
-            <a:schemeClr val="accent1"/>
-          </a:effectRef>
-          <a:fontRef idx="minor">
-            <a:schemeClr val="lt1"/>
-          </a:fontRef>
-        </p:style>
-        <p:txBody>
-          <a:bodyPr rtlCol="0" anchor="ctr" wrap="none"/>
-          <a:lstStyle/>
-          <a:p>
-            <a:pPr algn="ctr"/>
-            <a:r>
-              <a:rPr sz="1600" b="1">
-                <a:solidFill>
-                  <a:srgbClr val="FFFFFF"/>
-                </a:solidFill>
-              </a:rPr>
-              <a:t>5</a:t>
-            </a:r>
-          </a:p>
-        </p:txBody>
-      </p:sp>
-      <p:sp>
-        <p:nvSpPr>
-          <p:cNvPr id="33" name="TextBox 32"/>
-          <p:cNvSpPr txBox="1"/>
-          <p:nvPr/>
-        </p:nvSpPr>
-        <p:spPr>
-          <a:xfrm>
-            <a:off x="1143000" y="5074920"/>
-            <a:ext cx="2834640" cy="365760"/>
-          </a:xfrm>
-          <a:prstGeom prst="rect">
-            <a:avLst/>
-          </a:prstGeom>
-          <a:noFill/>
-        </p:spPr>
-        <p:txBody>
-          <a:bodyPr wrap="square" anchor="t" lIns="0" rIns="0" tIns="0" bIns="0">
-            <a:spAutoFit/>
-          </a:bodyPr>
-          <a:lstStyle/>
-          <a:p>
-            <a:pPr algn="l">
-              <a:lnSpc>
-                <a:spcPct val="100000"/>
-              </a:lnSpc>
-              <a:spcAft>
-                <a:spcPts val="0"/>
-              </a:spcAft>
-            </a:pPr>
-            <a:r>
-              <a:rPr sz="1500" b="1" i="0">
-                <a:solidFill>
-                  <a:srgbClr val="0B0B0B"/>
-                </a:solidFill>
-                <a:latin typeface="Calibri"/>
-              </a:rPr>
-              <a:t>Full pro forma</a:t>
-            </a:r>
-          </a:p>
-        </p:txBody>
-      </p:sp>
-      <p:sp>
-        <p:nvSpPr>
-          <p:cNvPr id="34" name="Rectangle 33"/>
-          <p:cNvSpPr/>
-          <p:nvPr/>
-        </p:nvSpPr>
-        <p:spPr>
-          <a:xfrm>
-            <a:off x="4069080" y="5111496"/>
-            <a:ext cx="777240" cy="292608"/>
-          </a:xfrm>
-          <a:prstGeom prst="rect">
-            <a:avLst/>
-          </a:prstGeom>
-          <a:solidFill>
-            <a:srgbClr val="FCFCFB"/>
-          </a:solidFill>
-          <a:ln w="9525">
-            <a:solidFill>
-              <a:srgbClr val="2A78D6"/>
-            </a:solidFill>
-          </a:ln>
-          <a:effectLst/>
-        </p:spPr>
-        <p:style>
-          <a:lnRef idx="1">
-            <a:schemeClr val="accent1"/>
-          </a:lnRef>
-          <a:fillRef idx="3">
-            <a:schemeClr val="accent1"/>
-          </a:fillRef>
-          <a:effectRef idx="2">
-            <a:schemeClr val="accent1"/>
-          </a:effectRef>
-          <a:fontRef idx="minor">
-            <a:schemeClr val="lt1"/>
-          </a:fontRef>
-        </p:style>
-        <p:txBody>
-          <a:bodyPr rtlCol="0" anchor="ctr"/>
-          <a:lstStyle/>
-          <a:p>
-            <a:pPr algn="ctr"/>
-          </a:p>
-        </p:txBody>
-      </p:sp>
-      <p:sp>
-        <p:nvSpPr>
-          <p:cNvPr id="35" name="TextBox 34"/>
-          <p:cNvSpPr txBox="1"/>
-          <p:nvPr/>
-        </p:nvSpPr>
-        <p:spPr>
-          <a:xfrm>
-            <a:off x="4069080" y="5148072"/>
-            <a:ext cx="777240" cy="256032"/>
-          </a:xfrm>
-          <a:prstGeom prst="rect">
-            <a:avLst/>
-          </a:prstGeom>
-          <a:noFill/>
-        </p:spPr>
-        <p:txBody>
-          <a:bodyPr wrap="square" anchor="t" lIns="0" rIns="0" tIns="0" bIns="0">
-            <a:spAutoFit/>
-          </a:bodyPr>
-          <a:lstStyle/>
-          <a:p>
-            <a:pPr algn="ctr">
-              <a:lnSpc>
-                <a:spcPct val="100000"/>
-              </a:lnSpc>
-              <a:spcAft>
-                <a:spcPts val="0"/>
-              </a:spcAft>
-            </a:pPr>
-            <a:r>
-              <a:rPr sz="1100" b="1" i="0">
-                <a:solidFill>
-                  <a:srgbClr val="2A78D6"/>
-                </a:solidFill>
-                <a:latin typeface="Calibri"/>
-              </a:rPr>
-              <a:t>~1 hr</a:t>
-            </a:r>
-          </a:p>
-        </p:txBody>
-      </p:sp>
-      <p:sp>
-        <p:nvSpPr>
-          <p:cNvPr id="36" name="TextBox 35"/>
-          <p:cNvSpPr txBox="1"/>
-          <p:nvPr/>
-        </p:nvSpPr>
-        <p:spPr>
-          <a:xfrm>
-            <a:off x="5029200" y="5074920"/>
-            <a:ext cx="6675120" cy="777240"/>
-          </a:xfrm>
-          <a:prstGeom prst="rect">
-            <a:avLst/>
-          </a:prstGeom>
-          <a:noFill/>
-        </p:spPr>
-        <p:txBody>
-          <a:bodyPr wrap="square" anchor="t" lIns="0" rIns="0" tIns="0" bIns="0">
-            <a:spAutoFit/>
-          </a:bodyPr>
-          <a:lstStyle/>
-          <a:p>
-            <a:pPr algn="l">
-              <a:lnSpc>
-                <a:spcPct val="110000"/>
-              </a:lnSpc>
-              <a:spcAft>
-                <a:spcPts val="0"/>
-              </a:spcAft>
-            </a:pPr>
-            <a:r>
-              <a:rPr sz="1200" b="0" i="0">
-                <a:solidFill>
-                  <a:srgbClr val="52514E"/>
-                </a:solidFill>
-                <a:latin typeface="Calibri"/>
-              </a:rPr>
-              <a:t>Layer in provided capex, O&amp;M, financing, and ITC/IRA tax credit treatment to compute NPV/IRR rather than simple payback.</a:t>
+              <a:t>—  As solar penetration rises, a co-located battery's ability to absorb otherwise-curtailed solar becomes more valuable — strengthening the strategic case for pairing.</a:t>
             </a:r>
           </a:p>
         </p:txBody>

</xml_diff>

<commit_message>
Remove solar from Q2d reserve scenario
Standalone solar is a variable, non-dispatchable resource and does
not qualify to offer NYISO reserve products, so its reserve revenue
is now $0. Combined system's reserve revenue comes entirely from the
storage component ($0.91M, +4.3% uplift vs. the prior +7.5% that
incorrectly credited solar footroom). Updates the scenario script,
both charts, the Q2d writeup, and the deck slide accordingly. Also
fixes a slide 8 layout bug where the italic caveat note collided
with the footer.

Co-Authored-By: Claude Sonnet 5 <noreply@anthropic.com>
Claude-Session: https://claude.ai/code/session_01Wd98BoYaSaTQ6bNKBze8DQ
</commit_message>
<xml_diff>
--- a/GCV_Solar_Storage_Valuation.pptx
+++ b/GCV_Solar_Storage_Valuation.pptx
@@ -9846,7 +9846,7 @@
                 </a:solidFill>
                 <a:latin typeface="Calibri"/>
               </a:rPr>
-              <a:t>—  Solar offers footroom only (already at its irradiance-limited max) = that hour's delivered MW → +$0.69M (+3.6%). Storage reuses the Q2b/c daily schedule (footroom while charging, headroom while discharging, both simultaneously while idle) → +$0.91M (+36.9%). Combined sums the two → +$1.60M (+7.5%).</a:t>
+              <a:t>—  Solar cannot provide reserve — it is a variable, non-dispatchable resource, so it earns $0. Storage reuses the Q2b/c daily schedule (footroom while charging, headroom while discharging, both simultaneously while idle) → +$0.91M (+36.9%). Combined reserve comes entirely from the storage component → +$0.91M (+4.3%).</a:t>
             </a:r>
           </a:p>
         </p:txBody>
@@ -9859,8 +9859,8 @@
         </p:nvSpPr>
         <p:spPr>
           <a:xfrm>
-            <a:off x="502920" y="6263640"/>
-            <a:ext cx="11155680" cy="320040"/>
+            <a:off x="502920" y="6144768"/>
+            <a:ext cx="11155680" cy="274320"/>
           </a:xfrm>
           <a:prstGeom prst="rect">
             <a:avLst/>

</xml_diff>

<commit_message>
Rebuild deck with slide 5 Inputs & Notation and RT/DA caveat
Regenerates GCV_Solar_Storage_Valuation.pptx from the already-committed
build_deck.py changes: slide 5 now shows the Inputs & Notation
parameter chips (solar/storage sizing, RTE, price basis) plus the
RT-vs-DA perfect-foresight caveat.

Co-Authored-By: Claude Sonnet 5 <noreply@anthropic.com>
Claude-Session: https://claude.ai/code/session_01Wd98BoYaSaTQ6bNKBze8DQ
</commit_message>
<xml_diff>
--- a/GCV_Solar_Storage_Valuation.pptx
+++ b/GCV_Solar_Storage_Valuation.pptx
@@ -5,19 +5,19 @@
     <p:sldMasterId id="2147483648" r:id="rId1"/>
   </p:sldMasterIdLst>
   <p:sldIdLst>
-    <p:sldId id="256" r:id="rId7"/>
-    <p:sldId id="257" r:id="rId8"/>
-    <p:sldId id="258" r:id="rId9"/>
-    <p:sldId id="259" r:id="rId10"/>
-    <p:sldId id="260" r:id="rId11"/>
-    <p:sldId id="261" r:id="rId12"/>
-    <p:sldId id="262" r:id="rId13"/>
-    <p:sldId id="263" r:id="rId14"/>
-    <p:sldId id="264" r:id="rId15"/>
-    <p:sldId id="265" r:id="rId16"/>
-    <p:sldId id="266" r:id="rId17"/>
+    <p:sldId id="256" r:id="rId2"/>
+    <p:sldId id="257" r:id="rId3"/>
+    <p:sldId id="258" r:id="rId4"/>
+    <p:sldId id="259" r:id="rId5"/>
+    <p:sldId id="260" r:id="rId6"/>
+    <p:sldId id="261" r:id="rId7"/>
+    <p:sldId id="262" r:id="rId8"/>
+    <p:sldId id="263" r:id="rId9"/>
+    <p:sldId id="264" r:id="rId10"/>
+    <p:sldId id="265" r:id="rId11"/>
+    <p:sldId id="266" r:id="rId12"/>
   </p:sldIdLst>
-  <p:sldSz cx="12191695" cy="6858000" type="screen4x3"/>
+  <p:sldSz cx="12192000" cy="6858000"/>
   <p:notesSz cx="6858000" cy="9144000"/>
   <p:defaultTextStyle>
     <a:defPPr>
@@ -114,6 +114,22 @@
       </a:defRPr>
     </a:lvl9pPr>
   </p:defaultTextStyle>
+  <p:extLst>
+    <p:ext uri="{EFAFB233-063F-42B5-8137-9DF3F51BA10A}">
+      <p15:sldGuideLst xmlns:p15="http://schemas.microsoft.com/office/powerpoint/2012/main">
+        <p15:guide id="1" orient="horz" pos="2160">
+          <p15:clr>
+            <a:srgbClr val="A4A3A4"/>
+          </p15:clr>
+        </p15:guide>
+        <p15:guide id="2" pos="2880">
+          <p15:clr>
+            <a:srgbClr val="A4A3A4"/>
+          </p15:clr>
+        </p15:guide>
+      </p15:sldGuideLst>
+    </p:ext>
+  </p:extLst>
 </p:presentation>
 </file>
 
@@ -155,10 +171,9 @@
           <a:lstStyle/>
           <a:p>
             <a:r>
-              <a:rPr lang="en-US" smtClean="0"/>
+              <a:rPr lang="en-US"/>
               <a:t>Click to edit Master title style</a:t>
             </a:r>
-            <a:endParaRPr lang="en-US"/>
           </a:p>
         </p:txBody>
       </p:sp>
@@ -274,10 +289,9 @@
           </a:lstStyle>
           <a:p>
             <a:r>
-              <a:rPr lang="en-US" smtClean="0"/>
+              <a:rPr lang="en-US"/>
               <a:t>Click to edit Master subtitle style</a:t>
             </a:r>
-            <a:endParaRPr lang="en-US"/>
           </a:p>
         </p:txBody>
       </p:sp>
@@ -298,7 +312,7 @@
           <a:p>
             <a:fld id="{5BCAD085-E8A6-8845-BD4E-CB4CCA059FC4}" type="datetimeFigureOut">
               <a:rPr lang="en-US" smtClean="0"/>
-              <a:t>1/27/13</a:t>
+              <a:t>9/14/26</a:t>
             </a:fld>
             <a:endParaRPr lang="en-US"/>
           </a:p>
@@ -392,10 +406,9 @@
           <a:lstStyle/>
           <a:p>
             <a:r>
-              <a:rPr lang="en-US" smtClean="0"/>
+              <a:rPr lang="en-US"/>
               <a:t>Click to edit Master title style</a:t>
             </a:r>
-            <a:endParaRPr lang="en-US"/>
           </a:p>
         </p:txBody>
       </p:sp>
@@ -416,38 +429,37 @@
           <a:p>
             <a:pPr lvl="0"/>
             <a:r>
-              <a:rPr lang="en-US" smtClean="0"/>
+              <a:rPr lang="en-US"/>
               <a:t>Click to edit Master text styles</a:t>
             </a:r>
           </a:p>
           <a:p>
             <a:pPr lvl="1"/>
             <a:r>
-              <a:rPr lang="en-US" smtClean="0"/>
+              <a:rPr lang="en-US"/>
               <a:t>Second level</a:t>
             </a:r>
           </a:p>
           <a:p>
             <a:pPr lvl="2"/>
             <a:r>
-              <a:rPr lang="en-US" smtClean="0"/>
+              <a:rPr lang="en-US"/>
               <a:t>Third level</a:t>
             </a:r>
           </a:p>
           <a:p>
             <a:pPr lvl="3"/>
             <a:r>
-              <a:rPr lang="en-US" smtClean="0"/>
+              <a:rPr lang="en-US"/>
               <a:t>Fourth level</a:t>
             </a:r>
           </a:p>
           <a:p>
             <a:pPr lvl="4"/>
             <a:r>
-              <a:rPr lang="en-US" smtClean="0"/>
+              <a:rPr lang="en-US"/>
               <a:t>Fifth level</a:t>
             </a:r>
-            <a:endParaRPr lang="en-US"/>
           </a:p>
         </p:txBody>
       </p:sp>
@@ -468,7 +480,7 @@
           <a:p>
             <a:fld id="{5BCAD085-E8A6-8845-BD4E-CB4CCA059FC4}" type="datetimeFigureOut">
               <a:rPr lang="en-US" smtClean="0"/>
-              <a:t>1/27/13</a:t>
+              <a:t>9/14/26</a:t>
             </a:fld>
             <a:endParaRPr lang="en-US"/>
           </a:p>
@@ -567,10 +579,9 @@
           <a:lstStyle/>
           <a:p>
             <a:r>
-              <a:rPr lang="en-US" smtClean="0"/>
+              <a:rPr lang="en-US"/>
               <a:t>Click to edit Master title style</a:t>
             </a:r>
-            <a:endParaRPr lang="en-US"/>
           </a:p>
         </p:txBody>
       </p:sp>
@@ -596,38 +607,37 @@
           <a:p>
             <a:pPr lvl="0"/>
             <a:r>
-              <a:rPr lang="en-US" smtClean="0"/>
+              <a:rPr lang="en-US"/>
               <a:t>Click to edit Master text styles</a:t>
             </a:r>
           </a:p>
           <a:p>
             <a:pPr lvl="1"/>
             <a:r>
-              <a:rPr lang="en-US" smtClean="0"/>
+              <a:rPr lang="en-US"/>
               <a:t>Second level</a:t>
             </a:r>
           </a:p>
           <a:p>
             <a:pPr lvl="2"/>
             <a:r>
-              <a:rPr lang="en-US" smtClean="0"/>
+              <a:rPr lang="en-US"/>
               <a:t>Third level</a:t>
             </a:r>
           </a:p>
           <a:p>
             <a:pPr lvl="3"/>
             <a:r>
-              <a:rPr lang="en-US" smtClean="0"/>
+              <a:rPr lang="en-US"/>
               <a:t>Fourth level</a:t>
             </a:r>
           </a:p>
           <a:p>
             <a:pPr lvl="4"/>
             <a:r>
-              <a:rPr lang="en-US" smtClean="0"/>
+              <a:rPr lang="en-US"/>
               <a:t>Fifth level</a:t>
             </a:r>
-            <a:endParaRPr lang="en-US"/>
           </a:p>
         </p:txBody>
       </p:sp>
@@ -648,7 +658,7 @@
           <a:p>
             <a:fld id="{5BCAD085-E8A6-8845-BD4E-CB4CCA059FC4}" type="datetimeFigureOut">
               <a:rPr lang="en-US" smtClean="0"/>
-              <a:t>1/27/13</a:t>
+              <a:t>9/14/26</a:t>
             </a:fld>
             <a:endParaRPr lang="en-US"/>
           </a:p>
@@ -742,10 +752,9 @@
           <a:lstStyle/>
           <a:p>
             <a:r>
-              <a:rPr lang="en-US" smtClean="0"/>
+              <a:rPr lang="en-US"/>
               <a:t>Click to edit Master title style</a:t>
             </a:r>
-            <a:endParaRPr lang="en-US"/>
           </a:p>
         </p:txBody>
       </p:sp>
@@ -766,38 +775,37 @@
           <a:p>
             <a:pPr lvl="0"/>
             <a:r>
-              <a:rPr lang="en-US" smtClean="0"/>
+              <a:rPr lang="en-US"/>
               <a:t>Click to edit Master text styles</a:t>
             </a:r>
           </a:p>
           <a:p>
             <a:pPr lvl="1"/>
             <a:r>
-              <a:rPr lang="en-US" smtClean="0"/>
+              <a:rPr lang="en-US"/>
               <a:t>Second level</a:t>
             </a:r>
           </a:p>
           <a:p>
             <a:pPr lvl="2"/>
             <a:r>
-              <a:rPr lang="en-US" smtClean="0"/>
+              <a:rPr lang="en-US"/>
               <a:t>Third level</a:t>
             </a:r>
           </a:p>
           <a:p>
             <a:pPr lvl="3"/>
             <a:r>
-              <a:rPr lang="en-US" smtClean="0"/>
+              <a:rPr lang="en-US"/>
               <a:t>Fourth level</a:t>
             </a:r>
           </a:p>
           <a:p>
             <a:pPr lvl="4"/>
             <a:r>
-              <a:rPr lang="en-US" smtClean="0"/>
+              <a:rPr lang="en-US"/>
               <a:t>Fifth level</a:t>
             </a:r>
-            <a:endParaRPr lang="en-US"/>
           </a:p>
         </p:txBody>
       </p:sp>
@@ -818,7 +826,7 @@
           <a:p>
             <a:fld id="{5BCAD085-E8A6-8845-BD4E-CB4CCA059FC4}" type="datetimeFigureOut">
               <a:rPr lang="en-US" smtClean="0"/>
-              <a:t>1/27/13</a:t>
+              <a:t>9/14/26</a:t>
             </a:fld>
             <a:endParaRPr lang="en-US"/>
           </a:p>
@@ -921,10 +929,9 @@
           </a:lstStyle>
           <a:p>
             <a:r>
-              <a:rPr lang="en-US" smtClean="0"/>
+              <a:rPr lang="en-US"/>
               <a:t>Click to edit Master title style</a:t>
             </a:r>
-            <a:endParaRPr lang="en-US"/>
           </a:p>
         </p:txBody>
       </p:sp>
@@ -1041,7 +1048,7 @@
           <a:p>
             <a:pPr lvl="0"/>
             <a:r>
-              <a:rPr lang="en-US" smtClean="0"/>
+              <a:rPr lang="en-US"/>
               <a:t>Click to edit Master text styles</a:t>
             </a:r>
           </a:p>
@@ -1064,7 +1071,7 @@
           <a:p>
             <a:fld id="{5BCAD085-E8A6-8845-BD4E-CB4CCA059FC4}" type="datetimeFigureOut">
               <a:rPr lang="en-US" smtClean="0"/>
-              <a:t>1/27/13</a:t>
+              <a:t>9/14/26</a:t>
             </a:fld>
             <a:endParaRPr lang="en-US"/>
           </a:p>
@@ -1158,10 +1165,9 @@
           <a:lstStyle/>
           <a:p>
             <a:r>
-              <a:rPr lang="en-US" smtClean="0"/>
+              <a:rPr lang="en-US"/>
               <a:t>Click to edit Master title style</a:t>
             </a:r>
-            <a:endParaRPr lang="en-US"/>
           </a:p>
         </p:txBody>
       </p:sp>
@@ -1215,38 +1221,37 @@
           <a:p>
             <a:pPr lvl="0"/>
             <a:r>
-              <a:rPr lang="en-US" smtClean="0"/>
+              <a:rPr lang="en-US"/>
               <a:t>Click to edit Master text styles</a:t>
             </a:r>
           </a:p>
           <a:p>
             <a:pPr lvl="1"/>
             <a:r>
-              <a:rPr lang="en-US" smtClean="0"/>
+              <a:rPr lang="en-US"/>
               <a:t>Second level</a:t>
             </a:r>
           </a:p>
           <a:p>
             <a:pPr lvl="2"/>
             <a:r>
-              <a:rPr lang="en-US" smtClean="0"/>
+              <a:rPr lang="en-US"/>
               <a:t>Third level</a:t>
             </a:r>
           </a:p>
           <a:p>
             <a:pPr lvl="3"/>
             <a:r>
-              <a:rPr lang="en-US" smtClean="0"/>
+              <a:rPr lang="en-US"/>
               <a:t>Fourth level</a:t>
             </a:r>
           </a:p>
           <a:p>
             <a:pPr lvl="4"/>
             <a:r>
-              <a:rPr lang="en-US" smtClean="0"/>
+              <a:rPr lang="en-US"/>
               <a:t>Fifth level</a:t>
             </a:r>
-            <a:endParaRPr lang="en-US"/>
           </a:p>
         </p:txBody>
       </p:sp>
@@ -1300,38 +1305,37 @@
           <a:p>
             <a:pPr lvl="0"/>
             <a:r>
-              <a:rPr lang="en-US" smtClean="0"/>
+              <a:rPr lang="en-US"/>
               <a:t>Click to edit Master text styles</a:t>
             </a:r>
           </a:p>
           <a:p>
             <a:pPr lvl="1"/>
             <a:r>
-              <a:rPr lang="en-US" smtClean="0"/>
+              <a:rPr lang="en-US"/>
               <a:t>Second level</a:t>
             </a:r>
           </a:p>
           <a:p>
             <a:pPr lvl="2"/>
             <a:r>
-              <a:rPr lang="en-US" smtClean="0"/>
+              <a:rPr lang="en-US"/>
               <a:t>Third level</a:t>
             </a:r>
           </a:p>
           <a:p>
             <a:pPr lvl="3"/>
             <a:r>
-              <a:rPr lang="en-US" smtClean="0"/>
+              <a:rPr lang="en-US"/>
               <a:t>Fourth level</a:t>
             </a:r>
           </a:p>
           <a:p>
             <a:pPr lvl="4"/>
             <a:r>
-              <a:rPr lang="en-US" smtClean="0"/>
+              <a:rPr lang="en-US"/>
               <a:t>Fifth level</a:t>
             </a:r>
-            <a:endParaRPr lang="en-US"/>
           </a:p>
         </p:txBody>
       </p:sp>
@@ -1352,7 +1356,7 @@
           <a:p>
             <a:fld id="{5BCAD085-E8A6-8845-BD4E-CB4CCA059FC4}" type="datetimeFigureOut">
               <a:rPr lang="en-US" smtClean="0"/>
-              <a:t>1/27/13</a:t>
+              <a:t>9/14/26</a:t>
             </a:fld>
             <a:endParaRPr lang="en-US"/>
           </a:p>
@@ -1450,10 +1454,9 @@
           </a:lstStyle>
           <a:p>
             <a:r>
-              <a:rPr lang="en-US" smtClean="0"/>
+              <a:rPr lang="en-US"/>
               <a:t>Click to edit Master title style</a:t>
             </a:r>
-            <a:endParaRPr lang="en-US"/>
           </a:p>
         </p:txBody>
       </p:sp>
@@ -1516,7 +1519,7 @@
           <a:p>
             <a:pPr lvl="0"/>
             <a:r>
-              <a:rPr lang="en-US" smtClean="0"/>
+              <a:rPr lang="en-US"/>
               <a:t>Click to edit Master text styles</a:t>
             </a:r>
           </a:p>
@@ -1572,38 +1575,37 @@
           <a:p>
             <a:pPr lvl="0"/>
             <a:r>
-              <a:rPr lang="en-US" smtClean="0"/>
+              <a:rPr lang="en-US"/>
               <a:t>Click to edit Master text styles</a:t>
             </a:r>
           </a:p>
           <a:p>
             <a:pPr lvl="1"/>
             <a:r>
-              <a:rPr lang="en-US" smtClean="0"/>
+              <a:rPr lang="en-US"/>
               <a:t>Second level</a:t>
             </a:r>
           </a:p>
           <a:p>
             <a:pPr lvl="2"/>
             <a:r>
-              <a:rPr lang="en-US" smtClean="0"/>
+              <a:rPr lang="en-US"/>
               <a:t>Third level</a:t>
             </a:r>
           </a:p>
           <a:p>
             <a:pPr lvl="3"/>
             <a:r>
-              <a:rPr lang="en-US" smtClean="0"/>
+              <a:rPr lang="en-US"/>
               <a:t>Fourth level</a:t>
             </a:r>
           </a:p>
           <a:p>
             <a:pPr lvl="4"/>
             <a:r>
-              <a:rPr lang="en-US" smtClean="0"/>
+              <a:rPr lang="en-US"/>
               <a:t>Fifth level</a:t>
             </a:r>
-            <a:endParaRPr lang="en-US"/>
           </a:p>
         </p:txBody>
       </p:sp>
@@ -1666,7 +1668,7 @@
           <a:p>
             <a:pPr lvl="0"/>
             <a:r>
-              <a:rPr lang="en-US" smtClean="0"/>
+              <a:rPr lang="en-US"/>
               <a:t>Click to edit Master text styles</a:t>
             </a:r>
           </a:p>
@@ -1722,38 +1724,37 @@
           <a:p>
             <a:pPr lvl="0"/>
             <a:r>
-              <a:rPr lang="en-US" smtClean="0"/>
+              <a:rPr lang="en-US"/>
               <a:t>Click to edit Master text styles</a:t>
             </a:r>
           </a:p>
           <a:p>
             <a:pPr lvl="1"/>
             <a:r>
-              <a:rPr lang="en-US" smtClean="0"/>
+              <a:rPr lang="en-US"/>
               <a:t>Second level</a:t>
             </a:r>
           </a:p>
           <a:p>
             <a:pPr lvl="2"/>
             <a:r>
-              <a:rPr lang="en-US" smtClean="0"/>
+              <a:rPr lang="en-US"/>
               <a:t>Third level</a:t>
             </a:r>
           </a:p>
           <a:p>
             <a:pPr lvl="3"/>
             <a:r>
-              <a:rPr lang="en-US" smtClean="0"/>
+              <a:rPr lang="en-US"/>
               <a:t>Fourth level</a:t>
             </a:r>
           </a:p>
           <a:p>
             <a:pPr lvl="4"/>
             <a:r>
-              <a:rPr lang="en-US" smtClean="0"/>
+              <a:rPr lang="en-US"/>
               <a:t>Fifth level</a:t>
             </a:r>
-            <a:endParaRPr lang="en-US"/>
           </a:p>
         </p:txBody>
       </p:sp>
@@ -1774,7 +1775,7 @@
           <a:p>
             <a:fld id="{5BCAD085-E8A6-8845-BD4E-CB4CCA059FC4}" type="datetimeFigureOut">
               <a:rPr lang="en-US" smtClean="0"/>
-              <a:t>1/27/13</a:t>
+              <a:t>9/14/26</a:t>
             </a:fld>
             <a:endParaRPr lang="en-US"/>
           </a:p>
@@ -1868,10 +1869,9 @@
           <a:lstStyle/>
           <a:p>
             <a:r>
-              <a:rPr lang="en-US" smtClean="0"/>
+              <a:rPr lang="en-US"/>
               <a:t>Click to edit Master title style</a:t>
             </a:r>
-            <a:endParaRPr lang="en-US"/>
           </a:p>
         </p:txBody>
       </p:sp>
@@ -1892,7 +1892,7 @@
           <a:p>
             <a:fld id="{5BCAD085-E8A6-8845-BD4E-CB4CCA059FC4}" type="datetimeFigureOut">
               <a:rPr lang="en-US" smtClean="0"/>
-              <a:t>1/27/13</a:t>
+              <a:t>9/14/26</a:t>
             </a:fld>
             <a:endParaRPr lang="en-US"/>
           </a:p>
@@ -1987,7 +1987,7 @@
           <a:p>
             <a:fld id="{5BCAD085-E8A6-8845-BD4E-CB4CCA059FC4}" type="datetimeFigureOut">
               <a:rPr lang="en-US" smtClean="0"/>
-              <a:t>1/27/13</a:t>
+              <a:t>9/14/26</a:t>
             </a:fld>
             <a:endParaRPr lang="en-US"/>
           </a:p>
@@ -2090,10 +2090,9 @@
           </a:lstStyle>
           <a:p>
             <a:r>
-              <a:rPr lang="en-US" smtClean="0"/>
+              <a:rPr lang="en-US"/>
               <a:t>Click to edit Master title style</a:t>
             </a:r>
-            <a:endParaRPr lang="en-US"/>
           </a:p>
         </p:txBody>
       </p:sp>
@@ -2147,38 +2146,37 @@
           <a:p>
             <a:pPr lvl="0"/>
             <a:r>
-              <a:rPr lang="en-US" smtClean="0"/>
+              <a:rPr lang="en-US"/>
               <a:t>Click to edit Master text styles</a:t>
             </a:r>
           </a:p>
           <a:p>
             <a:pPr lvl="1"/>
             <a:r>
-              <a:rPr lang="en-US" smtClean="0"/>
+              <a:rPr lang="en-US"/>
               <a:t>Second level</a:t>
             </a:r>
           </a:p>
           <a:p>
             <a:pPr lvl="2"/>
             <a:r>
-              <a:rPr lang="en-US" smtClean="0"/>
+              <a:rPr lang="en-US"/>
               <a:t>Third level</a:t>
             </a:r>
           </a:p>
           <a:p>
             <a:pPr lvl="3"/>
             <a:r>
-              <a:rPr lang="en-US" smtClean="0"/>
+              <a:rPr lang="en-US"/>
               <a:t>Fourth level</a:t>
             </a:r>
           </a:p>
           <a:p>
             <a:pPr lvl="4"/>
             <a:r>
-              <a:rPr lang="en-US" smtClean="0"/>
+              <a:rPr lang="en-US"/>
               <a:t>Fifth level</a:t>
             </a:r>
-            <a:endParaRPr lang="en-US"/>
           </a:p>
         </p:txBody>
       </p:sp>
@@ -2241,7 +2239,7 @@
           <a:p>
             <a:pPr lvl="0"/>
             <a:r>
-              <a:rPr lang="en-US" smtClean="0"/>
+              <a:rPr lang="en-US"/>
               <a:t>Click to edit Master text styles</a:t>
             </a:r>
           </a:p>
@@ -2264,7 +2262,7 @@
           <a:p>
             <a:fld id="{5BCAD085-E8A6-8845-BD4E-CB4CCA059FC4}" type="datetimeFigureOut">
               <a:rPr lang="en-US" smtClean="0"/>
-              <a:t>1/27/13</a:t>
+              <a:t>9/14/26</a:t>
             </a:fld>
             <a:endParaRPr lang="en-US"/>
           </a:p>
@@ -2367,10 +2365,9 @@
           </a:lstStyle>
           <a:p>
             <a:r>
-              <a:rPr lang="en-US" smtClean="0"/>
+              <a:rPr lang="en-US"/>
               <a:t>Click to edit Master title style</a:t>
             </a:r>
-            <a:endParaRPr lang="en-US"/>
           </a:p>
         </p:txBody>
       </p:sp>
@@ -2494,7 +2491,7 @@
           <a:p>
             <a:pPr lvl="0"/>
             <a:r>
-              <a:rPr lang="en-US" smtClean="0"/>
+              <a:rPr lang="en-US"/>
               <a:t>Click to edit Master text styles</a:t>
             </a:r>
           </a:p>
@@ -2517,7 +2514,7 @@
           <a:p>
             <a:fld id="{5BCAD085-E8A6-8845-BD4E-CB4CCA059FC4}" type="datetimeFigureOut">
               <a:rPr lang="en-US" smtClean="0"/>
-              <a:t>1/27/13</a:t>
+              <a:t>9/14/26</a:t>
             </a:fld>
             <a:endParaRPr lang="en-US"/>
           </a:p>
@@ -2626,10 +2623,9 @@
           <a:lstStyle/>
           <a:p>
             <a:r>
-              <a:rPr lang="en-US" smtClean="0"/>
+              <a:rPr lang="en-US"/>
               <a:t>Click to edit Master title style</a:t>
             </a:r>
-            <a:endParaRPr lang="en-US"/>
           </a:p>
         </p:txBody>
       </p:sp>
@@ -2660,38 +2656,37 @@
           <a:p>
             <a:pPr lvl="0"/>
             <a:r>
-              <a:rPr lang="en-US" smtClean="0"/>
+              <a:rPr lang="en-US"/>
               <a:t>Click to edit Master text styles</a:t>
             </a:r>
           </a:p>
           <a:p>
             <a:pPr lvl="1"/>
             <a:r>
-              <a:rPr lang="en-US" smtClean="0"/>
+              <a:rPr lang="en-US"/>
               <a:t>Second level</a:t>
             </a:r>
           </a:p>
           <a:p>
             <a:pPr lvl="2"/>
             <a:r>
-              <a:rPr lang="en-US" smtClean="0"/>
+              <a:rPr lang="en-US"/>
               <a:t>Third level</a:t>
             </a:r>
           </a:p>
           <a:p>
             <a:pPr lvl="3"/>
             <a:r>
-              <a:rPr lang="en-US" smtClean="0"/>
+              <a:rPr lang="en-US"/>
               <a:t>Fourth level</a:t>
             </a:r>
           </a:p>
           <a:p>
             <a:pPr lvl="4"/>
             <a:r>
-              <a:rPr lang="en-US" smtClean="0"/>
+              <a:rPr lang="en-US"/>
               <a:t>Fifth level</a:t>
             </a:r>
-            <a:endParaRPr lang="en-US"/>
           </a:p>
         </p:txBody>
       </p:sp>
@@ -2730,7 +2725,7 @@
           <a:p>
             <a:fld id="{5BCAD085-E8A6-8845-BD4E-CB4CCA059FC4}" type="datetimeFigureOut">
               <a:rPr lang="en-US" smtClean="0"/>
-              <a:t>1/27/13</a:t>
+              <a:t>9/14/26</a:t>
             </a:fld>
             <a:endParaRPr lang="en-US"/>
           </a:p>
@@ -3089,7 +3084,7 @@
 </file>
 
 <file path=ppt/slides/slide1.xml><?xml version="1.0" encoding="utf-8"?>
-<p:sld xmlns:a="http://schemas.openxmlformats.org/drawingml/2006/main" xmlns:p="http://schemas.openxmlformats.org/presentationml/2006/main" xmlns:r="http://schemas.openxmlformats.org/officeDocument/2006/relationships">
+<p:sld xmlns:a="http://schemas.openxmlformats.org/drawingml/2006/main" xmlns:r="http://schemas.openxmlformats.org/officeDocument/2006/relationships" xmlns:p="http://schemas.openxmlformats.org/presentationml/2006/main">
   <p:cSld>
     <p:bg>
       <p:bgPr>
@@ -3105,7 +3100,14 @@
         <p:cNvGrpSpPr/>
         <p:nvPr/>
       </p:nvGrpSpPr>
-      <p:grpSpPr/>
+      <p:grpSpPr>
+        <a:xfrm>
+          <a:off x="0" y="0"/>
+          <a:ext cx="0" cy="0"/>
+          <a:chOff x="0" y="0"/>
+          <a:chExt cx="0" cy="0"/>
+        </a:xfrm>
+      </p:grpSpPr>
       <p:sp>
         <p:nvSpPr>
           <p:cNvPr id="2" name="Rectangle 1"/>
@@ -3147,6 +3149,7 @@
           <a:lstStyle/>
           <a:p>
             <a:pPr algn="ctr"/>
+            <a:endParaRPr/>
           </a:p>
         </p:txBody>
       </p:sp>
@@ -3167,7 +3170,7 @@
           <a:noFill/>
         </p:spPr>
         <p:txBody>
-          <a:bodyPr wrap="square" anchor="t" lIns="0" rIns="0" tIns="0" bIns="0">
+          <a:bodyPr wrap="square" lIns="0" tIns="0" rIns="0" bIns="0" anchor="t">
             <a:spAutoFit/>
           </a:bodyPr>
           <a:lstStyle/>
@@ -3209,7 +3212,7 @@
           <a:noFill/>
         </p:spPr>
         <p:txBody>
-          <a:bodyPr wrap="square" anchor="t" lIns="0" rIns="0" tIns="0" bIns="0">
+          <a:bodyPr wrap="square" lIns="0" tIns="0" rIns="0" bIns="0" anchor="t">
             <a:spAutoFit/>
           </a:bodyPr>
           <a:lstStyle/>
@@ -3275,6 +3278,7 @@
           <a:lstStyle/>
           <a:p>
             <a:pPr algn="ctr"/>
+            <a:endParaRPr/>
           </a:p>
         </p:txBody>
       </p:sp>
@@ -3295,7 +3299,7 @@
           <a:noFill/>
         </p:spPr>
         <p:txBody>
-          <a:bodyPr wrap="square" anchor="t" lIns="0" rIns="0" tIns="0" bIns="0">
+          <a:bodyPr wrap="square" lIns="0" tIns="0" rIns="0" bIns="0" anchor="t">
             <a:spAutoFit/>
           </a:bodyPr>
           <a:lstStyle/>
@@ -3337,7 +3341,7 @@
           <a:noFill/>
         </p:spPr>
         <p:txBody>
-          <a:bodyPr wrap="square" anchor="t" lIns="0" rIns="0" tIns="0" bIns="0">
+          <a:bodyPr wrap="square" lIns="0" tIns="0" rIns="0" bIns="0" anchor="t">
             <a:spAutoFit/>
           </a:bodyPr>
           <a:lstStyle/>
@@ -3371,7 +3375,7 @@
 </file>
 
 <file path=ppt/slides/slide10.xml><?xml version="1.0" encoding="utf-8"?>
-<p:sld xmlns:a="http://schemas.openxmlformats.org/drawingml/2006/main" xmlns:p="http://schemas.openxmlformats.org/presentationml/2006/main" xmlns:r="http://schemas.openxmlformats.org/officeDocument/2006/relationships">
+<p:sld xmlns:a="http://schemas.openxmlformats.org/drawingml/2006/main" xmlns:r="http://schemas.openxmlformats.org/officeDocument/2006/relationships" xmlns:p="http://schemas.openxmlformats.org/presentationml/2006/main">
   <p:cSld>
     <p:bg>
       <p:bgPr>
@@ -3387,7 +3391,14 @@
         <p:cNvGrpSpPr/>
         <p:nvPr/>
       </p:nvGrpSpPr>
-      <p:grpSpPr/>
+      <p:grpSpPr>
+        <a:xfrm>
+          <a:off x="0" y="0"/>
+          <a:ext cx="0" cy="0"/>
+          <a:chOff x="0" y="0"/>
+          <a:chExt cx="0" cy="0"/>
+        </a:xfrm>
+      </p:grpSpPr>
       <p:sp>
         <p:nvSpPr>
           <p:cNvPr id="2" name="Rectangle 1"/>
@@ -3429,6 +3440,7 @@
           <a:lstStyle/>
           <a:p>
             <a:pPr algn="ctr"/>
+            <a:endParaRPr/>
           </a:p>
         </p:txBody>
       </p:sp>
@@ -3449,7 +3461,7 @@
           <a:noFill/>
         </p:spPr>
         <p:txBody>
-          <a:bodyPr wrap="square" anchor="t" lIns="0" rIns="0" tIns="0" bIns="0">
+          <a:bodyPr wrap="square" lIns="0" tIns="0" rIns="0" bIns="0" anchor="t">
             <a:spAutoFit/>
           </a:bodyPr>
           <a:lstStyle/>
@@ -3491,7 +3503,7 @@
           <a:noFill/>
         </p:spPr>
         <p:txBody>
-          <a:bodyPr wrap="square" anchor="t" lIns="0" rIns="0" tIns="0" bIns="0">
+          <a:bodyPr wrap="square" lIns="0" tIns="0" rIns="0" bIns="0" anchor="t">
             <a:spAutoFit/>
           </a:bodyPr>
           <a:lstStyle/>
@@ -3557,6 +3569,7 @@
           <a:lstStyle/>
           <a:p>
             <a:pPr algn="ctr"/>
+            <a:endParaRPr/>
           </a:p>
         </p:txBody>
       </p:sp>
@@ -3577,7 +3590,7 @@
           <a:noFill/>
         </p:spPr>
         <p:txBody>
-          <a:bodyPr wrap="square" anchor="t" lIns="0" rIns="0" tIns="0" bIns="0">
+          <a:bodyPr wrap="square" lIns="0" tIns="0" rIns="0" bIns="0" anchor="t">
             <a:spAutoFit/>
           </a:bodyPr>
           <a:lstStyle/>
@@ -3619,7 +3632,7 @@
           <a:noFill/>
         </p:spPr>
         <p:txBody>
-          <a:bodyPr wrap="square" anchor="t" lIns="0" rIns="0" tIns="0" bIns="0">
+          <a:bodyPr wrap="square" lIns="0" tIns="0" rIns="0" bIns="0" anchor="t">
             <a:spAutoFit/>
           </a:bodyPr>
           <a:lstStyle/>
@@ -3681,7 +3694,7 @@
           </a:fontRef>
         </p:style>
         <p:txBody>
-          <a:bodyPr rtlCol="0" anchor="ctr" wrap="none"/>
+          <a:bodyPr wrap="none" rtlCol="0" anchor="ctr"/>
           <a:lstStyle/>
           <a:p>
             <a:pPr algn="ctr"/>
@@ -3713,7 +3726,7 @@
           <a:noFill/>
         </p:spPr>
         <p:txBody>
-          <a:bodyPr wrap="square" anchor="t" lIns="0" rIns="0" tIns="0" bIns="0">
+          <a:bodyPr wrap="square" lIns="0" tIns="0" rIns="0" bIns="0" anchor="t">
             <a:spAutoFit/>
           </a:bodyPr>
           <a:lstStyle/>
@@ -3781,6 +3794,7 @@
           <a:lstStyle/>
           <a:p>
             <a:pPr algn="ctr"/>
+            <a:endParaRPr/>
           </a:p>
         </p:txBody>
       </p:sp>
@@ -3801,7 +3815,7 @@
           <a:noFill/>
         </p:spPr>
         <p:txBody>
-          <a:bodyPr wrap="square" anchor="t" lIns="0" rIns="0" tIns="0" bIns="0">
+          <a:bodyPr wrap="square" lIns="0" tIns="0" rIns="0" bIns="0" anchor="t">
             <a:spAutoFit/>
           </a:bodyPr>
           <a:lstStyle/>
@@ -3843,7 +3857,7 @@
           <a:noFill/>
         </p:spPr>
         <p:txBody>
-          <a:bodyPr wrap="square" anchor="t" lIns="0" rIns="0" tIns="0" bIns="0">
+          <a:bodyPr wrap="square" lIns="0" tIns="0" rIns="0" bIns="0" anchor="t">
             <a:spAutoFit/>
           </a:bodyPr>
           <a:lstStyle/>
@@ -3909,6 +3923,7 @@
           <a:lstStyle/>
           <a:p>
             <a:pPr algn="ctr"/>
+            <a:endParaRPr/>
           </a:p>
         </p:txBody>
       </p:sp>
@@ -3949,7 +3964,7 @@
           </a:fontRef>
         </p:style>
         <p:txBody>
-          <a:bodyPr rtlCol="0" anchor="ctr" wrap="none"/>
+          <a:bodyPr wrap="none" rtlCol="0" anchor="ctr"/>
           <a:lstStyle/>
           <a:p>
             <a:pPr algn="ctr"/>
@@ -3981,7 +3996,7 @@
           <a:noFill/>
         </p:spPr>
         <p:txBody>
-          <a:bodyPr wrap="square" anchor="t" lIns="0" rIns="0" tIns="0" bIns="0">
+          <a:bodyPr wrap="square" lIns="0" tIns="0" rIns="0" bIns="0" anchor="t">
             <a:spAutoFit/>
           </a:bodyPr>
           <a:lstStyle/>
@@ -4049,6 +4064,7 @@
           <a:lstStyle/>
           <a:p>
             <a:pPr algn="ctr"/>
+            <a:endParaRPr/>
           </a:p>
         </p:txBody>
       </p:sp>
@@ -4069,7 +4085,7 @@
           <a:noFill/>
         </p:spPr>
         <p:txBody>
-          <a:bodyPr wrap="square" anchor="t" lIns="0" rIns="0" tIns="0" bIns="0">
+          <a:bodyPr wrap="square" lIns="0" tIns="0" rIns="0" bIns="0" anchor="t">
             <a:spAutoFit/>
           </a:bodyPr>
           <a:lstStyle/>
@@ -4111,7 +4127,7 @@
           <a:noFill/>
         </p:spPr>
         <p:txBody>
-          <a:bodyPr wrap="square" anchor="t" lIns="0" rIns="0" tIns="0" bIns="0">
+          <a:bodyPr wrap="square" lIns="0" tIns="0" rIns="0" bIns="0" anchor="t">
             <a:spAutoFit/>
           </a:bodyPr>
           <a:lstStyle/>
@@ -4177,6 +4193,7 @@
           <a:lstStyle/>
           <a:p>
             <a:pPr algn="ctr"/>
+            <a:endParaRPr/>
           </a:p>
         </p:txBody>
       </p:sp>
@@ -4217,7 +4234,7 @@
           </a:fontRef>
         </p:style>
         <p:txBody>
-          <a:bodyPr rtlCol="0" anchor="ctr" wrap="none"/>
+          <a:bodyPr wrap="none" rtlCol="0" anchor="ctr"/>
           <a:lstStyle/>
           <a:p>
             <a:pPr algn="ctr"/>
@@ -4249,7 +4266,7 @@
           <a:noFill/>
         </p:spPr>
         <p:txBody>
-          <a:bodyPr wrap="square" anchor="t" lIns="0" rIns="0" tIns="0" bIns="0">
+          <a:bodyPr wrap="square" lIns="0" tIns="0" rIns="0" bIns="0" anchor="t">
             <a:spAutoFit/>
           </a:bodyPr>
           <a:lstStyle/>
@@ -4317,6 +4334,7 @@
           <a:lstStyle/>
           <a:p>
             <a:pPr algn="ctr"/>
+            <a:endParaRPr/>
           </a:p>
         </p:txBody>
       </p:sp>
@@ -4337,7 +4355,7 @@
           <a:noFill/>
         </p:spPr>
         <p:txBody>
-          <a:bodyPr wrap="square" anchor="t" lIns="0" rIns="0" tIns="0" bIns="0">
+          <a:bodyPr wrap="square" lIns="0" tIns="0" rIns="0" bIns="0" anchor="t">
             <a:spAutoFit/>
           </a:bodyPr>
           <a:lstStyle/>
@@ -4379,7 +4397,7 @@
           <a:noFill/>
         </p:spPr>
         <p:txBody>
-          <a:bodyPr wrap="square" anchor="t" lIns="0" rIns="0" tIns="0" bIns="0">
+          <a:bodyPr wrap="square" lIns="0" tIns="0" rIns="0" bIns="0" anchor="t">
             <a:spAutoFit/>
           </a:bodyPr>
           <a:lstStyle/>
@@ -4445,6 +4463,7 @@
           <a:lstStyle/>
           <a:p>
             <a:pPr algn="ctr"/>
+            <a:endParaRPr/>
           </a:p>
         </p:txBody>
       </p:sp>
@@ -4485,7 +4504,7 @@
           </a:fontRef>
         </p:style>
         <p:txBody>
-          <a:bodyPr rtlCol="0" anchor="ctr" wrap="none"/>
+          <a:bodyPr wrap="none" rtlCol="0" anchor="ctr"/>
           <a:lstStyle/>
           <a:p>
             <a:pPr algn="ctr"/>
@@ -4517,7 +4536,7 @@
           <a:noFill/>
         </p:spPr>
         <p:txBody>
-          <a:bodyPr wrap="square" anchor="t" lIns="0" rIns="0" tIns="0" bIns="0">
+          <a:bodyPr wrap="square" lIns="0" tIns="0" rIns="0" bIns="0" anchor="t">
             <a:spAutoFit/>
           </a:bodyPr>
           <a:lstStyle/>
@@ -4585,6 +4604,7 @@
           <a:lstStyle/>
           <a:p>
             <a:pPr algn="ctr"/>
+            <a:endParaRPr/>
           </a:p>
         </p:txBody>
       </p:sp>
@@ -4605,7 +4625,7 @@
           <a:noFill/>
         </p:spPr>
         <p:txBody>
-          <a:bodyPr wrap="square" anchor="t" lIns="0" rIns="0" tIns="0" bIns="0">
+          <a:bodyPr wrap="square" lIns="0" tIns="0" rIns="0" bIns="0" anchor="t">
             <a:spAutoFit/>
           </a:bodyPr>
           <a:lstStyle/>
@@ -4647,7 +4667,7 @@
           <a:noFill/>
         </p:spPr>
         <p:txBody>
-          <a:bodyPr wrap="square" anchor="t" lIns="0" rIns="0" tIns="0" bIns="0">
+          <a:bodyPr wrap="square" lIns="0" tIns="0" rIns="0" bIns="0" anchor="t">
             <a:spAutoFit/>
           </a:bodyPr>
           <a:lstStyle/>
@@ -4713,6 +4733,7 @@
           <a:lstStyle/>
           <a:p>
             <a:pPr algn="ctr"/>
+            <a:endParaRPr/>
           </a:p>
         </p:txBody>
       </p:sp>
@@ -4753,7 +4774,7 @@
           </a:fontRef>
         </p:style>
         <p:txBody>
-          <a:bodyPr rtlCol="0" anchor="ctr" wrap="none"/>
+          <a:bodyPr wrap="none" rtlCol="0" anchor="ctr"/>
           <a:lstStyle/>
           <a:p>
             <a:pPr algn="ctr"/>
@@ -4785,7 +4806,7 @@
           <a:noFill/>
         </p:spPr>
         <p:txBody>
-          <a:bodyPr wrap="square" anchor="t" lIns="0" rIns="0" tIns="0" bIns="0">
+          <a:bodyPr wrap="square" lIns="0" tIns="0" rIns="0" bIns="0" anchor="t">
             <a:spAutoFit/>
           </a:bodyPr>
           <a:lstStyle/>
@@ -4853,6 +4874,7 @@
           <a:lstStyle/>
           <a:p>
             <a:pPr algn="ctr"/>
+            <a:endParaRPr/>
           </a:p>
         </p:txBody>
       </p:sp>
@@ -4873,7 +4895,7 @@
           <a:noFill/>
         </p:spPr>
         <p:txBody>
-          <a:bodyPr wrap="square" anchor="t" lIns="0" rIns="0" tIns="0" bIns="0">
+          <a:bodyPr wrap="square" lIns="0" tIns="0" rIns="0" bIns="0" anchor="t">
             <a:spAutoFit/>
           </a:bodyPr>
           <a:lstStyle/>
@@ -4915,7 +4937,7 @@
           <a:noFill/>
         </p:spPr>
         <p:txBody>
-          <a:bodyPr wrap="square" anchor="t" lIns="0" rIns="0" tIns="0" bIns="0">
+          <a:bodyPr wrap="square" lIns="0" tIns="0" rIns="0" bIns="0" anchor="t">
             <a:spAutoFit/>
           </a:bodyPr>
           <a:lstStyle/>
@@ -4949,7 +4971,7 @@
 </file>
 
 <file path=ppt/slides/slide11.xml><?xml version="1.0" encoding="utf-8"?>
-<p:sld xmlns:a="http://schemas.openxmlformats.org/drawingml/2006/main" xmlns:p="http://schemas.openxmlformats.org/presentationml/2006/main" xmlns:r="http://schemas.openxmlformats.org/officeDocument/2006/relationships">
+<p:sld xmlns:a="http://schemas.openxmlformats.org/drawingml/2006/main" xmlns:r="http://schemas.openxmlformats.org/officeDocument/2006/relationships" xmlns:p="http://schemas.openxmlformats.org/presentationml/2006/main">
   <p:cSld>
     <p:bg>
       <p:bgPr>
@@ -4965,7 +4987,14 @@
         <p:cNvGrpSpPr/>
         <p:nvPr/>
       </p:nvGrpSpPr>
-      <p:grpSpPr/>
+      <p:grpSpPr>
+        <a:xfrm>
+          <a:off x="0" y="0"/>
+          <a:ext cx="0" cy="0"/>
+          <a:chOff x="0" y="0"/>
+          <a:chExt cx="0" cy="0"/>
+        </a:xfrm>
+      </p:grpSpPr>
       <p:sp>
         <p:nvSpPr>
           <p:cNvPr id="2" name="Rectangle 1"/>
@@ -5007,6 +5036,7 @@
           <a:lstStyle/>
           <a:p>
             <a:pPr algn="ctr"/>
+            <a:endParaRPr/>
           </a:p>
         </p:txBody>
       </p:sp>
@@ -5027,7 +5057,7 @@
           <a:noFill/>
         </p:spPr>
         <p:txBody>
-          <a:bodyPr wrap="square" anchor="t" lIns="0" rIns="0" tIns="0" bIns="0">
+          <a:bodyPr wrap="square" lIns="0" tIns="0" rIns="0" bIns="0" anchor="t">
             <a:spAutoFit/>
           </a:bodyPr>
           <a:lstStyle/>
@@ -5069,7 +5099,7 @@
           <a:noFill/>
         </p:spPr>
         <p:txBody>
-          <a:bodyPr wrap="square" anchor="t" lIns="0" rIns="0" tIns="0" bIns="0">
+          <a:bodyPr wrap="square" lIns="0" tIns="0" rIns="0" bIns="0" anchor="t">
             <a:spAutoFit/>
           </a:bodyPr>
           <a:lstStyle/>
@@ -5135,6 +5165,7 @@
           <a:lstStyle/>
           <a:p>
             <a:pPr algn="ctr"/>
+            <a:endParaRPr/>
           </a:p>
         </p:txBody>
       </p:sp>
@@ -5155,7 +5186,7 @@
           <a:noFill/>
         </p:spPr>
         <p:txBody>
-          <a:bodyPr wrap="square" anchor="t" lIns="0" rIns="0" tIns="0" bIns="0">
+          <a:bodyPr wrap="square" lIns="0" tIns="0" rIns="0" bIns="0" anchor="t">
             <a:spAutoFit/>
           </a:bodyPr>
           <a:lstStyle/>
@@ -5197,7 +5228,7 @@
           <a:noFill/>
         </p:spPr>
         <p:txBody>
-          <a:bodyPr wrap="square" anchor="t" lIns="0" rIns="0" tIns="0" bIns="0">
+          <a:bodyPr wrap="square" lIns="0" tIns="0" rIns="0" bIns="0" anchor="t">
             <a:spAutoFit/>
           </a:bodyPr>
           <a:lstStyle/>
@@ -5287,6 +5318,7 @@
           <a:lstStyle/>
           <a:p>
             <a:pPr algn="ctr"/>
+            <a:endParaRPr/>
           </a:p>
         </p:txBody>
       </p:sp>
@@ -5307,7 +5339,7 @@
           <a:noFill/>
         </p:spPr>
         <p:txBody>
-          <a:bodyPr wrap="square" lIns="0" rIns="0" tIns="0" bIns="0">
+          <a:bodyPr wrap="square" lIns="0" tIns="0" rIns="0" bIns="0">
             <a:spAutoFit/>
           </a:bodyPr>
           <a:lstStyle/>
@@ -5375,6 +5407,7 @@
           <a:lstStyle/>
           <a:p>
             <a:pPr algn="ctr"/>
+            <a:endParaRPr/>
           </a:p>
         </p:txBody>
       </p:sp>
@@ -5395,7 +5428,7 @@
           <a:noFill/>
         </p:spPr>
         <p:txBody>
-          <a:bodyPr wrap="square" anchor="t" lIns="0" rIns="0" tIns="0" bIns="0">
+          <a:bodyPr wrap="square" lIns="0" tIns="0" rIns="0" bIns="0" anchor="t">
             <a:spAutoFit/>
           </a:bodyPr>
           <a:lstStyle/>
@@ -5437,7 +5470,7 @@
           <a:noFill/>
         </p:spPr>
         <p:txBody>
-          <a:bodyPr wrap="square" lIns="0" rIns="0" tIns="0" bIns="0">
+          <a:bodyPr wrap="square" lIns="0" tIns="0" rIns="0" bIns="0">
             <a:spAutoFit/>
           </a:bodyPr>
           <a:lstStyle/>
@@ -5517,7 +5550,7 @@
           <a:noFill/>
         </p:spPr>
         <p:txBody>
-          <a:bodyPr wrap="square" anchor="t" lIns="0" rIns="0" tIns="0" bIns="0">
+          <a:bodyPr wrap="square" lIns="0" tIns="0" rIns="0" bIns="0" anchor="t">
             <a:spAutoFit/>
           </a:bodyPr>
           <a:lstStyle/>
@@ -5551,7 +5584,7 @@
 </file>
 
 <file path=ppt/slides/slide2.xml><?xml version="1.0" encoding="utf-8"?>
-<p:sld xmlns:a="http://schemas.openxmlformats.org/drawingml/2006/main" xmlns:p="http://schemas.openxmlformats.org/presentationml/2006/main" xmlns:r="http://schemas.openxmlformats.org/officeDocument/2006/relationships">
+<p:sld xmlns:a="http://schemas.openxmlformats.org/drawingml/2006/main" xmlns:r="http://schemas.openxmlformats.org/officeDocument/2006/relationships" xmlns:p="http://schemas.openxmlformats.org/presentationml/2006/main">
   <p:cSld>
     <p:bg>
       <p:bgPr>
@@ -5567,7 +5600,14 @@
         <p:cNvGrpSpPr/>
         <p:nvPr/>
       </p:nvGrpSpPr>
-      <p:grpSpPr/>
+      <p:grpSpPr>
+        <a:xfrm>
+          <a:off x="0" y="0"/>
+          <a:ext cx="0" cy="0"/>
+          <a:chOff x="0" y="0"/>
+          <a:chExt cx="0" cy="0"/>
+        </a:xfrm>
+      </p:grpSpPr>
       <p:sp>
         <p:nvSpPr>
           <p:cNvPr id="2" name="Rectangle 1"/>
@@ -5609,6 +5649,7 @@
           <a:lstStyle/>
           <a:p>
             <a:pPr algn="ctr"/>
+            <a:endParaRPr/>
           </a:p>
         </p:txBody>
       </p:sp>
@@ -5629,7 +5670,7 @@
           <a:noFill/>
         </p:spPr>
         <p:txBody>
-          <a:bodyPr wrap="square" anchor="t" lIns="0" rIns="0" tIns="0" bIns="0">
+          <a:bodyPr wrap="square" lIns="0" tIns="0" rIns="0" bIns="0" anchor="t">
             <a:spAutoFit/>
           </a:bodyPr>
           <a:lstStyle/>
@@ -5671,7 +5712,7 @@
           <a:noFill/>
         </p:spPr>
         <p:txBody>
-          <a:bodyPr wrap="square" anchor="t" lIns="0" rIns="0" tIns="0" bIns="0">
+          <a:bodyPr wrap="square" lIns="0" tIns="0" rIns="0" bIns="0" anchor="t">
             <a:spAutoFit/>
           </a:bodyPr>
           <a:lstStyle/>
@@ -5737,6 +5778,7 @@
           <a:lstStyle/>
           <a:p>
             <a:pPr algn="ctr"/>
+            <a:endParaRPr/>
           </a:p>
         </p:txBody>
       </p:sp>
@@ -5757,7 +5799,7 @@
           <a:noFill/>
         </p:spPr>
         <p:txBody>
-          <a:bodyPr wrap="square" anchor="t" lIns="0" rIns="0" tIns="0" bIns="0">
+          <a:bodyPr wrap="square" lIns="0" tIns="0" rIns="0" bIns="0" anchor="t">
             <a:spAutoFit/>
           </a:bodyPr>
           <a:lstStyle/>
@@ -5799,7 +5841,7 @@
           <a:noFill/>
         </p:spPr>
         <p:txBody>
-          <a:bodyPr wrap="square" anchor="t" lIns="0" rIns="0" tIns="0" bIns="0">
+          <a:bodyPr wrap="square" lIns="0" tIns="0" rIns="0" bIns="0" anchor="t">
             <a:spAutoFit/>
           </a:bodyPr>
           <a:lstStyle/>
@@ -5867,6 +5909,7 @@
           <a:lstStyle/>
           <a:p>
             <a:pPr algn="ctr"/>
+            <a:endParaRPr/>
           </a:p>
         </p:txBody>
       </p:sp>
@@ -5887,7 +5930,7 @@
           <a:noFill/>
         </p:spPr>
         <p:txBody>
-          <a:bodyPr wrap="square" anchor="t" lIns="0" rIns="0" tIns="0" bIns="0">
+          <a:bodyPr wrap="square" lIns="0" tIns="0" rIns="0" bIns="0" anchor="t">
             <a:spAutoFit/>
           </a:bodyPr>
           <a:lstStyle/>
@@ -5929,7 +5972,7 @@
           <a:noFill/>
         </p:spPr>
         <p:txBody>
-          <a:bodyPr wrap="square" anchor="t" lIns="0" rIns="0" tIns="0" bIns="0">
+          <a:bodyPr wrap="square" lIns="0" tIns="0" rIns="0" bIns="0" anchor="t">
             <a:spAutoFit/>
           </a:bodyPr>
           <a:lstStyle/>
@@ -6016,6 +6059,7 @@
           <a:lstStyle/>
           <a:p>
             <a:pPr algn="ctr"/>
+            <a:endParaRPr/>
           </a:p>
         </p:txBody>
       </p:sp>
@@ -6036,7 +6080,7 @@
           <a:noFill/>
         </p:spPr>
         <p:txBody>
-          <a:bodyPr wrap="square" anchor="t" lIns="0" rIns="0" tIns="0" bIns="0">
+          <a:bodyPr wrap="square" lIns="0" tIns="0" rIns="0" bIns="0" anchor="t">
             <a:spAutoFit/>
           </a:bodyPr>
           <a:lstStyle/>
@@ -6078,7 +6122,7 @@
           <a:noFill/>
         </p:spPr>
         <p:txBody>
-          <a:bodyPr wrap="square" anchor="t" lIns="0" rIns="0" tIns="0" bIns="0">
+          <a:bodyPr wrap="square" lIns="0" tIns="0" rIns="0" bIns="0" anchor="t">
             <a:spAutoFit/>
           </a:bodyPr>
           <a:lstStyle/>
@@ -6165,6 +6209,7 @@
           <a:lstStyle/>
           <a:p>
             <a:pPr algn="ctr"/>
+            <a:endParaRPr/>
           </a:p>
         </p:txBody>
       </p:sp>
@@ -6185,7 +6230,7 @@
           <a:noFill/>
         </p:spPr>
         <p:txBody>
-          <a:bodyPr wrap="square" anchor="t" lIns="0" rIns="0" tIns="0" bIns="0">
+          <a:bodyPr wrap="square" lIns="0" tIns="0" rIns="0" bIns="0" anchor="t">
             <a:spAutoFit/>
           </a:bodyPr>
           <a:lstStyle/>
@@ -6227,7 +6272,7 @@
           <a:noFill/>
         </p:spPr>
         <p:txBody>
-          <a:bodyPr wrap="square" anchor="t" lIns="0" rIns="0" tIns="0" bIns="0">
+          <a:bodyPr wrap="square" lIns="0" tIns="0" rIns="0" bIns="0" anchor="t">
             <a:spAutoFit/>
           </a:bodyPr>
           <a:lstStyle/>
@@ -6314,6 +6359,7 @@
           <a:lstStyle/>
           <a:p>
             <a:pPr algn="ctr"/>
+            <a:endParaRPr/>
           </a:p>
         </p:txBody>
       </p:sp>
@@ -6334,7 +6380,7 @@
           <a:noFill/>
         </p:spPr>
         <p:txBody>
-          <a:bodyPr wrap="square" anchor="t" lIns="0" rIns="0" tIns="0" bIns="0">
+          <a:bodyPr wrap="square" lIns="0" tIns="0" rIns="0" bIns="0" anchor="t">
             <a:spAutoFit/>
           </a:bodyPr>
           <a:lstStyle/>
@@ -6376,7 +6422,7 @@
           <a:noFill/>
         </p:spPr>
         <p:txBody>
-          <a:bodyPr wrap="square" anchor="t" lIns="0" rIns="0" tIns="0" bIns="0">
+          <a:bodyPr wrap="square" lIns="0" tIns="0" rIns="0" bIns="0" anchor="t">
             <a:spAutoFit/>
           </a:bodyPr>
           <a:lstStyle/>
@@ -6437,7 +6483,7 @@
           <a:noFill/>
         </p:spPr>
         <p:txBody>
-          <a:bodyPr wrap="square" lIns="0" rIns="0" tIns="0" bIns="0">
+          <a:bodyPr wrap="square" lIns="0" tIns="0" rIns="0" bIns="0">
             <a:spAutoFit/>
           </a:bodyPr>
           <a:lstStyle/>
@@ -6562,6 +6608,7 @@
           <a:lstStyle/>
           <a:p>
             <a:pPr algn="ctr"/>
+            <a:endParaRPr/>
           </a:p>
         </p:txBody>
       </p:sp>
@@ -6582,7 +6629,7 @@
           <a:noFill/>
         </p:spPr>
         <p:txBody>
-          <a:bodyPr wrap="square" anchor="t" lIns="0" rIns="0" tIns="0" bIns="0">
+          <a:bodyPr wrap="square" lIns="0" tIns="0" rIns="0" bIns="0" anchor="t">
             <a:spAutoFit/>
           </a:bodyPr>
           <a:lstStyle/>
@@ -6624,7 +6671,7 @@
           <a:noFill/>
         </p:spPr>
         <p:txBody>
-          <a:bodyPr wrap="square" anchor="t" lIns="0" rIns="0" tIns="0" bIns="0">
+          <a:bodyPr wrap="square" lIns="0" tIns="0" rIns="0" bIns="0" anchor="t">
             <a:spAutoFit/>
           </a:bodyPr>
           <a:lstStyle/>
@@ -6666,7 +6713,7 @@
           <a:noFill/>
         </p:spPr>
         <p:txBody>
-          <a:bodyPr wrap="square" lIns="0" rIns="0" tIns="0" bIns="0">
+          <a:bodyPr wrap="square" lIns="0" tIns="0" rIns="0" bIns="0">
             <a:spAutoFit/>
           </a:bodyPr>
           <a:lstStyle/>
@@ -6738,7 +6785,7 @@
 </file>
 
 <file path=ppt/slides/slide3.xml><?xml version="1.0" encoding="utf-8"?>
-<p:sld xmlns:a="http://schemas.openxmlformats.org/drawingml/2006/main" xmlns:p="http://schemas.openxmlformats.org/presentationml/2006/main" xmlns:r="http://schemas.openxmlformats.org/officeDocument/2006/relationships">
+<p:sld xmlns:a="http://schemas.openxmlformats.org/drawingml/2006/main" xmlns:r="http://schemas.openxmlformats.org/officeDocument/2006/relationships" xmlns:p="http://schemas.openxmlformats.org/presentationml/2006/main">
   <p:cSld>
     <p:bg>
       <p:bgPr>
@@ -6754,7 +6801,14 @@
         <p:cNvGrpSpPr/>
         <p:nvPr/>
       </p:nvGrpSpPr>
-      <p:grpSpPr/>
+      <p:grpSpPr>
+        <a:xfrm>
+          <a:off x="0" y="0"/>
+          <a:ext cx="0" cy="0"/>
+          <a:chOff x="0" y="0"/>
+          <a:chExt cx="0" cy="0"/>
+        </a:xfrm>
+      </p:grpSpPr>
       <p:sp>
         <p:nvSpPr>
           <p:cNvPr id="2" name="Rectangle 1"/>
@@ -6796,6 +6850,7 @@
           <a:lstStyle/>
           <a:p>
             <a:pPr algn="ctr"/>
+            <a:endParaRPr/>
           </a:p>
         </p:txBody>
       </p:sp>
@@ -6816,7 +6871,7 @@
           <a:noFill/>
         </p:spPr>
         <p:txBody>
-          <a:bodyPr wrap="square" anchor="t" lIns="0" rIns="0" tIns="0" bIns="0">
+          <a:bodyPr wrap="square" lIns="0" tIns="0" rIns="0" bIns="0" anchor="t">
             <a:spAutoFit/>
           </a:bodyPr>
           <a:lstStyle/>
@@ -6858,7 +6913,7 @@
           <a:noFill/>
         </p:spPr>
         <p:txBody>
-          <a:bodyPr wrap="square" anchor="t" lIns="0" rIns="0" tIns="0" bIns="0">
+          <a:bodyPr wrap="square" lIns="0" tIns="0" rIns="0" bIns="0" anchor="t">
             <a:spAutoFit/>
           </a:bodyPr>
           <a:lstStyle/>
@@ -6924,6 +6979,7 @@
           <a:lstStyle/>
           <a:p>
             <a:pPr algn="ctr"/>
+            <a:endParaRPr/>
           </a:p>
         </p:txBody>
       </p:sp>
@@ -6944,7 +7000,7 @@
           <a:noFill/>
         </p:spPr>
         <p:txBody>
-          <a:bodyPr wrap="square" anchor="t" lIns="0" rIns="0" tIns="0" bIns="0">
+          <a:bodyPr wrap="square" lIns="0" tIns="0" rIns="0" bIns="0" anchor="t">
             <a:spAutoFit/>
           </a:bodyPr>
           <a:lstStyle/>
@@ -6986,7 +7042,7 @@
           <a:noFill/>
         </p:spPr>
         <p:txBody>
-          <a:bodyPr wrap="square" anchor="t" lIns="0" rIns="0" tIns="0" bIns="0">
+          <a:bodyPr wrap="square" lIns="0" tIns="0" rIns="0" bIns="0" anchor="t">
             <a:spAutoFit/>
           </a:bodyPr>
           <a:lstStyle/>
@@ -7052,7 +7108,7 @@
           <a:noFill/>
         </p:spPr>
         <p:txBody>
-          <a:bodyPr wrap="square" lIns="0" rIns="0" tIns="0" bIns="0">
+          <a:bodyPr wrap="square" lIns="0" tIns="0" rIns="0" bIns="0">
             <a:spAutoFit/>
           </a:bodyPr>
           <a:lstStyle/>
@@ -7162,7 +7218,7 @@
 </file>
 
 <file path=ppt/slides/slide4.xml><?xml version="1.0" encoding="utf-8"?>
-<p:sld xmlns:a="http://schemas.openxmlformats.org/drawingml/2006/main" xmlns:p="http://schemas.openxmlformats.org/presentationml/2006/main" xmlns:r="http://schemas.openxmlformats.org/officeDocument/2006/relationships">
+<p:sld xmlns:a="http://schemas.openxmlformats.org/drawingml/2006/main" xmlns:r="http://schemas.openxmlformats.org/officeDocument/2006/relationships" xmlns:p="http://schemas.openxmlformats.org/presentationml/2006/main">
   <p:cSld>
     <p:bg>
       <p:bgPr>
@@ -7178,7 +7234,14 @@
         <p:cNvGrpSpPr/>
         <p:nvPr/>
       </p:nvGrpSpPr>
-      <p:grpSpPr/>
+      <p:grpSpPr>
+        <a:xfrm>
+          <a:off x="0" y="0"/>
+          <a:ext cx="0" cy="0"/>
+          <a:chOff x="0" y="0"/>
+          <a:chExt cx="0" cy="0"/>
+        </a:xfrm>
+      </p:grpSpPr>
       <p:sp>
         <p:nvSpPr>
           <p:cNvPr id="2" name="Rectangle 1"/>
@@ -7220,6 +7283,7 @@
           <a:lstStyle/>
           <a:p>
             <a:pPr algn="ctr"/>
+            <a:endParaRPr/>
           </a:p>
         </p:txBody>
       </p:sp>
@@ -7240,7 +7304,7 @@
           <a:noFill/>
         </p:spPr>
         <p:txBody>
-          <a:bodyPr wrap="square" anchor="t" lIns="0" rIns="0" tIns="0" bIns="0">
+          <a:bodyPr wrap="square" lIns="0" tIns="0" rIns="0" bIns="0" anchor="t">
             <a:spAutoFit/>
           </a:bodyPr>
           <a:lstStyle/>
@@ -7282,7 +7346,7 @@
           <a:noFill/>
         </p:spPr>
         <p:txBody>
-          <a:bodyPr wrap="square" anchor="t" lIns="0" rIns="0" tIns="0" bIns="0">
+          <a:bodyPr wrap="square" lIns="0" tIns="0" rIns="0" bIns="0" anchor="t">
             <a:spAutoFit/>
           </a:bodyPr>
           <a:lstStyle/>
@@ -7348,6 +7412,7 @@
           <a:lstStyle/>
           <a:p>
             <a:pPr algn="ctr"/>
+            <a:endParaRPr/>
           </a:p>
         </p:txBody>
       </p:sp>
@@ -7368,7 +7433,7 @@
           <a:noFill/>
         </p:spPr>
         <p:txBody>
-          <a:bodyPr wrap="square" anchor="t" lIns="0" rIns="0" tIns="0" bIns="0">
+          <a:bodyPr wrap="square" lIns="0" tIns="0" rIns="0" bIns="0" anchor="t">
             <a:spAutoFit/>
           </a:bodyPr>
           <a:lstStyle/>
@@ -7410,7 +7475,7 @@
           <a:noFill/>
         </p:spPr>
         <p:txBody>
-          <a:bodyPr wrap="square" anchor="t" lIns="0" rIns="0" tIns="0" bIns="0">
+          <a:bodyPr wrap="square" lIns="0" tIns="0" rIns="0" bIns="0" anchor="t">
             <a:spAutoFit/>
           </a:bodyPr>
           <a:lstStyle/>
@@ -7500,7 +7565,7 @@
           <a:noFill/>
         </p:spPr>
         <p:txBody>
-          <a:bodyPr wrap="square" anchor="t" lIns="0" rIns="0" tIns="0" bIns="0">
+          <a:bodyPr wrap="square" lIns="0" tIns="0" rIns="0" bIns="0" anchor="t">
             <a:spAutoFit/>
           </a:bodyPr>
           <a:lstStyle/>
@@ -7542,7 +7607,7 @@
           <a:noFill/>
         </p:spPr>
         <p:txBody>
-          <a:bodyPr wrap="square" lIns="0" rIns="0" tIns="0" bIns="0">
+          <a:bodyPr wrap="square" lIns="0" tIns="0" rIns="0" bIns="0">
             <a:spAutoFit/>
           </a:bodyPr>
           <a:lstStyle/>
@@ -7603,7 +7668,7 @@
           <a:noFill/>
         </p:spPr>
         <p:txBody>
-          <a:bodyPr wrap="square" anchor="t" lIns="0" rIns="0" tIns="0" bIns="0">
+          <a:bodyPr wrap="square" lIns="0" tIns="0" rIns="0" bIns="0" anchor="t">
             <a:spAutoFit/>
           </a:bodyPr>
           <a:lstStyle/>
@@ -7645,7 +7710,7 @@
           <a:noFill/>
         </p:spPr>
         <p:txBody>
-          <a:bodyPr wrap="square" lIns="0" rIns="0" tIns="0" bIns="0">
+          <a:bodyPr wrap="square" lIns="0" tIns="0" rIns="0" bIns="0">
             <a:spAutoFit/>
           </a:bodyPr>
           <a:lstStyle/>
@@ -7698,7 +7763,7 @@
 </file>
 
 <file path=ppt/slides/slide5.xml><?xml version="1.0" encoding="utf-8"?>
-<p:sld xmlns:a="http://schemas.openxmlformats.org/drawingml/2006/main" xmlns:p="http://schemas.openxmlformats.org/presentationml/2006/main" xmlns:r="http://schemas.openxmlformats.org/officeDocument/2006/relationships">
+<p:sld xmlns:a="http://schemas.openxmlformats.org/drawingml/2006/main" xmlns:r="http://schemas.openxmlformats.org/officeDocument/2006/relationships" xmlns:p="http://schemas.openxmlformats.org/presentationml/2006/main">
   <p:cSld>
     <p:bg>
       <p:bgPr>
@@ -7714,7 +7779,14 @@
         <p:cNvGrpSpPr/>
         <p:nvPr/>
       </p:nvGrpSpPr>
-      <p:grpSpPr/>
+      <p:grpSpPr>
+        <a:xfrm>
+          <a:off x="0" y="0"/>
+          <a:ext cx="0" cy="0"/>
+          <a:chOff x="0" y="0"/>
+          <a:chExt cx="0" cy="0"/>
+        </a:xfrm>
+      </p:grpSpPr>
       <p:sp>
         <p:nvSpPr>
           <p:cNvPr id="2" name="Rectangle 1"/>
@@ -7756,6 +7828,7 @@
           <a:lstStyle/>
           <a:p>
             <a:pPr algn="ctr"/>
+            <a:endParaRPr/>
           </a:p>
         </p:txBody>
       </p:sp>
@@ -7776,7 +7849,7 @@
           <a:noFill/>
         </p:spPr>
         <p:txBody>
-          <a:bodyPr wrap="square" anchor="t" lIns="0" rIns="0" tIns="0" bIns="0">
+          <a:bodyPr wrap="square" lIns="0" tIns="0" rIns="0" bIns="0" anchor="t">
             <a:spAutoFit/>
           </a:bodyPr>
           <a:lstStyle/>
@@ -7818,7 +7891,7 @@
           <a:noFill/>
         </p:spPr>
         <p:txBody>
-          <a:bodyPr wrap="square" anchor="t" lIns="0" rIns="0" tIns="0" bIns="0">
+          <a:bodyPr wrap="square" lIns="0" tIns="0" rIns="0" bIns="0" anchor="t">
             <a:spAutoFit/>
           </a:bodyPr>
           <a:lstStyle/>
@@ -7884,6 +7957,7 @@
           <a:lstStyle/>
           <a:p>
             <a:pPr algn="ctr"/>
+            <a:endParaRPr/>
           </a:p>
         </p:txBody>
       </p:sp>
@@ -7904,7 +7978,7 @@
           <a:noFill/>
         </p:spPr>
         <p:txBody>
-          <a:bodyPr wrap="square" anchor="t" lIns="0" rIns="0" tIns="0" bIns="0">
+          <a:bodyPr wrap="square" lIns="0" tIns="0" rIns="0" bIns="0" anchor="t">
             <a:spAutoFit/>
           </a:bodyPr>
           <a:lstStyle/>
@@ -7946,7 +8020,7 @@
           <a:noFill/>
         </p:spPr>
         <p:txBody>
-          <a:bodyPr wrap="square" anchor="t" lIns="0" rIns="0" tIns="0" bIns="0">
+          <a:bodyPr wrap="square" lIns="0" tIns="0" rIns="0" bIns="0" anchor="t">
             <a:spAutoFit/>
           </a:bodyPr>
           <a:lstStyle/>
@@ -8014,6 +8088,7 @@
           <a:lstStyle/>
           <a:p>
             <a:pPr algn="ctr"/>
+            <a:endParaRPr/>
           </a:p>
         </p:txBody>
       </p:sp>
@@ -8034,7 +8109,7 @@
           <a:noFill/>
         </p:spPr>
         <p:txBody>
-          <a:bodyPr wrap="square" anchor="t" lIns="0" rIns="0" tIns="0" bIns="0">
+          <a:bodyPr wrap="square" lIns="0" tIns="0" rIns="0" bIns="0" anchor="t">
             <a:spAutoFit/>
           </a:bodyPr>
           <a:lstStyle/>
@@ -8076,7 +8151,7 @@
           <a:noFill/>
         </p:spPr>
         <p:txBody>
-          <a:bodyPr wrap="square" anchor="t" lIns="0" rIns="0" tIns="0" bIns="0">
+          <a:bodyPr wrap="square" lIns="0" tIns="0" rIns="0" bIns="0" anchor="t">
             <a:spAutoFit/>
           </a:bodyPr>
           <a:lstStyle/>
@@ -8144,6 +8219,7 @@
           <a:lstStyle/>
           <a:p>
             <a:pPr algn="ctr"/>
+            <a:endParaRPr/>
           </a:p>
         </p:txBody>
       </p:sp>
@@ -8164,7 +8240,7 @@
           <a:noFill/>
         </p:spPr>
         <p:txBody>
-          <a:bodyPr wrap="square" anchor="t" lIns="0" rIns="0" tIns="0" bIns="0">
+          <a:bodyPr wrap="square" lIns="0" tIns="0" rIns="0" bIns="0" anchor="t">
             <a:spAutoFit/>
           </a:bodyPr>
           <a:lstStyle/>
@@ -8206,7 +8282,7 @@
           <a:noFill/>
         </p:spPr>
         <p:txBody>
-          <a:bodyPr wrap="square" anchor="t" lIns="0" rIns="0" tIns="0" bIns="0">
+          <a:bodyPr wrap="square" lIns="0" tIns="0" rIns="0" bIns="0" anchor="t">
             <a:spAutoFit/>
           </a:bodyPr>
           <a:lstStyle/>
@@ -8274,6 +8350,7 @@
           <a:lstStyle/>
           <a:p>
             <a:pPr algn="ctr"/>
+            <a:endParaRPr/>
           </a:p>
         </p:txBody>
       </p:sp>
@@ -8294,7 +8371,7 @@
           <a:noFill/>
         </p:spPr>
         <p:txBody>
-          <a:bodyPr wrap="square" anchor="t" lIns="0" rIns="0" tIns="0" bIns="0">
+          <a:bodyPr wrap="square" lIns="0" tIns="0" rIns="0" bIns="0" anchor="t">
             <a:spAutoFit/>
           </a:bodyPr>
           <a:lstStyle/>
@@ -8336,7 +8413,7 @@
           <a:noFill/>
         </p:spPr>
         <p:txBody>
-          <a:bodyPr wrap="square" anchor="t" lIns="0" rIns="0" tIns="0" bIns="0">
+          <a:bodyPr wrap="square" lIns="0" tIns="0" rIns="0" bIns="0" anchor="t">
             <a:spAutoFit/>
           </a:bodyPr>
           <a:lstStyle/>
@@ -8404,6 +8481,7 @@
           <a:lstStyle/>
           <a:p>
             <a:pPr algn="ctr"/>
+            <a:endParaRPr/>
           </a:p>
         </p:txBody>
       </p:sp>
@@ -8424,7 +8502,7 @@
           <a:noFill/>
         </p:spPr>
         <p:txBody>
-          <a:bodyPr wrap="square" anchor="t" lIns="0" rIns="0" tIns="0" bIns="0">
+          <a:bodyPr wrap="square" lIns="0" tIns="0" rIns="0" bIns="0" anchor="t">
             <a:spAutoFit/>
           </a:bodyPr>
           <a:lstStyle/>
@@ -8466,7 +8544,7 @@
           <a:noFill/>
         </p:spPr>
         <p:txBody>
-          <a:bodyPr wrap="square" anchor="t" lIns="0" rIns="0" tIns="0" bIns="0">
+          <a:bodyPr wrap="square" lIns="0" tIns="0" rIns="0" bIns="0" anchor="t">
             <a:spAutoFit/>
           </a:bodyPr>
           <a:lstStyle/>
@@ -8508,7 +8586,7 @@
           <a:noFill/>
         </p:spPr>
         <p:txBody>
-          <a:bodyPr wrap="square" anchor="t" lIns="0" rIns="0" tIns="0" bIns="0">
+          <a:bodyPr wrap="square" lIns="0" tIns="0" rIns="0" bIns="0" anchor="t">
             <a:spAutoFit/>
           </a:bodyPr>
           <a:lstStyle/>
@@ -8574,6 +8652,7 @@
           <a:lstStyle/>
           <a:p>
             <a:pPr algn="ctr"/>
+            <a:endParaRPr/>
           </a:p>
         </p:txBody>
       </p:sp>
@@ -8594,7 +8673,7 @@
           <a:noFill/>
         </p:spPr>
         <p:txBody>
-          <a:bodyPr wrap="square" anchor="t" lIns="0" rIns="0" tIns="0" bIns="0">
+          <a:bodyPr wrap="square" lIns="0" tIns="0" rIns="0" bIns="0" anchor="t">
             <a:spAutoFit/>
           </a:bodyPr>
           <a:lstStyle/>
@@ -8636,7 +8715,7 @@
           <a:noFill/>
         </p:spPr>
         <p:txBody>
-          <a:bodyPr wrap="square" anchor="t" lIns="0" rIns="0" tIns="0" bIns="0">
+          <a:bodyPr wrap="square" lIns="0" tIns="0" rIns="0" bIns="0" anchor="t">
             <a:spAutoFit/>
           </a:bodyPr>
           <a:lstStyle/>
@@ -8702,6 +8781,7 @@
           <a:lstStyle/>
           <a:p>
             <a:pPr algn="ctr"/>
+            <a:endParaRPr/>
           </a:p>
         </p:txBody>
       </p:sp>
@@ -8722,7 +8802,7 @@
           <a:noFill/>
         </p:spPr>
         <p:txBody>
-          <a:bodyPr wrap="square" anchor="t" lIns="0" rIns="0" tIns="0" bIns="0">
+          <a:bodyPr wrap="square" lIns="0" tIns="0" rIns="0" bIns="0" anchor="t">
             <a:spAutoFit/>
           </a:bodyPr>
           <a:lstStyle/>
@@ -8764,7 +8844,7 @@
           <a:noFill/>
         </p:spPr>
         <p:txBody>
-          <a:bodyPr wrap="square" anchor="t" lIns="0" rIns="0" tIns="0" bIns="0">
+          <a:bodyPr wrap="square" lIns="0" tIns="0" rIns="0" bIns="0" anchor="t">
             <a:spAutoFit/>
           </a:bodyPr>
           <a:lstStyle/>
@@ -8830,6 +8910,7 @@
           <a:lstStyle/>
           <a:p>
             <a:pPr algn="ctr"/>
+            <a:endParaRPr/>
           </a:p>
         </p:txBody>
       </p:sp>
@@ -8850,7 +8931,7 @@
           <a:noFill/>
         </p:spPr>
         <p:txBody>
-          <a:bodyPr wrap="square" anchor="t" lIns="0" rIns="0" tIns="0" bIns="0">
+          <a:bodyPr wrap="square" lIns="0" tIns="0" rIns="0" bIns="0" anchor="t">
             <a:spAutoFit/>
           </a:bodyPr>
           <a:lstStyle/>
@@ -8892,7 +8973,7 @@
           <a:noFill/>
         </p:spPr>
         <p:txBody>
-          <a:bodyPr wrap="square" anchor="t" lIns="0" rIns="0" tIns="0" bIns="0">
+          <a:bodyPr wrap="square" lIns="0" tIns="0" rIns="0" bIns="0" anchor="t">
             <a:spAutoFit/>
           </a:bodyPr>
           <a:lstStyle/>
@@ -8958,6 +9039,7 @@
           <a:lstStyle/>
           <a:p>
             <a:pPr algn="ctr"/>
+            <a:endParaRPr/>
           </a:p>
         </p:txBody>
       </p:sp>
@@ -8978,7 +9060,7 @@
           <a:noFill/>
         </p:spPr>
         <p:txBody>
-          <a:bodyPr wrap="square" anchor="t" lIns="0" rIns="0" tIns="0" bIns="0">
+          <a:bodyPr wrap="square" lIns="0" tIns="0" rIns="0" bIns="0" anchor="t">
             <a:spAutoFit/>
           </a:bodyPr>
           <a:lstStyle/>
@@ -9020,7 +9102,7 @@
           <a:noFill/>
         </p:spPr>
         <p:txBody>
-          <a:bodyPr wrap="square" anchor="t" lIns="0" rIns="0" tIns="0" bIns="0">
+          <a:bodyPr wrap="square" lIns="0" tIns="0" rIns="0" bIns="0" anchor="t">
             <a:spAutoFit/>
           </a:bodyPr>
           <a:lstStyle/>
@@ -9086,6 +9168,7 @@
           <a:lstStyle/>
           <a:p>
             <a:pPr algn="ctr"/>
+            <a:endParaRPr/>
           </a:p>
         </p:txBody>
       </p:sp>
@@ -9106,7 +9189,7 @@
           <a:noFill/>
         </p:spPr>
         <p:txBody>
-          <a:bodyPr wrap="square" anchor="t" lIns="0" rIns="0" tIns="0" bIns="0">
+          <a:bodyPr wrap="square" lIns="0" tIns="0" rIns="0" bIns="0" anchor="t">
             <a:spAutoFit/>
           </a:bodyPr>
           <a:lstStyle/>
@@ -9140,7 +9223,7 @@
 </file>
 
 <file path=ppt/slides/slide6.xml><?xml version="1.0" encoding="utf-8"?>
-<p:sld xmlns:a="http://schemas.openxmlformats.org/drawingml/2006/main" xmlns:p="http://schemas.openxmlformats.org/presentationml/2006/main" xmlns:r="http://schemas.openxmlformats.org/officeDocument/2006/relationships">
+<p:sld xmlns:a="http://schemas.openxmlformats.org/drawingml/2006/main" xmlns:r="http://schemas.openxmlformats.org/officeDocument/2006/relationships" xmlns:p="http://schemas.openxmlformats.org/presentationml/2006/main">
   <p:cSld>
     <p:bg>
       <p:bgPr>
@@ -9156,7 +9239,14 @@
         <p:cNvGrpSpPr/>
         <p:nvPr/>
       </p:nvGrpSpPr>
-      <p:grpSpPr/>
+      <p:grpSpPr>
+        <a:xfrm>
+          <a:off x="0" y="0"/>
+          <a:ext cx="0" cy="0"/>
+          <a:chOff x="0" y="0"/>
+          <a:chExt cx="0" cy="0"/>
+        </a:xfrm>
+      </p:grpSpPr>
       <p:sp>
         <p:nvSpPr>
           <p:cNvPr id="2" name="Rectangle 1"/>
@@ -9198,6 +9288,7 @@
           <a:lstStyle/>
           <a:p>
             <a:pPr algn="ctr"/>
+            <a:endParaRPr/>
           </a:p>
         </p:txBody>
       </p:sp>
@@ -9218,7 +9309,7 @@
           <a:noFill/>
         </p:spPr>
         <p:txBody>
-          <a:bodyPr wrap="square" anchor="t" lIns="0" rIns="0" tIns="0" bIns="0">
+          <a:bodyPr wrap="square" lIns="0" tIns="0" rIns="0" bIns="0" anchor="t">
             <a:spAutoFit/>
           </a:bodyPr>
           <a:lstStyle/>
@@ -9260,7 +9351,7 @@
           <a:noFill/>
         </p:spPr>
         <p:txBody>
-          <a:bodyPr wrap="square" anchor="t" lIns="0" rIns="0" tIns="0" bIns="0">
+          <a:bodyPr wrap="square" lIns="0" tIns="0" rIns="0" bIns="0" anchor="t">
             <a:spAutoFit/>
           </a:bodyPr>
           <a:lstStyle/>
@@ -9326,6 +9417,7 @@
           <a:lstStyle/>
           <a:p>
             <a:pPr algn="ctr"/>
+            <a:endParaRPr/>
           </a:p>
         </p:txBody>
       </p:sp>
@@ -9346,7 +9438,7 @@
           <a:noFill/>
         </p:spPr>
         <p:txBody>
-          <a:bodyPr wrap="square" anchor="t" lIns="0" rIns="0" tIns="0" bIns="0">
+          <a:bodyPr wrap="square" lIns="0" tIns="0" rIns="0" bIns="0" anchor="t">
             <a:spAutoFit/>
           </a:bodyPr>
           <a:lstStyle/>
@@ -9388,7 +9480,7 @@
           <a:noFill/>
         </p:spPr>
         <p:txBody>
-          <a:bodyPr wrap="square" anchor="t" lIns="0" rIns="0" tIns="0" bIns="0">
+          <a:bodyPr wrap="square" lIns="0" tIns="0" rIns="0" bIns="0" anchor="t">
             <a:spAutoFit/>
           </a:bodyPr>
           <a:lstStyle/>
@@ -9454,7 +9546,7 @@
           <a:noFill/>
         </p:spPr>
         <p:txBody>
-          <a:bodyPr wrap="square" lIns="0" rIns="0" tIns="0" bIns="0">
+          <a:bodyPr wrap="square" lIns="0" tIns="0" rIns="0" bIns="0">
             <a:spAutoFit/>
           </a:bodyPr>
           <a:lstStyle/>
@@ -9545,7 +9637,7 @@
 </file>
 
 <file path=ppt/slides/slide7.xml><?xml version="1.0" encoding="utf-8"?>
-<p:sld xmlns:a="http://schemas.openxmlformats.org/drawingml/2006/main" xmlns:p="http://schemas.openxmlformats.org/presentationml/2006/main" xmlns:r="http://schemas.openxmlformats.org/officeDocument/2006/relationships">
+<p:sld xmlns:a="http://schemas.openxmlformats.org/drawingml/2006/main" xmlns:r="http://schemas.openxmlformats.org/officeDocument/2006/relationships" xmlns:p="http://schemas.openxmlformats.org/presentationml/2006/main">
   <p:cSld>
     <p:bg>
       <p:bgPr>
@@ -9561,7 +9653,14 @@
         <p:cNvGrpSpPr/>
         <p:nvPr/>
       </p:nvGrpSpPr>
-      <p:grpSpPr/>
+      <p:grpSpPr>
+        <a:xfrm>
+          <a:off x="0" y="0"/>
+          <a:ext cx="0" cy="0"/>
+          <a:chOff x="0" y="0"/>
+          <a:chExt cx="0" cy="0"/>
+        </a:xfrm>
+      </p:grpSpPr>
       <p:sp>
         <p:nvSpPr>
           <p:cNvPr id="2" name="Rectangle 1"/>
@@ -9603,6 +9702,7 @@
           <a:lstStyle/>
           <a:p>
             <a:pPr algn="ctr"/>
+            <a:endParaRPr/>
           </a:p>
         </p:txBody>
       </p:sp>
@@ -9623,7 +9723,7 @@
           <a:noFill/>
         </p:spPr>
         <p:txBody>
-          <a:bodyPr wrap="square" anchor="t" lIns="0" rIns="0" tIns="0" bIns="0">
+          <a:bodyPr wrap="square" lIns="0" tIns="0" rIns="0" bIns="0" anchor="t">
             <a:spAutoFit/>
           </a:bodyPr>
           <a:lstStyle/>
@@ -9665,7 +9765,7 @@
           <a:noFill/>
         </p:spPr>
         <p:txBody>
-          <a:bodyPr wrap="square" anchor="t" lIns="0" rIns="0" tIns="0" bIns="0">
+          <a:bodyPr wrap="square" lIns="0" tIns="0" rIns="0" bIns="0" anchor="t">
             <a:spAutoFit/>
           </a:bodyPr>
           <a:lstStyle/>
@@ -9731,6 +9831,7 @@
           <a:lstStyle/>
           <a:p>
             <a:pPr algn="ctr"/>
+            <a:endParaRPr/>
           </a:p>
         </p:txBody>
       </p:sp>
@@ -9751,7 +9852,7 @@
           <a:noFill/>
         </p:spPr>
         <p:txBody>
-          <a:bodyPr wrap="square" anchor="t" lIns="0" rIns="0" tIns="0" bIns="0">
+          <a:bodyPr wrap="square" lIns="0" tIns="0" rIns="0" bIns="0" anchor="t">
             <a:spAutoFit/>
           </a:bodyPr>
           <a:lstStyle/>
@@ -9793,7 +9894,7 @@
           <a:noFill/>
         </p:spPr>
         <p:txBody>
-          <a:bodyPr wrap="square" anchor="t" lIns="0" rIns="0" tIns="0" bIns="0">
+          <a:bodyPr wrap="square" lIns="0" tIns="0" rIns="0" bIns="0" anchor="t">
             <a:spAutoFit/>
           </a:bodyPr>
           <a:lstStyle/>
@@ -9835,7 +9936,7 @@
           <a:noFill/>
         </p:spPr>
         <p:txBody>
-          <a:bodyPr wrap="square" lIns="0" rIns="0" tIns="0" bIns="0">
+          <a:bodyPr wrap="square" lIns="0" tIns="0" rIns="0" bIns="0">
             <a:spAutoFit/>
           </a:bodyPr>
           <a:lstStyle/>
@@ -9941,6 +10042,7 @@
           <a:lstStyle/>
           <a:p>
             <a:pPr algn="ctr"/>
+            <a:endParaRPr/>
           </a:p>
         </p:txBody>
       </p:sp>
@@ -9961,7 +10063,7 @@
           <a:noFill/>
         </p:spPr>
         <p:txBody>
-          <a:bodyPr wrap="square" anchor="t" lIns="0" rIns="0" tIns="0" bIns="0">
+          <a:bodyPr wrap="square" lIns="0" tIns="0" rIns="0" bIns="0" anchor="t">
             <a:spAutoFit/>
           </a:bodyPr>
           <a:lstStyle/>
@@ -10003,7 +10105,7 @@
           <a:noFill/>
         </p:spPr>
         <p:txBody>
-          <a:bodyPr wrap="square" anchor="t" lIns="0" rIns="0" tIns="0" bIns="0">
+          <a:bodyPr wrap="square" lIns="0" tIns="0" rIns="0" bIns="0" anchor="t">
             <a:spAutoFit/>
           </a:bodyPr>
           <a:lstStyle/>
@@ -10035,15 +10137,12 @@
                 <a:spcPts val="0"/>
               </a:spcAft>
             </a:pPr>
-            <a:r>
-              <a:rPr sz="1400" b="0" i="0">
-                <a:solidFill>
-                  <a:srgbClr val="52514E"/>
-                </a:solidFill>
-                <a:latin typeface="Calibri"/>
-              </a:rPr>
-              <a:t/>
-            </a:r>
+            <a:endParaRPr sz="1400" b="0" i="0">
+              <a:solidFill>
+                <a:srgbClr val="52514E"/>
+              </a:solidFill>
+              <a:latin typeface="Calibri"/>
+            </a:endParaRPr>
           </a:p>
           <a:p>
             <a:pPr algn="l">
@@ -10083,7 +10182,7 @@
           <a:noFill/>
         </p:spPr>
         <p:txBody>
-          <a:bodyPr wrap="square" anchor="t" lIns="0" rIns="0" tIns="0" bIns="0">
+          <a:bodyPr wrap="square" lIns="0" tIns="0" rIns="0" bIns="0" anchor="t">
             <a:spAutoFit/>
           </a:bodyPr>
           <a:lstStyle/>
@@ -10117,7 +10216,7 @@
 </file>
 
 <file path=ppt/slides/slide8.xml><?xml version="1.0" encoding="utf-8"?>
-<p:sld xmlns:a="http://schemas.openxmlformats.org/drawingml/2006/main" xmlns:p="http://schemas.openxmlformats.org/presentationml/2006/main" xmlns:r="http://schemas.openxmlformats.org/officeDocument/2006/relationships">
+<p:sld xmlns:a="http://schemas.openxmlformats.org/drawingml/2006/main" xmlns:r="http://schemas.openxmlformats.org/officeDocument/2006/relationships" xmlns:p="http://schemas.openxmlformats.org/presentationml/2006/main">
   <p:cSld>
     <p:bg>
       <p:bgPr>
@@ -10133,7 +10232,14 @@
         <p:cNvGrpSpPr/>
         <p:nvPr/>
       </p:nvGrpSpPr>
-      <p:grpSpPr/>
+      <p:grpSpPr>
+        <a:xfrm>
+          <a:off x="0" y="0"/>
+          <a:ext cx="0" cy="0"/>
+          <a:chOff x="0" y="0"/>
+          <a:chExt cx="0" cy="0"/>
+        </a:xfrm>
+      </p:grpSpPr>
       <p:sp>
         <p:nvSpPr>
           <p:cNvPr id="2" name="Rectangle 1"/>
@@ -10175,6 +10281,7 @@
           <a:lstStyle/>
           <a:p>
             <a:pPr algn="ctr"/>
+            <a:endParaRPr/>
           </a:p>
         </p:txBody>
       </p:sp>
@@ -10195,7 +10302,7 @@
           <a:noFill/>
         </p:spPr>
         <p:txBody>
-          <a:bodyPr wrap="square" anchor="t" lIns="0" rIns="0" tIns="0" bIns="0">
+          <a:bodyPr wrap="square" lIns="0" tIns="0" rIns="0" bIns="0" anchor="t">
             <a:spAutoFit/>
           </a:bodyPr>
           <a:lstStyle/>
@@ -10237,7 +10344,7 @@
           <a:noFill/>
         </p:spPr>
         <p:txBody>
-          <a:bodyPr wrap="square" anchor="t" lIns="0" rIns="0" tIns="0" bIns="0">
+          <a:bodyPr wrap="square" lIns="0" tIns="0" rIns="0" bIns="0" anchor="t">
             <a:spAutoFit/>
           </a:bodyPr>
           <a:lstStyle/>
@@ -10303,6 +10410,7 @@
           <a:lstStyle/>
           <a:p>
             <a:pPr algn="ctr"/>
+            <a:endParaRPr/>
           </a:p>
         </p:txBody>
       </p:sp>
@@ -10323,7 +10431,7 @@
           <a:noFill/>
         </p:spPr>
         <p:txBody>
-          <a:bodyPr wrap="square" anchor="t" lIns="0" rIns="0" tIns="0" bIns="0">
+          <a:bodyPr wrap="square" lIns="0" tIns="0" rIns="0" bIns="0" anchor="t">
             <a:spAutoFit/>
           </a:bodyPr>
           <a:lstStyle/>
@@ -10365,7 +10473,7 @@
           <a:noFill/>
         </p:spPr>
         <p:txBody>
-          <a:bodyPr wrap="square" anchor="t" lIns="0" rIns="0" tIns="0" bIns="0">
+          <a:bodyPr wrap="square" lIns="0" tIns="0" rIns="0" bIns="0" anchor="t">
             <a:spAutoFit/>
           </a:bodyPr>
           <a:lstStyle/>
@@ -10455,7 +10563,7 @@
           <a:noFill/>
         </p:spPr>
         <p:txBody>
-          <a:bodyPr wrap="square" lIns="0" rIns="0" tIns="0" bIns="0">
+          <a:bodyPr wrap="square" lIns="0" tIns="0" rIns="0" bIns="0">
             <a:spAutoFit/>
           </a:bodyPr>
           <a:lstStyle/>
@@ -10516,7 +10624,7 @@
           <a:noFill/>
         </p:spPr>
         <p:txBody>
-          <a:bodyPr wrap="square" anchor="t" lIns="0" rIns="0" tIns="0" bIns="0">
+          <a:bodyPr wrap="square" lIns="0" tIns="0" rIns="0" bIns="0" anchor="t">
             <a:spAutoFit/>
           </a:bodyPr>
           <a:lstStyle/>
@@ -10550,7 +10658,7 @@
 </file>
 
 <file path=ppt/slides/slide9.xml><?xml version="1.0" encoding="utf-8"?>
-<p:sld xmlns:a="http://schemas.openxmlformats.org/drawingml/2006/main" xmlns:p="http://schemas.openxmlformats.org/presentationml/2006/main" xmlns:r="http://schemas.openxmlformats.org/officeDocument/2006/relationships">
+<p:sld xmlns:a="http://schemas.openxmlformats.org/drawingml/2006/main" xmlns:r="http://schemas.openxmlformats.org/officeDocument/2006/relationships" xmlns:p="http://schemas.openxmlformats.org/presentationml/2006/main">
   <p:cSld>
     <p:bg>
       <p:bgPr>
@@ -10566,7 +10674,14 @@
         <p:cNvGrpSpPr/>
         <p:nvPr/>
       </p:nvGrpSpPr>
-      <p:grpSpPr/>
+      <p:grpSpPr>
+        <a:xfrm>
+          <a:off x="0" y="0"/>
+          <a:ext cx="0" cy="0"/>
+          <a:chOff x="0" y="0"/>
+          <a:chExt cx="0" cy="0"/>
+        </a:xfrm>
+      </p:grpSpPr>
       <p:sp>
         <p:nvSpPr>
           <p:cNvPr id="2" name="Rectangle 1"/>
@@ -10608,6 +10723,7 @@
           <a:lstStyle/>
           <a:p>
             <a:pPr algn="ctr"/>
+            <a:endParaRPr/>
           </a:p>
         </p:txBody>
       </p:sp>
@@ -10628,7 +10744,7 @@
           <a:noFill/>
         </p:spPr>
         <p:txBody>
-          <a:bodyPr wrap="square" anchor="t" lIns="0" rIns="0" tIns="0" bIns="0">
+          <a:bodyPr wrap="square" lIns="0" tIns="0" rIns="0" bIns="0" anchor="t">
             <a:spAutoFit/>
           </a:bodyPr>
           <a:lstStyle/>
@@ -10670,7 +10786,7 @@
           <a:noFill/>
         </p:spPr>
         <p:txBody>
-          <a:bodyPr wrap="square" anchor="t" lIns="0" rIns="0" tIns="0" bIns="0">
+          <a:bodyPr wrap="square" lIns="0" tIns="0" rIns="0" bIns="0" anchor="t">
             <a:spAutoFit/>
           </a:bodyPr>
           <a:lstStyle/>
@@ -10736,6 +10852,7 @@
           <a:lstStyle/>
           <a:p>
             <a:pPr algn="ctr"/>
+            <a:endParaRPr/>
           </a:p>
         </p:txBody>
       </p:sp>
@@ -10756,7 +10873,7 @@
           <a:noFill/>
         </p:spPr>
         <p:txBody>
-          <a:bodyPr wrap="square" anchor="t" lIns="0" rIns="0" tIns="0" bIns="0">
+          <a:bodyPr wrap="square" lIns="0" tIns="0" rIns="0" bIns="0" anchor="t">
             <a:spAutoFit/>
           </a:bodyPr>
           <a:lstStyle/>
@@ -10798,7 +10915,7 @@
           <a:noFill/>
         </p:spPr>
         <p:txBody>
-          <a:bodyPr wrap="square" anchor="t" lIns="0" rIns="0" tIns="0" bIns="0">
+          <a:bodyPr wrap="square" lIns="0" tIns="0" rIns="0" bIns="0" anchor="t">
             <a:spAutoFit/>
           </a:bodyPr>
           <a:lstStyle/>
@@ -10864,6 +10981,7 @@
           <a:lstStyle/>
           <a:p>
             <a:pPr algn="ctr"/>
+            <a:endParaRPr/>
           </a:p>
         </p:txBody>
       </p:sp>
@@ -10884,7 +11002,7 @@
           <a:noFill/>
         </p:spPr>
         <p:txBody>
-          <a:bodyPr wrap="square" anchor="t" lIns="0" rIns="0" tIns="0" bIns="0">
+          <a:bodyPr wrap="square" lIns="0" tIns="0" rIns="0" bIns="0" anchor="t">
             <a:spAutoFit/>
           </a:bodyPr>
           <a:lstStyle/>
@@ -10926,7 +11044,7 @@
           <a:noFill/>
         </p:spPr>
         <p:txBody>
-          <a:bodyPr wrap="square" anchor="t" lIns="0" rIns="0" tIns="0" bIns="0">
+          <a:bodyPr wrap="square" lIns="0" tIns="0" rIns="0" bIns="0" anchor="t">
             <a:spAutoFit/>
           </a:bodyPr>
           <a:lstStyle/>
@@ -10968,7 +11086,7 @@
           <a:noFill/>
         </p:spPr>
         <p:txBody>
-          <a:bodyPr wrap="square" lIns="0" rIns="0" tIns="0" bIns="0">
+          <a:bodyPr wrap="square" lIns="0" tIns="0" rIns="0" bIns="0">
             <a:spAutoFit/>
           </a:bodyPr>
           <a:lstStyle/>
@@ -11053,6 +11171,7 @@
           <a:lstStyle/>
           <a:p>
             <a:pPr algn="ctr"/>
+            <a:endParaRPr/>
           </a:p>
         </p:txBody>
       </p:sp>
@@ -11073,7 +11192,7 @@
           <a:noFill/>
         </p:spPr>
         <p:txBody>
-          <a:bodyPr wrap="square" anchor="t" lIns="0" rIns="0" tIns="0" bIns="0">
+          <a:bodyPr wrap="square" lIns="0" tIns="0" rIns="0" bIns="0" anchor="t">
             <a:spAutoFit/>
           </a:bodyPr>
           <a:lstStyle/>
@@ -11115,7 +11234,7 @@
           <a:noFill/>
         </p:spPr>
         <p:txBody>
-          <a:bodyPr wrap="square" anchor="t" lIns="0" rIns="0" tIns="0" bIns="0">
+          <a:bodyPr wrap="square" lIns="0" tIns="0" rIns="0" bIns="0" anchor="t">
             <a:spAutoFit/>
           </a:bodyPr>
           <a:lstStyle/>
@@ -11157,7 +11276,7 @@
           <a:noFill/>
         </p:spPr>
         <p:txBody>
-          <a:bodyPr wrap="square" lIns="0" rIns="0" tIns="0" bIns="0">
+          <a:bodyPr wrap="square" lIns="0" tIns="0" rIns="0" bIns="0">
             <a:spAutoFit/>
           </a:bodyPr>
           <a:lstStyle/>
@@ -11242,6 +11361,7 @@
           <a:lstStyle/>
           <a:p>
             <a:pPr algn="ctr"/>
+            <a:endParaRPr/>
           </a:p>
         </p:txBody>
       </p:sp>
@@ -11262,7 +11382,7 @@
           <a:noFill/>
         </p:spPr>
         <p:txBody>
-          <a:bodyPr wrap="square" anchor="t" lIns="0" rIns="0" tIns="0" bIns="0">
+          <a:bodyPr wrap="square" lIns="0" tIns="0" rIns="0" bIns="0" anchor="t">
             <a:spAutoFit/>
           </a:bodyPr>
           <a:lstStyle/>
@@ -11304,7 +11424,7 @@
           <a:noFill/>
         </p:spPr>
         <p:txBody>
-          <a:bodyPr wrap="square" anchor="t" lIns="0" rIns="0" tIns="0" bIns="0">
+          <a:bodyPr wrap="square" lIns="0" tIns="0" rIns="0" bIns="0" anchor="t">
             <a:spAutoFit/>
           </a:bodyPr>
           <a:lstStyle/>
@@ -11346,7 +11466,7 @@
           <a:noFill/>
         </p:spPr>
         <p:txBody>
-          <a:bodyPr wrap="square" lIns="0" rIns="0" tIns="0" bIns="0">
+          <a:bodyPr wrap="square" lIns="0" tIns="0" rIns="0" bIns="0">
             <a:spAutoFit/>
           </a:bodyPr>
           <a:lstStyle/>

</xml_diff>

<commit_message>
Rephrase seasonal-value headlines to name each tech's most valuable month
Slide 5 headlines now name a specific month per technology instead of
a vague range: solar's highest capture price is February, while
storage's largest raw arbitrage spread is July (with November called
out as a lower-risk alternative).

Co-Authored-By: Claude Sonnet 5 <noreply@anthropic.com>
</commit_message>
<xml_diff>
--- a/GCV_Solar_Storage_Valuation.pptx
+++ b/GCV_Solar_Storage_Valuation.pptx
@@ -8597,7 +8597,7 @@
                 </a:solidFill>
                 <a:latin typeface="Calibri"/>
               </a:rPr>
-              <a:t>Solar: most valuable May–Sep</a:t>
+              <a:t>Solar: most valuable month — February</a:t>
             </a:r>
           </a:p>
         </p:txBody>
@@ -8639,7 +8639,7 @@
                 </a:solidFill>
                 <a:latin typeface="Calibri"/>
               </a:rPr>
-              <a:t>—  Summer capture price runs 8–17% above the flat average (Jul: $48.89 vs. $41.72) — solar hours line up with A/C-driven peak prices.</a:t>
+              <a:t>—  February has solar's highest capture price ($49.59/MWh) — driven by winter's high overall price level, not solar's own timing.</a:t>
             </a:r>
           </a:p>
           <a:p>
@@ -8658,7 +8658,7 @@
                 </a:solidFill>
                 <a:latin typeface="Calibri"/>
               </a:rPr>
-              <a:t>—  Winter capture price runs below flat average (95–99%) — winter price spikes hit before sunrise / after sunset, which solar misses.</a:t>
+              <a:t>—  Solar's real timing value-add shows up in summer instead: Jul capture beats the flat average by 17% ($48.89 vs. $41.72), since output aligns with A/C-driven peak prices.</a:t>
             </a:r>
           </a:p>
         </p:txBody>
@@ -8700,7 +8700,7 @@
                 </a:solidFill>
                 <a:latin typeface="Calibri"/>
               </a:rPr>
-              <a:t>Storage: most valuable in extreme-weather months</a:t>
+              <a:t>Storage: most valuable month — July</a:t>
             </a:r>
           </a:p>
         </p:txBody>
@@ -8742,7 +8742,7 @@
                 </a:solidFill>
                 <a:latin typeface="Calibri"/>
               </a:rPr>
-              <a:t>—  Jul ($50/MWh avg. daily spread) and Feb ($43/MWh) are far above the $29 annual average — driven by sharp heat-wave / cold-snap price spikes.</a:t>
+              <a:t>—  Jul has the largest avg. daily DA spread ($50/MWh) — the single biggest arbitrage opportunity by raw dollar value, driven by sharp heat-wave price spikes.</a:t>
             </a:r>
           </a:p>
           <a:p>
@@ -8761,7 +8761,7 @@
                 </a:solidFill>
                 <a:latin typeface="Calibri"/>
               </a:rPr>
-              <a:t>—  Shoulder months (Mar–Jun, Aug–Dec) are weakest ($21–30) — mild weather means flatter daily price shapes and less arbitrage opportunity.</a:t>
+              <a:t>—  Nov is a lower-risk alternative: an above-average spread ($30) paired with one of the smallest DA-RT gaps ($8) — large opportunity with little real-time basis risk (highlighted on chart).</a:t>
             </a:r>
           </a:p>
         </p:txBody>

</xml_diff>